<commit_message>
Remove roles and decisions slides from presentation deck
Drop former slides 6 and 8, renumber to an 8-slide managerial flow.

Co-authored-by: BossPrime <matheussilva030499-oss@users.noreply.github.com>
</commit_message>
<xml_diff>
--- a/docs/Apresentacao_Ofensores_Lentidao.pptx
+++ b/docs/Apresentacao_Ofensores_Lentidao.pptx
@@ -13,8 +13,6 @@
     <p:sldId id="261" r:id="rId12"/>
     <p:sldId id="262" r:id="rId13"/>
     <p:sldId id="263" r:id="rId14"/>
-    <p:sldId id="264" r:id="rId15"/>
-    <p:sldId id="265" r:id="rId16"/>
   </p:sldIdLst>
   <p:sldSz cx="12191695" cy="6858000" type="screen4x3"/>
   <p:notesSz cx="6858000" cy="9144000"/>
@@ -3332,217 +3330,6 @@
 </p:sld>
 </file>
 
-<file path=ppt/slides/slide10.xml><?xml version="1.0" encoding="utf-8"?>
-<p:sld xmlns:a="http://schemas.openxmlformats.org/drawingml/2006/main" xmlns:p="http://schemas.openxmlformats.org/presentationml/2006/main" xmlns:r="http://schemas.openxmlformats.org/officeDocument/2006/relationships">
-  <p:cSld>
-    <p:spTree>
-      <p:nvGrpSpPr>
-        <p:cNvPr id="1" name=""/>
-        <p:cNvGrpSpPr/>
-        <p:nvPr/>
-      </p:nvGrpSpPr>
-      <p:grpSpPr/>
-      <p:sp>
-        <p:nvSpPr>
-          <p:cNvPr id="2" name="Rectangle 1"/>
-          <p:cNvSpPr/>
-          <p:nvPr/>
-        </p:nvSpPr>
-        <p:spPr>
-          <a:xfrm>
-            <a:off x="0" y="0"/>
-            <a:ext cx="12191695" cy="6858000"/>
-          </a:xfrm>
-          <a:prstGeom prst="rect">
-            <a:avLst/>
-          </a:prstGeom>
-          <a:solidFill>
-            <a:srgbClr val="0F2C59"/>
-          </a:solidFill>
-          <a:ln>
-            <a:noFill/>
-          </a:ln>
-        </p:spPr>
-        <p:style>
-          <a:lnRef idx="1">
-            <a:schemeClr val="accent1"/>
-          </a:lnRef>
-          <a:fillRef idx="3">
-            <a:schemeClr val="accent1"/>
-          </a:fillRef>
-          <a:effectRef idx="2">
-            <a:schemeClr val="accent1"/>
-          </a:effectRef>
-          <a:fontRef idx="minor">
-            <a:schemeClr val="lt1"/>
-          </a:fontRef>
-        </p:style>
-        <p:txBody>
-          <a:bodyPr rtlCol="0" anchor="ctr"/>
-          <a:lstStyle/>
-          <a:p>
-            <a:pPr algn="ctr"/>
-          </a:p>
-        </p:txBody>
-      </p:sp>
-      <p:sp>
-        <p:nvSpPr>
-          <p:cNvPr id="3" name="Rectangle 2"/>
-          <p:cNvSpPr/>
-          <p:nvPr/>
-        </p:nvSpPr>
-        <p:spPr>
-          <a:xfrm>
-            <a:off x="0" y="5212080"/>
-            <a:ext cx="12191695" cy="1645920"/>
-          </a:xfrm>
-          <a:prstGeom prst="rect">
-            <a:avLst/>
-          </a:prstGeom>
-          <a:solidFill>
-            <a:srgbClr val="1B6B93"/>
-          </a:solidFill>
-          <a:ln>
-            <a:noFill/>
-          </a:ln>
-        </p:spPr>
-        <p:style>
-          <a:lnRef idx="1">
-            <a:schemeClr val="accent1"/>
-          </a:lnRef>
-          <a:fillRef idx="3">
-            <a:schemeClr val="accent1"/>
-          </a:fillRef>
-          <a:effectRef idx="2">
-            <a:schemeClr val="accent1"/>
-          </a:effectRef>
-          <a:fontRef idx="minor">
-            <a:schemeClr val="lt1"/>
-          </a:fontRef>
-        </p:style>
-        <p:txBody>
-          <a:bodyPr rtlCol="0" anchor="ctr"/>
-          <a:lstStyle/>
-          <a:p>
-            <a:pPr algn="ctr"/>
-          </a:p>
-        </p:txBody>
-      </p:sp>
-      <p:sp>
-        <p:nvSpPr>
-          <p:cNvPr id="4" name="TextBox 3"/>
-          <p:cNvSpPr txBox="1"/>
-          <p:nvPr/>
-        </p:nvSpPr>
-        <p:spPr>
-          <a:xfrm>
-            <a:off x="731520" y="1828800"/>
-            <a:ext cx="10698480" cy="1371600"/>
-          </a:xfrm>
-          <a:prstGeom prst="rect">
-            <a:avLst/>
-          </a:prstGeom>
-          <a:noFill/>
-        </p:spPr>
-        <p:txBody>
-          <a:bodyPr wrap="square">
-            <a:spAutoFit/>
-          </a:bodyPr>
-          <a:lstStyle/>
-          <a:p>
-            <a:pPr algn="ctr"/>
-            <a:r>
-              <a:rPr sz="3200" b="1">
-                <a:solidFill>
-                  <a:srgbClr val="FFFFFF"/>
-                </a:solidFill>
-                <a:latin typeface="Calibri"/>
-              </a:rPr>
-              <a:t>Problema de processo
-não se resolve com chamado de TI.</a:t>
-            </a:r>
-          </a:p>
-        </p:txBody>
-      </p:sp>
-      <p:sp>
-        <p:nvSpPr>
-          <p:cNvPr id="5" name="TextBox 4"/>
-          <p:cNvSpPr txBox="1"/>
-          <p:nvPr/>
-        </p:nvSpPr>
-        <p:spPr>
-          <a:xfrm>
-            <a:off x="731520" y="3657600"/>
-            <a:ext cx="10698480" cy="548640"/>
-          </a:xfrm>
-          <a:prstGeom prst="rect">
-            <a:avLst/>
-          </a:prstGeom>
-          <a:noFill/>
-        </p:spPr>
-        <p:txBody>
-          <a:bodyPr wrap="square">
-            <a:spAutoFit/>
-          </a:bodyPr>
-          <a:lstStyle/>
-          <a:p>
-            <a:pPr algn="ctr"/>
-            <a:r>
-              <a:rPr sz="1800" b="0">
-                <a:solidFill>
-                  <a:srgbClr val="9BC9E0"/>
-                </a:solidFill>
-                <a:latin typeface="Calibri"/>
-              </a:rPr>
-              <a:t>Disciplina de processo  ·  Padronização de posto  ·  Dono claro</a:t>
-            </a:r>
-          </a:p>
-        </p:txBody>
-      </p:sp>
-      <p:sp>
-        <p:nvSpPr>
-          <p:cNvPr id="6" name="TextBox 5"/>
-          <p:cNvSpPr txBox="1"/>
-          <p:nvPr/>
-        </p:nvSpPr>
-        <p:spPr>
-          <a:xfrm>
-            <a:off x="731520" y="5669280"/>
-            <a:ext cx="10698480" cy="731520"/>
-          </a:xfrm>
-          <a:prstGeom prst="rect">
-            <a:avLst/>
-          </a:prstGeom>
-          <a:noFill/>
-        </p:spPr>
-        <p:txBody>
-          <a:bodyPr wrap="square">
-            <a:spAutoFit/>
-          </a:bodyPr>
-          <a:lstStyle/>
-          <a:p>
-            <a:pPr algn="ctr"/>
-            <a:r>
-              <a:rPr sz="1600" b="1">
-                <a:solidFill>
-                  <a:srgbClr val="FFFFFF"/>
-                </a:solidFill>
-                <a:latin typeface="Calibri"/>
-              </a:rPr>
-              <a:t>TI capacita (IP RAP + Filebeat + checklist)
-Engenharia e Área Técnica corrigem na origem</a:t>
-            </a:r>
-          </a:p>
-        </p:txBody>
-      </p:sp>
-    </p:spTree>
-  </p:cSld>
-  <p:clrMapOvr>
-    <a:masterClrMapping/>
-  </p:clrMapOvr>
-</p:sld>
-</file>
-
 <file path=ppt/slides/slide2.xml><?xml version="1.0" encoding="utf-8"?>
 <p:sld xmlns:a="http://schemas.openxmlformats.org/drawingml/2006/main" xmlns:p="http://schemas.openxmlformats.org/presentationml/2006/main" xmlns:r="http://schemas.openxmlformats.org/officeDocument/2006/relationships">
   <p:cSld>
@@ -4294,7 +4081,7 @@
                 </a:solidFill>
                 <a:latin typeface="Calibri"/>
               </a:rPr>
-              <a:t>2/10</a:t>
+              <a:t>2/8</a:t>
             </a:r>
           </a:p>
         </p:txBody>
@@ -5727,7 +5514,7 @@
                 </a:solidFill>
                 <a:latin typeface="Calibri"/>
               </a:rPr>
-              <a:t>3/10</a:t>
+              <a:t>3/8</a:t>
             </a:r>
           </a:p>
         </p:txBody>
@@ -6778,7 +6565,7 @@
                 </a:solidFill>
                 <a:latin typeface="Calibri"/>
               </a:rPr>
-              <a:t>4/10</a:t>
+              <a:t>4/8</a:t>
             </a:r>
           </a:p>
         </p:txBody>
@@ -7385,7 +7172,7 @@
                 </a:solidFill>
                 <a:latin typeface="Calibri"/>
               </a:rPr>
-              <a:t>5/10</a:t>
+              <a:t>5/8</a:t>
             </a:r>
           </a:p>
         </p:txBody>
@@ -7567,66 +7354,58 @@
                 </a:solidFill>
                 <a:latin typeface="Calibri"/>
               </a:rPr>
-              <a:t>Papéis e responsabilidades</a:t>
-            </a:r>
-          </a:p>
-        </p:txBody>
-      </p:sp>
-      <p:sp>
-        <p:nvSpPr>
-          <p:cNvPr id="6" name="Rounded Rectangle 5"/>
+              <a:t>Compromisso da TI — Treinamento</a:t>
+            </a:r>
+          </a:p>
+        </p:txBody>
+      </p:sp>
+      <p:sp>
+        <p:nvSpPr>
+          <p:cNvPr id="6" name="TextBox 5"/>
+          <p:cNvSpPr txBox="1"/>
+          <p:nvPr/>
+        </p:nvSpPr>
+        <p:spPr>
+          <a:xfrm>
+            <a:off x="548640" y="1371600"/>
+            <a:ext cx="10972800" cy="457200"/>
+          </a:xfrm>
+          <a:prstGeom prst="rect">
+            <a:avLst/>
+          </a:prstGeom>
+          <a:noFill/>
+        </p:spPr>
+        <p:txBody>
+          <a:bodyPr wrap="square">
+            <a:spAutoFit/>
+          </a:bodyPr>
+          <a:lstStyle/>
+          <a:p>
+            <a:pPr algn="l"/>
+            <a:r>
+              <a:rPr sz="1800" b="0">
+                <a:solidFill>
+                  <a:srgbClr val="4A4A4A"/>
+                </a:solidFill>
+                <a:latin typeface="Calibri"/>
+              </a:rPr>
+              <a:t>A TI não veio só apontar problema. Vamos capacitar Área Técnica e Engenharia.</a:t>
+            </a:r>
+          </a:p>
+        </p:txBody>
+      </p:sp>
+      <p:sp>
+        <p:nvSpPr>
+          <p:cNvPr id="7" name="Rounded Rectangle 6"/>
           <p:cNvSpPr/>
           <p:nvPr/>
         </p:nvSpPr>
         <p:spPr>
           <a:xfrm>
-            <a:off x="548640" y="1828800"/>
-            <a:ext cx="3611880" cy="3657600"/>
+            <a:off x="548640" y="2103120"/>
+            <a:ext cx="3611880" cy="3200400"/>
           </a:xfrm>
           <a:prstGeom prst="roundRect">
-            <a:avLst/>
-          </a:prstGeom>
-          <a:solidFill>
-            <a:srgbClr val="FFFFFF"/>
-          </a:solidFill>
-          <a:ln>
-            <a:noFill/>
-          </a:ln>
-        </p:spPr>
-        <p:style>
-          <a:lnRef idx="1">
-            <a:schemeClr val="accent1"/>
-          </a:lnRef>
-          <a:fillRef idx="3">
-            <a:schemeClr val="accent1"/>
-          </a:fillRef>
-          <a:effectRef idx="2">
-            <a:schemeClr val="accent1"/>
-          </a:effectRef>
-          <a:fontRef idx="minor">
-            <a:schemeClr val="lt1"/>
-          </a:fontRef>
-        </p:style>
-        <p:txBody>
-          <a:bodyPr rtlCol="0" anchor="ctr"/>
-          <a:lstStyle/>
-          <a:p>
-            <a:pPr algn="ctr"/>
-          </a:p>
-        </p:txBody>
-      </p:sp>
-      <p:sp>
-        <p:nvSpPr>
-          <p:cNvPr id="7" name="Rectangle 6"/>
-          <p:cNvSpPr/>
-          <p:nvPr/>
-        </p:nvSpPr>
-        <p:spPr>
-          <a:xfrm>
-            <a:off x="548640" y="1828800"/>
-            <a:ext cx="3611880" cy="1005840"/>
-          </a:xfrm>
-          <a:prstGeom prst="rect">
             <a:avLst/>
           </a:prstGeom>
           <a:solidFill>
@@ -7666,85 +7445,120 @@
         </p:nvSpPr>
         <p:spPr>
           <a:xfrm>
-            <a:off x="731520" y="2103120"/>
-            <a:ext cx="3200400" cy="548640"/>
-          </a:xfrm>
-          <a:prstGeom prst="rect">
-            <a:avLst/>
-          </a:prstGeom>
-          <a:noFill/>
-        </p:spPr>
-        <p:txBody>
-          <a:bodyPr wrap="square">
-            <a:spAutoFit/>
-          </a:bodyPr>
-          <a:lstStyle/>
-          <a:p>
-            <a:pPr algn="ctr"/>
-            <a:r>
-              <a:rPr sz="2200" b="1">
+            <a:off x="822960" y="2377440"/>
+            <a:ext cx="3017520" cy="365760"/>
+          </a:xfrm>
+          <a:prstGeom prst="rect">
+            <a:avLst/>
+          </a:prstGeom>
+          <a:noFill/>
+        </p:spPr>
+        <p:txBody>
+          <a:bodyPr wrap="square">
+            <a:spAutoFit/>
+          </a:bodyPr>
+          <a:lstStyle/>
+          <a:p>
+            <a:pPr algn="l"/>
+            <a:r>
+              <a:rPr sz="1400" b="1">
+                <a:solidFill>
+                  <a:srgbClr val="9BC9E0"/>
+                </a:solidFill>
+                <a:latin typeface="Calibri"/>
+              </a:rPr>
+              <a:t>01</a:t>
+            </a:r>
+          </a:p>
+        </p:txBody>
+      </p:sp>
+      <p:sp>
+        <p:nvSpPr>
+          <p:cNvPr id="9" name="TextBox 8"/>
+          <p:cNvSpPr txBox="1"/>
+          <p:nvPr/>
+        </p:nvSpPr>
+        <p:spPr>
+          <a:xfrm>
+            <a:off x="822960" y="2926080"/>
+            <a:ext cx="3017520" cy="548640"/>
+          </a:xfrm>
+          <a:prstGeom prst="rect">
+            <a:avLst/>
+          </a:prstGeom>
+          <a:noFill/>
+        </p:spPr>
+        <p:txBody>
+          <a:bodyPr wrap="square">
+            <a:spAutoFit/>
+          </a:bodyPr>
+          <a:lstStyle/>
+          <a:p>
+            <a:pPr algn="l"/>
+            <a:r>
+              <a:rPr sz="2600" b="1">
                 <a:solidFill>
                   <a:srgbClr val="FFFFFF"/>
                 </a:solidFill>
                 <a:latin typeface="Calibri"/>
               </a:rPr>
-              <a:t>Engenharia</a:t>
-            </a:r>
-          </a:p>
-        </p:txBody>
-      </p:sp>
-      <p:sp>
-        <p:nvSpPr>
-          <p:cNvPr id="9" name="TextBox 8"/>
-          <p:cNvSpPr txBox="1"/>
-          <p:nvPr/>
-        </p:nvSpPr>
-        <p:spPr>
-          <a:xfrm>
-            <a:off x="822960" y="3200400"/>
-            <a:ext cx="3063240" cy="1828800"/>
-          </a:xfrm>
-          <a:prstGeom prst="rect">
-            <a:avLst/>
-          </a:prstGeom>
-          <a:noFill/>
-        </p:spPr>
-        <p:txBody>
-          <a:bodyPr wrap="square">
-            <a:spAutoFit/>
-          </a:bodyPr>
-          <a:lstStyle/>
-          <a:p>
-            <a:pPr algn="ctr"/>
-            <a:r>
-              <a:rPr sz="1700" b="0">
-                <a:solidFill>
-                  <a:srgbClr val="4A4A4A"/>
-                </a:solidFill>
-                <a:latin typeface="Calibri"/>
-              </a:rPr>
-              <a:t>Roteiro, modelo, postos
-e padronização de processo</a:t>
-            </a:r>
-          </a:p>
-        </p:txBody>
-      </p:sp>
-      <p:sp>
-        <p:nvSpPr>
-          <p:cNvPr id="10" name="Rounded Rectangle 9"/>
+              <a:t>IP em RAP</a:t>
+            </a:r>
+          </a:p>
+        </p:txBody>
+      </p:sp>
+      <p:sp>
+        <p:nvSpPr>
+          <p:cNvPr id="10" name="TextBox 9"/>
+          <p:cNvSpPr txBox="1"/>
+          <p:nvPr/>
+        </p:nvSpPr>
+        <p:spPr>
+          <a:xfrm>
+            <a:off x="822960" y="3749039"/>
+            <a:ext cx="3017520" cy="1097280"/>
+          </a:xfrm>
+          <a:prstGeom prst="rect">
+            <a:avLst/>
+          </a:prstGeom>
+          <a:noFill/>
+        </p:spPr>
+        <p:txBody>
+          <a:bodyPr wrap="square">
+            <a:spAutoFit/>
+          </a:bodyPr>
+          <a:lstStyle/>
+          <a:p>
+            <a:pPr algn="l"/>
+            <a:r>
+              <a:rPr sz="1600" b="0">
+                <a:solidFill>
+                  <a:srgbClr val="D6E3F0"/>
+                </a:solidFill>
+                <a:latin typeface="Calibri"/>
+              </a:rPr>
+              <a:t>Padronização e prevenção
+de IP duplicado</a:t>
+            </a:r>
+          </a:p>
+        </p:txBody>
+      </p:sp>
+      <p:sp>
+        <p:nvSpPr>
+          <p:cNvPr id="11" name="Rounded Rectangle 10"/>
           <p:cNvSpPr/>
           <p:nvPr/>
         </p:nvSpPr>
         <p:spPr>
           <a:xfrm>
-            <a:off x="4389120" y="1828800"/>
-            <a:ext cx="3611880" cy="3657600"/>
+            <a:off x="4389120" y="2103120"/>
+            <a:ext cx="3611880" cy="3200400"/>
           </a:xfrm>
           <a:prstGeom prst="roundRect">
             <a:avLst/>
           </a:prstGeom>
           <a:solidFill>
-            <a:srgbClr val="FFFFFF"/>
+            <a:srgbClr val="0F2C59"/>
           </a:solidFill>
           <a:ln>
             <a:noFill/>
@@ -7774,20 +7588,126 @@
       </p:sp>
       <p:sp>
         <p:nvSpPr>
-          <p:cNvPr id="11" name="Rectangle 10"/>
+          <p:cNvPr id="12" name="TextBox 11"/>
+          <p:cNvSpPr txBox="1"/>
+          <p:nvPr/>
+        </p:nvSpPr>
+        <p:spPr>
+          <a:xfrm>
+            <a:off x="4663440" y="2377440"/>
+            <a:ext cx="3017520" cy="365760"/>
+          </a:xfrm>
+          <a:prstGeom prst="rect">
+            <a:avLst/>
+          </a:prstGeom>
+          <a:noFill/>
+        </p:spPr>
+        <p:txBody>
+          <a:bodyPr wrap="square">
+            <a:spAutoFit/>
+          </a:bodyPr>
+          <a:lstStyle/>
+          <a:p>
+            <a:pPr algn="l"/>
+            <a:r>
+              <a:rPr sz="1400" b="1">
+                <a:solidFill>
+                  <a:srgbClr val="9BC9E0"/>
+                </a:solidFill>
+                <a:latin typeface="Calibri"/>
+              </a:rPr>
+              <a:t>02</a:t>
+            </a:r>
+          </a:p>
+        </p:txBody>
+      </p:sp>
+      <p:sp>
+        <p:nvSpPr>
+          <p:cNvPr id="13" name="TextBox 12"/>
+          <p:cNvSpPr txBox="1"/>
+          <p:nvPr/>
+        </p:nvSpPr>
+        <p:spPr>
+          <a:xfrm>
+            <a:off x="4663440" y="2926080"/>
+            <a:ext cx="3017520" cy="548640"/>
+          </a:xfrm>
+          <a:prstGeom prst="rect">
+            <a:avLst/>
+          </a:prstGeom>
+          <a:noFill/>
+        </p:spPr>
+        <p:txBody>
+          <a:bodyPr wrap="square">
+            <a:spAutoFit/>
+          </a:bodyPr>
+          <a:lstStyle/>
+          <a:p>
+            <a:pPr algn="l"/>
+            <a:r>
+              <a:rPr sz="2600" b="1">
+                <a:solidFill>
+                  <a:srgbClr val="FFFFFF"/>
+                </a:solidFill>
+                <a:latin typeface="Calibri"/>
+              </a:rPr>
+              <a:t>Filebeat</a:t>
+            </a:r>
+          </a:p>
+        </p:txBody>
+      </p:sp>
+      <p:sp>
+        <p:nvSpPr>
+          <p:cNvPr id="14" name="TextBox 13"/>
+          <p:cNvSpPr txBox="1"/>
+          <p:nvPr/>
+        </p:nvSpPr>
+        <p:spPr>
+          <a:xfrm>
+            <a:off x="4663440" y="3749039"/>
+            <a:ext cx="3017520" cy="1097280"/>
+          </a:xfrm>
+          <a:prstGeom prst="rect">
+            <a:avLst/>
+          </a:prstGeom>
+          <a:noFill/>
+        </p:spPr>
+        <p:txBody>
+          <a:bodyPr wrap="square">
+            <a:spAutoFit/>
+          </a:bodyPr>
+          <a:lstStyle/>
+          <a:p>
+            <a:pPr algn="l"/>
+            <a:r>
+              <a:rPr sz="1600" b="0">
+                <a:solidFill>
+                  <a:srgbClr val="D6E3F0"/>
+                </a:solidFill>
+                <a:latin typeface="Calibri"/>
+              </a:rPr>
+              <a:t>Coleta/envio de logs
+e boas práticas</a:t>
+            </a:r>
+          </a:p>
+        </p:txBody>
+      </p:sp>
+      <p:sp>
+        <p:nvSpPr>
+          <p:cNvPr id="15" name="Rounded Rectangle 14"/>
           <p:cNvSpPr/>
           <p:nvPr/>
         </p:nvSpPr>
         <p:spPr>
           <a:xfrm>
-            <a:off x="4389120" y="1828800"/>
-            <a:ext cx="3611880" cy="1005840"/>
-          </a:xfrm>
-          <a:prstGeom prst="rect">
+            <a:off x="8229600" y="2103120"/>
+            <a:ext cx="3611880" cy="3200400"/>
+          </a:xfrm>
+          <a:prstGeom prst="roundRect">
             <a:avLst/>
           </a:prstGeom>
           <a:solidFill>
-            <a:srgbClr val="1B6B93"/>
+            <a:srgbClr val="0F2C59"/>
           </a:solidFill>
           <a:ln>
             <a:noFill/>
@@ -7817,228 +7737,70 @@
       </p:sp>
       <p:sp>
         <p:nvSpPr>
-          <p:cNvPr id="12" name="TextBox 11"/>
-          <p:cNvSpPr txBox="1"/>
-          <p:nvPr/>
-        </p:nvSpPr>
-        <p:spPr>
-          <a:xfrm>
-            <a:off x="4572000" y="2103120"/>
-            <a:ext cx="3200400" cy="548640"/>
-          </a:xfrm>
-          <a:prstGeom prst="rect">
-            <a:avLst/>
-          </a:prstGeom>
-          <a:noFill/>
-        </p:spPr>
-        <p:txBody>
-          <a:bodyPr wrap="square">
-            <a:spAutoFit/>
-          </a:bodyPr>
-          <a:lstStyle/>
-          <a:p>
-            <a:pPr algn="ctr"/>
-            <a:r>
-              <a:rPr sz="2200" b="1">
+          <p:cNvPr id="16" name="TextBox 15"/>
+          <p:cNvSpPr txBox="1"/>
+          <p:nvPr/>
+        </p:nvSpPr>
+        <p:spPr>
+          <a:xfrm>
+            <a:off x="8503920" y="2377440"/>
+            <a:ext cx="3017520" cy="365760"/>
+          </a:xfrm>
+          <a:prstGeom prst="rect">
+            <a:avLst/>
+          </a:prstGeom>
+          <a:noFill/>
+        </p:spPr>
+        <p:txBody>
+          <a:bodyPr wrap="square">
+            <a:spAutoFit/>
+          </a:bodyPr>
+          <a:lstStyle/>
+          <a:p>
+            <a:pPr algn="l"/>
+            <a:r>
+              <a:rPr sz="1400" b="1">
+                <a:solidFill>
+                  <a:srgbClr val="9BC9E0"/>
+                </a:solidFill>
+                <a:latin typeface="Calibri"/>
+              </a:rPr>
+              <a:t>03</a:t>
+            </a:r>
+          </a:p>
+        </p:txBody>
+      </p:sp>
+      <p:sp>
+        <p:nvSpPr>
+          <p:cNvPr id="17" name="TextBox 16"/>
+          <p:cNvSpPr txBox="1"/>
+          <p:nvPr/>
+        </p:nvSpPr>
+        <p:spPr>
+          <a:xfrm>
+            <a:off x="8503920" y="2926080"/>
+            <a:ext cx="3017520" cy="548640"/>
+          </a:xfrm>
+          <a:prstGeom prst="rect">
+            <a:avLst/>
+          </a:prstGeom>
+          <a:noFill/>
+        </p:spPr>
+        <p:txBody>
+          <a:bodyPr wrap="square">
+            <a:spAutoFit/>
+          </a:bodyPr>
+          <a:lstStyle/>
+          <a:p>
+            <a:pPr algn="l"/>
+            <a:r>
+              <a:rPr sz="2600" b="1">
                 <a:solidFill>
                   <a:srgbClr val="FFFFFF"/>
                 </a:solidFill>
                 <a:latin typeface="Calibri"/>
               </a:rPr>
-              <a:t>Área Técnica</a:t>
-            </a:r>
-          </a:p>
-        </p:txBody>
-      </p:sp>
-      <p:sp>
-        <p:nvSpPr>
-          <p:cNvPr id="13" name="TextBox 12"/>
-          <p:cNvSpPr txBox="1"/>
-          <p:nvPr/>
-        </p:nvSpPr>
-        <p:spPr>
-          <a:xfrm>
-            <a:off x="4663440" y="3200400"/>
-            <a:ext cx="3063240" cy="1828800"/>
-          </a:xfrm>
-          <a:prstGeom prst="rect">
-            <a:avLst/>
-          </a:prstGeom>
-          <a:noFill/>
-        </p:spPr>
-        <p:txBody>
-          <a:bodyPr wrap="square">
-            <a:spAutoFit/>
-          </a:bodyPr>
-          <a:lstStyle/>
-          <a:p>
-            <a:pPr algn="ctr"/>
-            <a:r>
-              <a:rPr sz="1700" b="0">
-                <a:solidFill>
-                  <a:srgbClr val="4A4A4A"/>
-                </a:solidFill>
-                <a:latin typeface="Calibri"/>
-              </a:rPr>
-              <a:t>Equipamento, cabo, IP
-e desempenho do posto</a:t>
-            </a:r>
-          </a:p>
-        </p:txBody>
-      </p:sp>
-      <p:sp>
-        <p:nvSpPr>
-          <p:cNvPr id="14" name="Rounded Rectangle 13"/>
-          <p:cNvSpPr/>
-          <p:nvPr/>
-        </p:nvSpPr>
-        <p:spPr>
-          <a:xfrm>
-            <a:off x="8229600" y="1828800"/>
-            <a:ext cx="3611880" cy="3657600"/>
-          </a:xfrm>
-          <a:prstGeom prst="roundRect">
-            <a:avLst/>
-          </a:prstGeom>
-          <a:solidFill>
-            <a:srgbClr val="FFFFFF"/>
-          </a:solidFill>
-          <a:ln>
-            <a:noFill/>
-          </a:ln>
-        </p:spPr>
-        <p:style>
-          <a:lnRef idx="1">
-            <a:schemeClr val="accent1"/>
-          </a:lnRef>
-          <a:fillRef idx="3">
-            <a:schemeClr val="accent1"/>
-          </a:fillRef>
-          <a:effectRef idx="2">
-            <a:schemeClr val="accent1"/>
-          </a:effectRef>
-          <a:fontRef idx="minor">
-            <a:schemeClr val="lt1"/>
-          </a:fontRef>
-        </p:style>
-        <p:txBody>
-          <a:bodyPr rtlCol="0" anchor="ctr"/>
-          <a:lstStyle/>
-          <a:p>
-            <a:pPr algn="ctr"/>
-          </a:p>
-        </p:txBody>
-      </p:sp>
-      <p:sp>
-        <p:nvSpPr>
-          <p:cNvPr id="15" name="Rectangle 14"/>
-          <p:cNvSpPr/>
-          <p:nvPr/>
-        </p:nvSpPr>
-        <p:spPr>
-          <a:xfrm>
-            <a:off x="8229600" y="1828800"/>
-            <a:ext cx="3611880" cy="1005840"/>
-          </a:xfrm>
-          <a:prstGeom prst="rect">
-            <a:avLst/>
-          </a:prstGeom>
-          <a:solidFill>
-            <a:srgbClr val="2A9D8F"/>
-          </a:solidFill>
-          <a:ln>
-            <a:noFill/>
-          </a:ln>
-        </p:spPr>
-        <p:style>
-          <a:lnRef idx="1">
-            <a:schemeClr val="accent1"/>
-          </a:lnRef>
-          <a:fillRef idx="3">
-            <a:schemeClr val="accent1"/>
-          </a:fillRef>
-          <a:effectRef idx="2">
-            <a:schemeClr val="accent1"/>
-          </a:effectRef>
-          <a:fontRef idx="minor">
-            <a:schemeClr val="lt1"/>
-          </a:fontRef>
-        </p:style>
-        <p:txBody>
-          <a:bodyPr rtlCol="0" anchor="ctr"/>
-          <a:lstStyle/>
-          <a:p>
-            <a:pPr algn="ctr"/>
-          </a:p>
-        </p:txBody>
-      </p:sp>
-      <p:sp>
-        <p:nvSpPr>
-          <p:cNvPr id="16" name="TextBox 15"/>
-          <p:cNvSpPr txBox="1"/>
-          <p:nvPr/>
-        </p:nvSpPr>
-        <p:spPr>
-          <a:xfrm>
-            <a:off x="8412480" y="2103120"/>
-            <a:ext cx="3200400" cy="548640"/>
-          </a:xfrm>
-          <a:prstGeom prst="rect">
-            <a:avLst/>
-          </a:prstGeom>
-          <a:noFill/>
-        </p:spPr>
-        <p:txBody>
-          <a:bodyPr wrap="square">
-            <a:spAutoFit/>
-          </a:bodyPr>
-          <a:lstStyle/>
-          <a:p>
-            <a:pPr algn="ctr"/>
-            <a:r>
-              <a:rPr sz="2200" b="1">
-                <a:solidFill>
-                  <a:srgbClr val="FFFFFF"/>
-                </a:solidFill>
-                <a:latin typeface="Calibri"/>
-              </a:rPr>
-              <a:t>TI</a:t>
-            </a:r>
-          </a:p>
-        </p:txBody>
-      </p:sp>
-      <p:sp>
-        <p:nvSpPr>
-          <p:cNvPr id="17" name="TextBox 16"/>
-          <p:cNvSpPr txBox="1"/>
-          <p:nvPr/>
-        </p:nvSpPr>
-        <p:spPr>
-          <a:xfrm>
-            <a:off x="8503920" y="3200400"/>
-            <a:ext cx="3063240" cy="1828800"/>
-          </a:xfrm>
-          <a:prstGeom prst="rect">
-            <a:avLst/>
-          </a:prstGeom>
-          <a:noFill/>
-        </p:spPr>
-        <p:txBody>
-          <a:bodyPr wrap="square">
-            <a:spAutoFit/>
-          </a:bodyPr>
-          <a:lstStyle/>
-          <a:p>
-            <a:pPr algn="ctr"/>
-            <a:r>
-              <a:rPr sz="1700" b="0">
-                <a:solidFill>
-                  <a:srgbClr val="4A4A4A"/>
-                </a:solidFill>
-                <a:latin typeface="Calibri"/>
-              </a:rPr>
-              <a:t>Diagnóstico com evidência,
-rede/sistema e capacitação</a:t>
+              <a:t>Checklist</a:t>
             </a:r>
           </a:p>
         </p:txBody>
@@ -8046,6 +7808,42 @@
       <p:sp>
         <p:nvSpPr>
           <p:cNvPr id="18" name="TextBox 17"/>
+          <p:cNvSpPr txBox="1"/>
+          <p:nvPr/>
+        </p:nvSpPr>
+        <p:spPr>
+          <a:xfrm>
+            <a:off x="8503920" y="3749039"/>
+            <a:ext cx="3017520" cy="1097280"/>
+          </a:xfrm>
+          <a:prstGeom prst="rect">
+            <a:avLst/>
+          </a:prstGeom>
+          <a:noFill/>
+        </p:spPr>
+        <p:txBody>
+          <a:bodyPr wrap="square">
+            <a:spAutoFit/>
+          </a:bodyPr>
+          <a:lstStyle/>
+          <a:p>
+            <a:pPr algn="l"/>
+            <a:r>
+              <a:rPr sz="1600" b="0">
+                <a:solidFill>
+                  <a:srgbClr val="D6E3F0"/>
+                </a:solidFill>
+                <a:latin typeface="Calibri"/>
+              </a:rPr>
+              <a:t>Antes de classificar como
+“falha de TI”</a:t>
+            </a:r>
+          </a:p>
+        </p:txBody>
+      </p:sp>
+      <p:sp>
+        <p:nvSpPr>
+          <p:cNvPr id="19" name="TextBox 18"/>
           <p:cNvSpPr txBox="1"/>
           <p:nvPr/>
         </p:nvSpPr>
@@ -8080,7 +7878,7 @@
       </p:sp>
       <p:sp>
         <p:nvSpPr>
-          <p:cNvPr id="19" name="TextBox 18"/>
+          <p:cNvPr id="20" name="TextBox 19"/>
           <p:cNvSpPr txBox="1"/>
           <p:nvPr/>
         </p:nvSpPr>
@@ -8108,7 +7906,7 @@
                 </a:solidFill>
                 <a:latin typeface="Calibri"/>
               </a:rPr>
-              <a:t>6/10</a:t>
+              <a:t>6/8</a:t>
             </a:r>
           </a:p>
         </p:txBody>
@@ -8290,58 +8088,23 @@
                 </a:solidFill>
                 <a:latin typeface="Calibri"/>
               </a:rPr>
-              <a:t>Compromisso da TI — Treinamento</a:t>
-            </a:r>
-          </a:p>
-        </p:txBody>
-      </p:sp>
-      <p:sp>
-        <p:nvSpPr>
-          <p:cNvPr id="6" name="TextBox 5"/>
-          <p:cNvSpPr txBox="1"/>
-          <p:nvPr/>
-        </p:nvSpPr>
-        <p:spPr>
-          <a:xfrm>
-            <a:off x="548640" y="1371600"/>
-            <a:ext cx="10972800" cy="457200"/>
-          </a:xfrm>
-          <a:prstGeom prst="rect">
-            <a:avLst/>
-          </a:prstGeom>
-          <a:noFill/>
-        </p:spPr>
-        <p:txBody>
-          <a:bodyPr wrap="square">
-            <a:spAutoFit/>
-          </a:bodyPr>
-          <a:lstStyle/>
-          <a:p>
-            <a:pPr algn="l"/>
-            <a:r>
-              <a:rPr sz="1800" b="0">
-                <a:solidFill>
-                  <a:srgbClr val="4A4A4A"/>
-                </a:solidFill>
-                <a:latin typeface="Calibri"/>
-              </a:rPr>
-              <a:t>A TI não veio só apontar problema. Vamos capacitar Área Técnica e Engenharia.</a:t>
-            </a:r>
-          </a:p>
-        </p:txBody>
-      </p:sp>
-      <p:sp>
-        <p:nvSpPr>
-          <p:cNvPr id="7" name="Rounded Rectangle 6"/>
+              <a:t>Plano de ação resumido</a:t>
+            </a:r>
+          </a:p>
+        </p:txBody>
+      </p:sp>
+      <p:sp>
+        <p:nvSpPr>
+          <p:cNvPr id="6" name="Rectangle 5"/>
           <p:cNvSpPr/>
           <p:nvPr/>
         </p:nvSpPr>
         <p:spPr>
           <a:xfrm>
-            <a:off x="548640" y="2103120"/>
-            <a:ext cx="3611880" cy="3200400"/>
-          </a:xfrm>
-          <a:prstGeom prst="roundRect">
+            <a:off x="457200" y="1417320"/>
+            <a:ext cx="11247120" cy="502920"/>
+          </a:xfrm>
+          <a:prstGeom prst="rect">
             <a:avLst/>
           </a:prstGeom>
           <a:solidFill>
@@ -8375,14 +8138,49 @@
       </p:sp>
       <p:sp>
         <p:nvSpPr>
+          <p:cNvPr id="7" name="TextBox 6"/>
+          <p:cNvSpPr txBox="1"/>
+          <p:nvPr/>
+        </p:nvSpPr>
+        <p:spPr>
+          <a:xfrm>
+            <a:off x="640080" y="1508760"/>
+            <a:ext cx="1188720" cy="365760"/>
+          </a:xfrm>
+          <a:prstGeom prst="rect">
+            <a:avLst/>
+          </a:prstGeom>
+          <a:noFill/>
+        </p:spPr>
+        <p:txBody>
+          <a:bodyPr wrap="square">
+            <a:spAutoFit/>
+          </a:bodyPr>
+          <a:lstStyle/>
+          <a:p>
+            <a:pPr algn="l"/>
+            <a:r>
+              <a:rPr sz="1400" b="1">
+                <a:solidFill>
+                  <a:srgbClr val="FFFFFF"/>
+                </a:solidFill>
+                <a:latin typeface="Calibri"/>
+              </a:rPr>
+              <a:t>ID</a:t>
+            </a:r>
+          </a:p>
+        </p:txBody>
+      </p:sp>
+      <p:sp>
+        <p:nvSpPr>
           <p:cNvPr id="8" name="TextBox 7"/>
           <p:cNvSpPr txBox="1"/>
           <p:nvPr/>
         </p:nvSpPr>
         <p:spPr>
           <a:xfrm>
-            <a:off x="822960" y="2377440"/>
-            <a:ext cx="3017520" cy="365760"/>
+            <a:off x="2011680" y="1508760"/>
+            <a:ext cx="5943600" cy="365760"/>
           </a:xfrm>
           <a:prstGeom prst="rect">
             <a:avLst/>
@@ -8399,11 +8197,11 @@
             <a:r>
               <a:rPr sz="1400" b="1">
                 <a:solidFill>
-                  <a:srgbClr val="9BC9E0"/>
-                </a:solidFill>
-                <a:latin typeface="Calibri"/>
-              </a:rPr>
-              <a:t>01</a:t>
+                  <a:srgbClr val="FFFFFF"/>
+                </a:solidFill>
+                <a:latin typeface="Calibri"/>
+              </a:rPr>
+              <a:t>Ação</a:t>
             </a:r>
           </a:p>
         </p:txBody>
@@ -8416,8 +8214,8 @@
         </p:nvSpPr>
         <p:spPr>
           <a:xfrm>
-            <a:off x="822960" y="2926080"/>
-            <a:ext cx="3017520" cy="548640"/>
+            <a:off x="8046720" y="1508760"/>
+            <a:ext cx="3383280" cy="365760"/>
           </a:xfrm>
           <a:prstGeom prst="rect">
             <a:avLst/>
@@ -8432,69 +8230,33 @@
           <a:p>
             <a:pPr algn="l"/>
             <a:r>
-              <a:rPr sz="2600" b="1">
+              <a:rPr sz="1400" b="1">
                 <a:solidFill>
                   <a:srgbClr val="FFFFFF"/>
                 </a:solidFill>
                 <a:latin typeface="Calibri"/>
               </a:rPr>
-              <a:t>IP em RAP</a:t>
-            </a:r>
-          </a:p>
-        </p:txBody>
-      </p:sp>
-      <p:sp>
-        <p:nvSpPr>
-          <p:cNvPr id="10" name="TextBox 9"/>
-          <p:cNvSpPr txBox="1"/>
-          <p:nvPr/>
-        </p:nvSpPr>
-        <p:spPr>
-          <a:xfrm>
-            <a:off x="822960" y="3749039"/>
-            <a:ext cx="3017520" cy="1097280"/>
-          </a:xfrm>
-          <a:prstGeom prst="rect">
-            <a:avLst/>
-          </a:prstGeom>
-          <a:noFill/>
-        </p:spPr>
-        <p:txBody>
-          <a:bodyPr wrap="square">
-            <a:spAutoFit/>
-          </a:bodyPr>
-          <a:lstStyle/>
-          <a:p>
-            <a:pPr algn="l"/>
-            <a:r>
-              <a:rPr sz="1600" b="0">
-                <a:solidFill>
-                  <a:srgbClr val="D6E3F0"/>
-                </a:solidFill>
-                <a:latin typeface="Calibri"/>
-              </a:rPr>
-              <a:t>Padronização e prevenção
-de IP duplicado</a:t>
-            </a:r>
-          </a:p>
-        </p:txBody>
-      </p:sp>
-      <p:sp>
-        <p:nvSpPr>
-          <p:cNvPr id="11" name="Rounded Rectangle 10"/>
+              <a:t>Dono</a:t>
+            </a:r>
+          </a:p>
+        </p:txBody>
+      </p:sp>
+      <p:sp>
+        <p:nvSpPr>
+          <p:cNvPr id="10" name="Rectangle 9"/>
           <p:cNvSpPr/>
           <p:nvPr/>
         </p:nvSpPr>
         <p:spPr>
           <a:xfrm>
-            <a:off x="4389120" y="2103120"/>
-            <a:ext cx="3611880" cy="3200400"/>
-          </a:xfrm>
-          <a:prstGeom prst="roundRect">
+            <a:off x="457200" y="1965960"/>
+            <a:ext cx="11247120" cy="640080"/>
+          </a:xfrm>
+          <a:prstGeom prst="rect">
             <a:avLst/>
           </a:prstGeom>
           <a:solidFill>
-            <a:srgbClr val="0F2C59"/>
+            <a:srgbClr val="FFFFFF"/>
           </a:solidFill>
           <a:ln>
             <a:noFill/>
@@ -8524,14 +8286,49 @@
       </p:sp>
       <p:sp>
         <p:nvSpPr>
+          <p:cNvPr id="11" name="TextBox 10"/>
+          <p:cNvSpPr txBox="1"/>
+          <p:nvPr/>
+        </p:nvSpPr>
+        <p:spPr>
+          <a:xfrm>
+            <a:off x="640080" y="2130552"/>
+            <a:ext cx="1188720" cy="365760"/>
+          </a:xfrm>
+          <a:prstGeom prst="rect">
+            <a:avLst/>
+          </a:prstGeom>
+          <a:noFill/>
+        </p:spPr>
+        <p:txBody>
+          <a:bodyPr wrap="square">
+            <a:spAutoFit/>
+          </a:bodyPr>
+          <a:lstStyle/>
+          <a:p>
+            <a:pPr algn="l"/>
+            <a:r>
+              <a:rPr sz="1400" b="1">
+                <a:solidFill>
+                  <a:srgbClr val="1B6B93"/>
+                </a:solidFill>
+                <a:latin typeface="Calibri"/>
+              </a:rPr>
+              <a:t>PA-01</a:t>
+            </a:r>
+          </a:p>
+        </p:txBody>
+      </p:sp>
+      <p:sp>
+        <p:nvSpPr>
           <p:cNvPr id="12" name="TextBox 11"/>
           <p:cNvSpPr txBox="1"/>
           <p:nvPr/>
         </p:nvSpPr>
         <p:spPr>
           <a:xfrm>
-            <a:off x="4663440" y="2377440"/>
-            <a:ext cx="3017520" cy="365760"/>
+            <a:off x="2011680" y="2130552"/>
+            <a:ext cx="5943600" cy="365760"/>
           </a:xfrm>
           <a:prstGeom prst="rect">
             <a:avLst/>
@@ -8546,13 +8343,13 @@
           <a:p>
             <a:pPr algn="l"/>
             <a:r>
-              <a:rPr sz="1400" b="1">
-                <a:solidFill>
-                  <a:srgbClr val="9BC9E0"/>
-                </a:solidFill>
-                <a:latin typeface="Calibri"/>
-              </a:rPr>
-              <a:t>02</a:t>
+              <a:rPr sz="1400" b="0">
+                <a:solidFill>
+                  <a:srgbClr val="1F1F1F"/>
+                </a:solidFill>
+                <a:latin typeface="Calibri"/>
+              </a:rPr>
+              <a:t>Padronizar/substituir cabos e conectores</a:t>
             </a:r>
           </a:p>
         </p:txBody>
@@ -8565,8 +8362,8 @@
         </p:nvSpPr>
         <p:spPr>
           <a:xfrm>
-            <a:off x="4663440" y="2926080"/>
-            <a:ext cx="3017520" cy="548640"/>
+            <a:off x="8046720" y="2130552"/>
+            <a:ext cx="3383280" cy="365760"/>
           </a:xfrm>
           <a:prstGeom prst="rect">
             <a:avLst/>
@@ -8581,69 +8378,33 @@
           <a:p>
             <a:pPr algn="l"/>
             <a:r>
-              <a:rPr sz="2600" b="1">
-                <a:solidFill>
-                  <a:srgbClr val="FFFFFF"/>
-                </a:solidFill>
-                <a:latin typeface="Calibri"/>
-              </a:rPr>
-              <a:t>Filebeat</a:t>
-            </a:r>
-          </a:p>
-        </p:txBody>
-      </p:sp>
-      <p:sp>
-        <p:nvSpPr>
-          <p:cNvPr id="14" name="TextBox 13"/>
-          <p:cNvSpPr txBox="1"/>
-          <p:nvPr/>
-        </p:nvSpPr>
-        <p:spPr>
-          <a:xfrm>
-            <a:off x="4663440" y="3749039"/>
-            <a:ext cx="3017520" cy="1097280"/>
-          </a:xfrm>
-          <a:prstGeom prst="rect">
-            <a:avLst/>
-          </a:prstGeom>
-          <a:noFill/>
-        </p:spPr>
-        <p:txBody>
-          <a:bodyPr wrap="square">
-            <a:spAutoFit/>
-          </a:bodyPr>
-          <a:lstStyle/>
-          <a:p>
-            <a:pPr algn="l"/>
-            <a:r>
-              <a:rPr sz="1600" b="0">
-                <a:solidFill>
-                  <a:srgbClr val="D6E3F0"/>
-                </a:solidFill>
-                <a:latin typeface="Calibri"/>
-              </a:rPr>
-              <a:t>Coleta/envio de logs
-e boas práticas</a:t>
-            </a:r>
-          </a:p>
-        </p:txBody>
-      </p:sp>
-      <p:sp>
-        <p:nvSpPr>
-          <p:cNvPr id="15" name="Rounded Rectangle 14"/>
+              <a:rPr sz="1300" b="0">
+                <a:solidFill>
+                  <a:srgbClr val="4A4A4A"/>
+                </a:solidFill>
+                <a:latin typeface="Calibri"/>
+              </a:rPr>
+              <a:t>Área Técnica / Engenharia</a:t>
+            </a:r>
+          </a:p>
+        </p:txBody>
+      </p:sp>
+      <p:sp>
+        <p:nvSpPr>
+          <p:cNvPr id="14" name="Rectangle 13"/>
           <p:cNvSpPr/>
           <p:nvPr/>
         </p:nvSpPr>
         <p:spPr>
           <a:xfrm>
-            <a:off x="8229600" y="2103120"/>
-            <a:ext cx="3611880" cy="3200400"/>
-          </a:xfrm>
-          <a:prstGeom prst="roundRect">
+            <a:off x="457200" y="2606039"/>
+            <a:ext cx="11247120" cy="640080"/>
+          </a:xfrm>
+          <a:prstGeom prst="rect">
             <a:avLst/>
           </a:prstGeom>
           <a:solidFill>
-            <a:srgbClr val="0F2C59"/>
+            <a:srgbClr val="E8EEF5"/>
           </a:solidFill>
           <a:ln>
             <a:noFill/>
@@ -8673,14 +8434,49 @@
       </p:sp>
       <p:sp>
         <p:nvSpPr>
+          <p:cNvPr id="15" name="TextBox 14"/>
+          <p:cNvSpPr txBox="1"/>
+          <p:nvPr/>
+        </p:nvSpPr>
+        <p:spPr>
+          <a:xfrm>
+            <a:off x="640080" y="2770631"/>
+            <a:ext cx="1188720" cy="365760"/>
+          </a:xfrm>
+          <a:prstGeom prst="rect">
+            <a:avLst/>
+          </a:prstGeom>
+          <a:noFill/>
+        </p:spPr>
+        <p:txBody>
+          <a:bodyPr wrap="square">
+            <a:spAutoFit/>
+          </a:bodyPr>
+          <a:lstStyle/>
+          <a:p>
+            <a:pPr algn="l"/>
+            <a:r>
+              <a:rPr sz="1400" b="1">
+                <a:solidFill>
+                  <a:srgbClr val="1B6B93"/>
+                </a:solidFill>
+                <a:latin typeface="Calibri"/>
+              </a:rPr>
+              <a:t>PA-02</a:t>
+            </a:r>
+          </a:p>
+        </p:txBody>
+      </p:sp>
+      <p:sp>
+        <p:nvSpPr>
           <p:cNvPr id="16" name="TextBox 15"/>
           <p:cNvSpPr txBox="1"/>
           <p:nvPr/>
         </p:nvSpPr>
         <p:spPr>
           <a:xfrm>
-            <a:off x="8503920" y="2377440"/>
-            <a:ext cx="3017520" cy="365760"/>
+            <a:off x="2011680" y="2770631"/>
+            <a:ext cx="5943600" cy="365760"/>
           </a:xfrm>
           <a:prstGeom prst="rect">
             <a:avLst/>
@@ -8695,27 +8491,140 @@
           <a:p>
             <a:pPr algn="l"/>
             <a:r>
+              <a:rPr sz="1400" b="0">
+                <a:solidFill>
+                  <a:srgbClr val="1F1F1F"/>
+                </a:solidFill>
+                <a:latin typeface="Calibri"/>
+              </a:rPr>
+              <a:t>Eliminar IPs duplicados e oficializar endereçamento</a:t>
+            </a:r>
+          </a:p>
+        </p:txBody>
+      </p:sp>
+      <p:sp>
+        <p:nvSpPr>
+          <p:cNvPr id="17" name="TextBox 16"/>
+          <p:cNvSpPr txBox="1"/>
+          <p:nvPr/>
+        </p:nvSpPr>
+        <p:spPr>
+          <a:xfrm>
+            <a:off x="8046720" y="2770631"/>
+            <a:ext cx="3383280" cy="365760"/>
+          </a:xfrm>
+          <a:prstGeom prst="rect">
+            <a:avLst/>
+          </a:prstGeom>
+          <a:noFill/>
+        </p:spPr>
+        <p:txBody>
+          <a:bodyPr wrap="square">
+            <a:spAutoFit/>
+          </a:bodyPr>
+          <a:lstStyle/>
+          <a:p>
+            <a:pPr algn="l"/>
+            <a:r>
+              <a:rPr sz="1300" b="0">
+                <a:solidFill>
+                  <a:srgbClr val="4A4A4A"/>
+                </a:solidFill>
+                <a:latin typeface="Calibri"/>
+              </a:rPr>
+              <a:t>Área Técnica / Engenharia</a:t>
+            </a:r>
+          </a:p>
+        </p:txBody>
+      </p:sp>
+      <p:sp>
+        <p:nvSpPr>
+          <p:cNvPr id="18" name="Rectangle 17"/>
+          <p:cNvSpPr/>
+          <p:nvPr/>
+        </p:nvSpPr>
+        <p:spPr>
+          <a:xfrm>
+            <a:off x="457200" y="3246120"/>
+            <a:ext cx="11247120" cy="640080"/>
+          </a:xfrm>
+          <a:prstGeom prst="rect">
+            <a:avLst/>
+          </a:prstGeom>
+          <a:solidFill>
+            <a:srgbClr val="FFFFFF"/>
+          </a:solidFill>
+          <a:ln>
+            <a:noFill/>
+          </a:ln>
+        </p:spPr>
+        <p:style>
+          <a:lnRef idx="1">
+            <a:schemeClr val="accent1"/>
+          </a:lnRef>
+          <a:fillRef idx="3">
+            <a:schemeClr val="accent1"/>
+          </a:fillRef>
+          <a:effectRef idx="2">
+            <a:schemeClr val="accent1"/>
+          </a:effectRef>
+          <a:fontRef idx="minor">
+            <a:schemeClr val="lt1"/>
+          </a:fontRef>
+        </p:style>
+        <p:txBody>
+          <a:bodyPr rtlCol="0" anchor="ctr"/>
+          <a:lstStyle/>
+          <a:p>
+            <a:pPr algn="ctr"/>
+          </a:p>
+        </p:txBody>
+      </p:sp>
+      <p:sp>
+        <p:nvSpPr>
+          <p:cNvPr id="19" name="TextBox 18"/>
+          <p:cNvSpPr txBox="1"/>
+          <p:nvPr/>
+        </p:nvSpPr>
+        <p:spPr>
+          <a:xfrm>
+            <a:off x="640080" y="3410712"/>
+            <a:ext cx="1188720" cy="365760"/>
+          </a:xfrm>
+          <a:prstGeom prst="rect">
+            <a:avLst/>
+          </a:prstGeom>
+          <a:noFill/>
+        </p:spPr>
+        <p:txBody>
+          <a:bodyPr wrap="square">
+            <a:spAutoFit/>
+          </a:bodyPr>
+          <a:lstStyle/>
+          <a:p>
+            <a:pPr algn="l"/>
+            <a:r>
               <a:rPr sz="1400" b="1">
                 <a:solidFill>
-                  <a:srgbClr val="9BC9E0"/>
-                </a:solidFill>
-                <a:latin typeface="Calibri"/>
-              </a:rPr>
-              <a:t>03</a:t>
-            </a:r>
-          </a:p>
-        </p:txBody>
-      </p:sp>
-      <p:sp>
-        <p:nvSpPr>
-          <p:cNvPr id="17" name="TextBox 16"/>
-          <p:cNvSpPr txBox="1"/>
-          <p:nvPr/>
-        </p:nvSpPr>
-        <p:spPr>
-          <a:xfrm>
-            <a:off x="8503920" y="2926080"/>
-            <a:ext cx="3017520" cy="548640"/>
+                  <a:srgbClr val="1B6B93"/>
+                </a:solidFill>
+                <a:latin typeface="Calibri"/>
+              </a:rPr>
+              <a:t>PA-03</a:t>
+            </a:r>
+          </a:p>
+        </p:txBody>
+      </p:sp>
+      <p:sp>
+        <p:nvSpPr>
+          <p:cNvPr id="20" name="TextBox 19"/>
+          <p:cNvSpPr txBox="1"/>
+          <p:nvPr/>
+        </p:nvSpPr>
+        <p:spPr>
+          <a:xfrm>
+            <a:off x="2011680" y="3410712"/>
+            <a:ext cx="5943600" cy="365760"/>
           </a:xfrm>
           <a:prstGeom prst="rect">
             <a:avLst/>
@@ -8730,27 +8639,27 @@
           <a:p>
             <a:pPr algn="l"/>
             <a:r>
-              <a:rPr sz="2600" b="1">
-                <a:solidFill>
-                  <a:srgbClr val="FFFFFF"/>
-                </a:solidFill>
-                <a:latin typeface="Calibri"/>
-              </a:rPr>
-              <a:t>Checklist</a:t>
-            </a:r>
-          </a:p>
-        </p:txBody>
-      </p:sp>
-      <p:sp>
-        <p:nvSpPr>
-          <p:cNvPr id="18" name="TextBox 17"/>
-          <p:cNvSpPr txBox="1"/>
-          <p:nvPr/>
-        </p:nvSpPr>
-        <p:spPr>
-          <a:xfrm>
-            <a:off x="8503920" y="3749039"/>
-            <a:ext cx="3017520" cy="1097280"/>
+              <a:rPr sz="1400" b="0">
+                <a:solidFill>
+                  <a:srgbClr val="1F1F1F"/>
+                </a:solidFill>
+                <a:latin typeface="Calibri"/>
+              </a:rPr>
+              <a:t>Controle de liberação de roteiro</a:t>
+            </a:r>
+          </a:p>
+        </p:txBody>
+      </p:sp>
+      <p:sp>
+        <p:nvSpPr>
+          <p:cNvPr id="21" name="TextBox 20"/>
+          <p:cNvSpPr txBox="1"/>
+          <p:nvPr/>
+        </p:nvSpPr>
+        <p:spPr>
+          <a:xfrm>
+            <a:off x="8046720" y="3410712"/>
+            <a:ext cx="3383280" cy="365760"/>
           </a:xfrm>
           <a:prstGeom prst="rect">
             <a:avLst/>
@@ -8765,21 +8674,464 @@
           <a:p>
             <a:pPr algn="l"/>
             <a:r>
-              <a:rPr sz="1600" b="0">
-                <a:solidFill>
-                  <a:srgbClr val="D6E3F0"/>
-                </a:solidFill>
-                <a:latin typeface="Calibri"/>
-              </a:rPr>
-              <a:t>Antes de classificar como
-“falha de TI”</a:t>
-            </a:r>
-          </a:p>
-        </p:txBody>
-      </p:sp>
-      <p:sp>
-        <p:nvSpPr>
-          <p:cNvPr id="19" name="TextBox 18"/>
+              <a:rPr sz="1300" b="0">
+                <a:solidFill>
+                  <a:srgbClr val="4A4A4A"/>
+                </a:solidFill>
+                <a:latin typeface="Calibri"/>
+              </a:rPr>
+              <a:t>Engenharia / Área Técnica</a:t>
+            </a:r>
+          </a:p>
+        </p:txBody>
+      </p:sp>
+      <p:sp>
+        <p:nvSpPr>
+          <p:cNvPr id="22" name="Rectangle 21"/>
+          <p:cNvSpPr/>
+          <p:nvPr/>
+        </p:nvSpPr>
+        <p:spPr>
+          <a:xfrm>
+            <a:off x="457200" y="3886200"/>
+            <a:ext cx="11247120" cy="640080"/>
+          </a:xfrm>
+          <a:prstGeom prst="rect">
+            <a:avLst/>
+          </a:prstGeom>
+          <a:solidFill>
+            <a:srgbClr val="E8EEF5"/>
+          </a:solidFill>
+          <a:ln>
+            <a:noFill/>
+          </a:ln>
+        </p:spPr>
+        <p:style>
+          <a:lnRef idx="1">
+            <a:schemeClr val="accent1"/>
+          </a:lnRef>
+          <a:fillRef idx="3">
+            <a:schemeClr val="accent1"/>
+          </a:fillRef>
+          <a:effectRef idx="2">
+            <a:schemeClr val="accent1"/>
+          </a:effectRef>
+          <a:fontRef idx="minor">
+            <a:schemeClr val="lt1"/>
+          </a:fontRef>
+        </p:style>
+        <p:txBody>
+          <a:bodyPr rtlCol="0" anchor="ctr"/>
+          <a:lstStyle/>
+          <a:p>
+            <a:pPr algn="ctr"/>
+          </a:p>
+        </p:txBody>
+      </p:sp>
+      <p:sp>
+        <p:nvSpPr>
+          <p:cNvPr id="23" name="TextBox 22"/>
+          <p:cNvSpPr txBox="1"/>
+          <p:nvPr/>
+        </p:nvSpPr>
+        <p:spPr>
+          <a:xfrm>
+            <a:off x="640080" y="4050792"/>
+            <a:ext cx="1188720" cy="365760"/>
+          </a:xfrm>
+          <a:prstGeom prst="rect">
+            <a:avLst/>
+          </a:prstGeom>
+          <a:noFill/>
+        </p:spPr>
+        <p:txBody>
+          <a:bodyPr wrap="square">
+            <a:spAutoFit/>
+          </a:bodyPr>
+          <a:lstStyle/>
+          <a:p>
+            <a:pPr algn="l"/>
+            <a:r>
+              <a:rPr sz="1400" b="1">
+                <a:solidFill>
+                  <a:srgbClr val="1B6B93"/>
+                </a:solidFill>
+                <a:latin typeface="Calibri"/>
+              </a:rPr>
+              <a:t>PA-04</a:t>
+            </a:r>
+          </a:p>
+        </p:txBody>
+      </p:sp>
+      <p:sp>
+        <p:nvSpPr>
+          <p:cNvPr id="24" name="TextBox 23"/>
+          <p:cNvSpPr txBox="1"/>
+          <p:nvPr/>
+        </p:nvSpPr>
+        <p:spPr>
+          <a:xfrm>
+            <a:off x="2011680" y="4050792"/>
+            <a:ext cx="5943600" cy="365760"/>
+          </a:xfrm>
+          <a:prstGeom prst="rect">
+            <a:avLst/>
+          </a:prstGeom>
+          <a:noFill/>
+        </p:spPr>
+        <p:txBody>
+          <a:bodyPr wrap="square">
+            <a:spAutoFit/>
+          </a:bodyPr>
+          <a:lstStyle/>
+          <a:p>
+            <a:pPr algn="l"/>
+            <a:r>
+              <a:rPr sz="1400" b="0">
+                <a:solidFill>
+                  <a:srgbClr val="1F1F1F"/>
+                </a:solidFill>
+                <a:latin typeface="Calibri"/>
+              </a:rPr>
+              <a:t>Adequação de RASPs/PCs com baixa performance</a:t>
+            </a:r>
+          </a:p>
+        </p:txBody>
+      </p:sp>
+      <p:sp>
+        <p:nvSpPr>
+          <p:cNvPr id="25" name="TextBox 24"/>
+          <p:cNvSpPr txBox="1"/>
+          <p:nvPr/>
+        </p:nvSpPr>
+        <p:spPr>
+          <a:xfrm>
+            <a:off x="8046720" y="4050792"/>
+            <a:ext cx="3383280" cy="365760"/>
+          </a:xfrm>
+          <a:prstGeom prst="rect">
+            <a:avLst/>
+          </a:prstGeom>
+          <a:noFill/>
+        </p:spPr>
+        <p:txBody>
+          <a:bodyPr wrap="square">
+            <a:spAutoFit/>
+          </a:bodyPr>
+          <a:lstStyle/>
+          <a:p>
+            <a:pPr algn="l"/>
+            <a:r>
+              <a:rPr sz="1300" b="0">
+                <a:solidFill>
+                  <a:srgbClr val="4A4A4A"/>
+                </a:solidFill>
+                <a:latin typeface="Calibri"/>
+              </a:rPr>
+              <a:t>Área Técnica / Engenharia</a:t>
+            </a:r>
+          </a:p>
+        </p:txBody>
+      </p:sp>
+      <p:sp>
+        <p:nvSpPr>
+          <p:cNvPr id="26" name="Rectangle 25"/>
+          <p:cNvSpPr/>
+          <p:nvPr/>
+        </p:nvSpPr>
+        <p:spPr>
+          <a:xfrm>
+            <a:off x="457200" y="4526279"/>
+            <a:ext cx="11247120" cy="640080"/>
+          </a:xfrm>
+          <a:prstGeom prst="rect">
+            <a:avLst/>
+          </a:prstGeom>
+          <a:solidFill>
+            <a:srgbClr val="FFFFFF"/>
+          </a:solidFill>
+          <a:ln>
+            <a:noFill/>
+          </a:ln>
+        </p:spPr>
+        <p:style>
+          <a:lnRef idx="1">
+            <a:schemeClr val="accent1"/>
+          </a:lnRef>
+          <a:fillRef idx="3">
+            <a:schemeClr val="accent1"/>
+          </a:fillRef>
+          <a:effectRef idx="2">
+            <a:schemeClr val="accent1"/>
+          </a:effectRef>
+          <a:fontRef idx="minor">
+            <a:schemeClr val="lt1"/>
+          </a:fontRef>
+        </p:style>
+        <p:txBody>
+          <a:bodyPr rtlCol="0" anchor="ctr"/>
+          <a:lstStyle/>
+          <a:p>
+            <a:pPr algn="ctr"/>
+          </a:p>
+        </p:txBody>
+      </p:sp>
+      <p:sp>
+        <p:nvSpPr>
+          <p:cNvPr id="27" name="TextBox 26"/>
+          <p:cNvSpPr txBox="1"/>
+          <p:nvPr/>
+        </p:nvSpPr>
+        <p:spPr>
+          <a:xfrm>
+            <a:off x="640080" y="4690871"/>
+            <a:ext cx="1188720" cy="365760"/>
+          </a:xfrm>
+          <a:prstGeom prst="rect">
+            <a:avLst/>
+          </a:prstGeom>
+          <a:noFill/>
+        </p:spPr>
+        <p:txBody>
+          <a:bodyPr wrap="square">
+            <a:spAutoFit/>
+          </a:bodyPr>
+          <a:lstStyle/>
+          <a:p>
+            <a:pPr algn="l"/>
+            <a:r>
+              <a:rPr sz="1400" b="1">
+                <a:solidFill>
+                  <a:srgbClr val="1B6B93"/>
+                </a:solidFill>
+                <a:latin typeface="Calibri"/>
+              </a:rPr>
+              <a:t>PA-05</a:t>
+            </a:r>
+          </a:p>
+        </p:txBody>
+      </p:sp>
+      <p:sp>
+        <p:nvSpPr>
+          <p:cNvPr id="28" name="TextBox 27"/>
+          <p:cNvSpPr txBox="1"/>
+          <p:nvPr/>
+        </p:nvSpPr>
+        <p:spPr>
+          <a:xfrm>
+            <a:off x="2011680" y="4690871"/>
+            <a:ext cx="5943600" cy="365760"/>
+          </a:xfrm>
+          <a:prstGeom prst="rect">
+            <a:avLst/>
+          </a:prstGeom>
+          <a:noFill/>
+        </p:spPr>
+        <p:txBody>
+          <a:bodyPr wrap="square">
+            <a:spAutoFit/>
+          </a:bodyPr>
+          <a:lstStyle/>
+          <a:p>
+            <a:pPr algn="l"/>
+            <a:r>
+              <a:rPr sz="1400" b="0">
+                <a:solidFill>
+                  <a:srgbClr val="1F1F1F"/>
+                </a:solidFill>
+                <a:latin typeface="Calibri"/>
+              </a:rPr>
+              <a:t>Padronizar status passou/não passou</a:t>
+            </a:r>
+          </a:p>
+        </p:txBody>
+      </p:sp>
+      <p:sp>
+        <p:nvSpPr>
+          <p:cNvPr id="29" name="TextBox 28"/>
+          <p:cNvSpPr txBox="1"/>
+          <p:nvPr/>
+        </p:nvSpPr>
+        <p:spPr>
+          <a:xfrm>
+            <a:off x="8046720" y="4690871"/>
+            <a:ext cx="3383280" cy="365760"/>
+          </a:xfrm>
+          <a:prstGeom prst="rect">
+            <a:avLst/>
+          </a:prstGeom>
+          <a:noFill/>
+        </p:spPr>
+        <p:txBody>
+          <a:bodyPr wrap="square">
+            <a:spAutoFit/>
+          </a:bodyPr>
+          <a:lstStyle/>
+          <a:p>
+            <a:pPr algn="l"/>
+            <a:r>
+              <a:rPr sz="1300" b="0">
+                <a:solidFill>
+                  <a:srgbClr val="4A4A4A"/>
+                </a:solidFill>
+                <a:latin typeface="Calibri"/>
+              </a:rPr>
+              <a:t>Engenharia / Área Técnica</a:t>
+            </a:r>
+          </a:p>
+        </p:txBody>
+      </p:sp>
+      <p:sp>
+        <p:nvSpPr>
+          <p:cNvPr id="30" name="Rectangle 29"/>
+          <p:cNvSpPr/>
+          <p:nvPr/>
+        </p:nvSpPr>
+        <p:spPr>
+          <a:xfrm>
+            <a:off x="457200" y="5166360"/>
+            <a:ext cx="11247120" cy="640080"/>
+          </a:xfrm>
+          <a:prstGeom prst="rect">
+            <a:avLst/>
+          </a:prstGeom>
+          <a:solidFill>
+            <a:srgbClr val="E8EEF5"/>
+          </a:solidFill>
+          <a:ln>
+            <a:noFill/>
+          </a:ln>
+        </p:spPr>
+        <p:style>
+          <a:lnRef idx="1">
+            <a:schemeClr val="accent1"/>
+          </a:lnRef>
+          <a:fillRef idx="3">
+            <a:schemeClr val="accent1"/>
+          </a:fillRef>
+          <a:effectRef idx="2">
+            <a:schemeClr val="accent1"/>
+          </a:effectRef>
+          <a:fontRef idx="minor">
+            <a:schemeClr val="lt1"/>
+          </a:fontRef>
+        </p:style>
+        <p:txBody>
+          <a:bodyPr rtlCol="0" anchor="ctr"/>
+          <a:lstStyle/>
+          <a:p>
+            <a:pPr algn="ctr"/>
+          </a:p>
+        </p:txBody>
+      </p:sp>
+      <p:sp>
+        <p:nvSpPr>
+          <p:cNvPr id="31" name="TextBox 30"/>
+          <p:cNvSpPr txBox="1"/>
+          <p:nvPr/>
+        </p:nvSpPr>
+        <p:spPr>
+          <a:xfrm>
+            <a:off x="640080" y="5330952"/>
+            <a:ext cx="1188720" cy="365760"/>
+          </a:xfrm>
+          <a:prstGeom prst="rect">
+            <a:avLst/>
+          </a:prstGeom>
+          <a:noFill/>
+        </p:spPr>
+        <p:txBody>
+          <a:bodyPr wrap="square">
+            <a:spAutoFit/>
+          </a:bodyPr>
+          <a:lstStyle/>
+          <a:p>
+            <a:pPr algn="l"/>
+            <a:r>
+              <a:rPr sz="1400" b="1">
+                <a:solidFill>
+                  <a:srgbClr val="1B6B93"/>
+                </a:solidFill>
+                <a:latin typeface="Calibri"/>
+              </a:rPr>
+              <a:t>PA-06</a:t>
+            </a:r>
+          </a:p>
+        </p:txBody>
+      </p:sp>
+      <p:sp>
+        <p:nvSpPr>
+          <p:cNvPr id="32" name="TextBox 31"/>
+          <p:cNvSpPr txBox="1"/>
+          <p:nvPr/>
+        </p:nvSpPr>
+        <p:spPr>
+          <a:xfrm>
+            <a:off x="2011680" y="5330952"/>
+            <a:ext cx="5943600" cy="365760"/>
+          </a:xfrm>
+          <a:prstGeom prst="rect">
+            <a:avLst/>
+          </a:prstGeom>
+          <a:noFill/>
+        </p:spPr>
+        <p:txBody>
+          <a:bodyPr wrap="square">
+            <a:spAutoFit/>
+          </a:bodyPr>
+          <a:lstStyle/>
+          <a:p>
+            <a:pPr algn="l"/>
+            <a:r>
+              <a:rPr sz="1400" b="0">
+                <a:solidFill>
+                  <a:srgbClr val="1F1F1F"/>
+                </a:solidFill>
+                <a:latin typeface="Calibri"/>
+              </a:rPr>
+              <a:t>Treinamento TI (IP RAP + Filebeat + checklist)</a:t>
+            </a:r>
+          </a:p>
+        </p:txBody>
+      </p:sp>
+      <p:sp>
+        <p:nvSpPr>
+          <p:cNvPr id="33" name="TextBox 32"/>
+          <p:cNvSpPr txBox="1"/>
+          <p:nvPr/>
+        </p:nvSpPr>
+        <p:spPr>
+          <a:xfrm>
+            <a:off x="8046720" y="5330952"/>
+            <a:ext cx="3383280" cy="365760"/>
+          </a:xfrm>
+          <a:prstGeom prst="rect">
+            <a:avLst/>
+          </a:prstGeom>
+          <a:noFill/>
+        </p:spPr>
+        <p:txBody>
+          <a:bodyPr wrap="square">
+            <a:spAutoFit/>
+          </a:bodyPr>
+          <a:lstStyle/>
+          <a:p>
+            <a:pPr algn="l"/>
+            <a:r>
+              <a:rPr sz="1300" b="0">
+                <a:solidFill>
+                  <a:srgbClr val="4A4A4A"/>
+                </a:solidFill>
+                <a:latin typeface="Calibri"/>
+              </a:rPr>
+              <a:t>TI</a:t>
+            </a:r>
+          </a:p>
+        </p:txBody>
+      </p:sp>
+      <p:sp>
+        <p:nvSpPr>
+          <p:cNvPr id="34" name="TextBox 33"/>
           <p:cNvSpPr txBox="1"/>
           <p:nvPr/>
         </p:nvSpPr>
@@ -8814,7 +9166,7 @@
       </p:sp>
       <p:sp>
         <p:nvSpPr>
-          <p:cNvPr id="20" name="TextBox 19"/>
+          <p:cNvPr id="35" name="TextBox 34"/>
           <p:cNvSpPr txBox="1"/>
           <p:nvPr/>
         </p:nvSpPr>
@@ -8842,7 +9194,7 @@
                 </a:solidFill>
                 <a:latin typeface="Calibri"/>
               </a:rPr>
-              <a:t>7/10</a:t>
+              <a:t>7/8</a:t>
             </a:r>
           </a:p>
         </p:txBody>
@@ -8880,7 +9232,7 @@
             <a:avLst/>
           </a:prstGeom>
           <a:solidFill>
-            <a:srgbClr val="F7F9FC"/>
+            <a:srgbClr val="0F2C59"/>
           </a:solidFill>
           <a:ln>
             <a:noFill/>
@@ -8916,51 +9268,8 @@
         </p:nvSpPr>
         <p:spPr>
           <a:xfrm>
-            <a:off x="0" y="0"/>
-            <a:ext cx="12191695" cy="960120"/>
-          </a:xfrm>
-          <a:prstGeom prst="rect">
-            <a:avLst/>
-          </a:prstGeom>
-          <a:solidFill>
-            <a:srgbClr val="0F2C59"/>
-          </a:solidFill>
-          <a:ln>
-            <a:noFill/>
-          </a:ln>
-        </p:spPr>
-        <p:style>
-          <a:lnRef idx="1">
-            <a:schemeClr val="accent1"/>
-          </a:lnRef>
-          <a:fillRef idx="3">
-            <a:schemeClr val="accent1"/>
-          </a:fillRef>
-          <a:effectRef idx="2">
-            <a:schemeClr val="accent1"/>
-          </a:effectRef>
-          <a:fontRef idx="minor">
-            <a:schemeClr val="lt1"/>
-          </a:fontRef>
-        </p:style>
-        <p:txBody>
-          <a:bodyPr rtlCol="0" anchor="ctr"/>
-          <a:lstStyle/>
-          <a:p>
-            <a:pPr algn="ctr"/>
-          </a:p>
-        </p:txBody>
-      </p:sp>
-      <p:sp>
-        <p:nvSpPr>
-          <p:cNvPr id="4" name="Rectangle 3"/>
-          <p:cNvSpPr/>
-          <p:nvPr/>
-        </p:nvSpPr>
-        <p:spPr>
-          <a:xfrm>
-            <a:off x="0" y="960120"/>
-            <a:ext cx="12191695" cy="73152"/>
+            <a:off x="0" y="5212080"/>
+            <a:ext cx="12191695" cy="1645920"/>
           </a:xfrm>
           <a:prstGeom prst="rect">
             <a:avLst/>
@@ -8996,2017 +9305,107 @@
       </p:sp>
       <p:sp>
         <p:nvSpPr>
+          <p:cNvPr id="4" name="TextBox 3"/>
+          <p:cNvSpPr txBox="1"/>
+          <p:nvPr/>
+        </p:nvSpPr>
+        <p:spPr>
+          <a:xfrm>
+            <a:off x="731520" y="1828800"/>
+            <a:ext cx="10698480" cy="1371600"/>
+          </a:xfrm>
+          <a:prstGeom prst="rect">
+            <a:avLst/>
+          </a:prstGeom>
+          <a:noFill/>
+        </p:spPr>
+        <p:txBody>
+          <a:bodyPr wrap="square">
+            <a:spAutoFit/>
+          </a:bodyPr>
+          <a:lstStyle/>
+          <a:p>
+            <a:pPr algn="ctr"/>
+            <a:r>
+              <a:rPr sz="3200" b="1">
+                <a:solidFill>
+                  <a:srgbClr val="FFFFFF"/>
+                </a:solidFill>
+                <a:latin typeface="Calibri"/>
+              </a:rPr>
+              <a:t>Problema de processo
+não se resolve com chamado de TI.</a:t>
+            </a:r>
+          </a:p>
+        </p:txBody>
+      </p:sp>
+      <p:sp>
+        <p:nvSpPr>
           <p:cNvPr id="5" name="TextBox 4"/>
           <p:cNvSpPr txBox="1"/>
           <p:nvPr/>
         </p:nvSpPr>
         <p:spPr>
           <a:xfrm>
-            <a:off x="457200" y="256032"/>
-            <a:ext cx="10972800" cy="457200"/>
-          </a:xfrm>
-          <a:prstGeom prst="rect">
-            <a:avLst/>
-          </a:prstGeom>
-          <a:noFill/>
-        </p:spPr>
-        <p:txBody>
-          <a:bodyPr wrap="square">
-            <a:spAutoFit/>
-          </a:bodyPr>
-          <a:lstStyle/>
-          <a:p>
-            <a:pPr algn="l"/>
-            <a:r>
-              <a:rPr sz="2800" b="1">
+            <a:off x="731520" y="3657600"/>
+            <a:ext cx="10698480" cy="548640"/>
+          </a:xfrm>
+          <a:prstGeom prst="rect">
+            <a:avLst/>
+          </a:prstGeom>
+          <a:noFill/>
+        </p:spPr>
+        <p:txBody>
+          <a:bodyPr wrap="square">
+            <a:spAutoFit/>
+          </a:bodyPr>
+          <a:lstStyle/>
+          <a:p>
+            <a:pPr algn="ctr"/>
+            <a:r>
+              <a:rPr sz="1800" b="0">
+                <a:solidFill>
+                  <a:srgbClr val="9BC9E0"/>
+                </a:solidFill>
+                <a:latin typeface="Calibri"/>
+              </a:rPr>
+              <a:t>Disciplina de processo  ·  Padronização de posto  ·  Dono claro</a:t>
+            </a:r>
+          </a:p>
+        </p:txBody>
+      </p:sp>
+      <p:sp>
+        <p:nvSpPr>
+          <p:cNvPr id="6" name="TextBox 5"/>
+          <p:cNvSpPr txBox="1"/>
+          <p:nvPr/>
+        </p:nvSpPr>
+        <p:spPr>
+          <a:xfrm>
+            <a:off x="731520" y="5669280"/>
+            <a:ext cx="10698480" cy="731520"/>
+          </a:xfrm>
+          <a:prstGeom prst="rect">
+            <a:avLst/>
+          </a:prstGeom>
+          <a:noFill/>
+        </p:spPr>
+        <p:txBody>
+          <a:bodyPr wrap="square">
+            <a:spAutoFit/>
+          </a:bodyPr>
+          <a:lstStyle/>
+          <a:p>
+            <a:pPr algn="ctr"/>
+            <a:r>
+              <a:rPr sz="1600" b="1">
                 <a:solidFill>
                   <a:srgbClr val="FFFFFF"/>
                 </a:solidFill>
                 <a:latin typeface="Calibri"/>
               </a:rPr>
-              <a:t>Decisões solicitadas à gerência</a:t>
-            </a:r>
-          </a:p>
-        </p:txBody>
-      </p:sp>
-      <p:sp>
-        <p:nvSpPr>
-          <p:cNvPr id="6" name="Rounded Rectangle 5"/>
-          <p:cNvSpPr/>
-          <p:nvPr/>
-        </p:nvSpPr>
-        <p:spPr>
-          <a:xfrm>
-            <a:off x="640080" y="1554480"/>
-            <a:ext cx="10881360" cy="914400"/>
-          </a:xfrm>
-          <a:prstGeom prst="roundRect">
-            <a:avLst/>
-          </a:prstGeom>
-          <a:solidFill>
-            <a:srgbClr val="FFFFFF"/>
-          </a:solidFill>
-          <a:ln>
-            <a:noFill/>
-          </a:ln>
-        </p:spPr>
-        <p:style>
-          <a:lnRef idx="1">
-            <a:schemeClr val="accent1"/>
-          </a:lnRef>
-          <a:fillRef idx="3">
-            <a:schemeClr val="accent1"/>
-          </a:fillRef>
-          <a:effectRef idx="2">
-            <a:schemeClr val="accent1"/>
-          </a:effectRef>
-          <a:fontRef idx="minor">
-            <a:schemeClr val="lt1"/>
-          </a:fontRef>
-        </p:style>
-        <p:txBody>
-          <a:bodyPr rtlCol="0" anchor="ctr"/>
-          <a:lstStyle/>
-          <a:p>
-            <a:pPr algn="ctr"/>
-          </a:p>
-        </p:txBody>
-      </p:sp>
-      <p:sp>
-        <p:nvSpPr>
-          <p:cNvPr id="7" name="Rounded Rectangle 6"/>
-          <p:cNvSpPr/>
-          <p:nvPr/>
-        </p:nvSpPr>
-        <p:spPr>
-          <a:xfrm>
-            <a:off x="868680" y="1783080"/>
-            <a:ext cx="502920" cy="502920"/>
-          </a:xfrm>
-          <a:prstGeom prst="roundRect">
-            <a:avLst/>
-          </a:prstGeom>
-          <a:solidFill>
-            <a:srgbClr val="0F2C59"/>
-          </a:solidFill>
-          <a:ln>
-            <a:noFill/>
-          </a:ln>
-        </p:spPr>
-        <p:style>
-          <a:lnRef idx="1">
-            <a:schemeClr val="accent1"/>
-          </a:lnRef>
-          <a:fillRef idx="3">
-            <a:schemeClr val="accent1"/>
-          </a:fillRef>
-          <a:effectRef idx="2">
-            <a:schemeClr val="accent1"/>
-          </a:effectRef>
-          <a:fontRef idx="minor">
-            <a:schemeClr val="lt1"/>
-          </a:fontRef>
-        </p:style>
-        <p:txBody>
-          <a:bodyPr rtlCol="0" anchor="ctr"/>
-          <a:lstStyle/>
-          <a:p>
-            <a:pPr algn="ctr"/>
-          </a:p>
-        </p:txBody>
-      </p:sp>
-      <p:sp>
-        <p:nvSpPr>
-          <p:cNvPr id="8" name="TextBox 7"/>
-          <p:cNvSpPr txBox="1"/>
-          <p:nvPr/>
-        </p:nvSpPr>
-        <p:spPr>
-          <a:xfrm>
-            <a:off x="868680" y="1847088"/>
-            <a:ext cx="502920" cy="411480"/>
-          </a:xfrm>
-          <a:prstGeom prst="rect">
-            <a:avLst/>
-          </a:prstGeom>
-          <a:noFill/>
-        </p:spPr>
-        <p:txBody>
-          <a:bodyPr wrap="square">
-            <a:spAutoFit/>
-          </a:bodyPr>
-          <a:lstStyle/>
-          <a:p>
-            <a:pPr algn="ctr"/>
-            <a:r>
-              <a:rPr sz="1600" b="1">
-                <a:solidFill>
-                  <a:srgbClr val="FFFFFF"/>
-                </a:solidFill>
-                <a:latin typeface="Calibri"/>
-              </a:rPr>
-              <a:t>1</a:t>
-            </a:r>
-          </a:p>
-        </p:txBody>
-      </p:sp>
-      <p:sp>
-        <p:nvSpPr>
-          <p:cNvPr id="9" name="TextBox 8"/>
-          <p:cNvSpPr txBox="1"/>
-          <p:nvPr/>
-        </p:nvSpPr>
-        <p:spPr>
-          <a:xfrm>
-            <a:off x="1645920" y="1828800"/>
-            <a:ext cx="9509760" cy="457200"/>
-          </a:xfrm>
-          <a:prstGeom prst="rect">
-            <a:avLst/>
-          </a:prstGeom>
-          <a:noFill/>
-        </p:spPr>
-        <p:txBody>
-          <a:bodyPr wrap="square">
-            <a:spAutoFit/>
-          </a:bodyPr>
-          <a:lstStyle/>
-          <a:p>
-            <a:pPr algn="l"/>
-            <a:r>
-              <a:rPr sz="1800" b="0">
-                <a:solidFill>
-                  <a:srgbClr val="1F1F1F"/>
-                </a:solidFill>
-                <a:latin typeface="Calibri"/>
-              </a:rPr>
-              <a:t>Reconhecer os ofensores como prioridade de Engenharia e Área Técnica</a:t>
-            </a:r>
-          </a:p>
-        </p:txBody>
-      </p:sp>
-      <p:sp>
-        <p:nvSpPr>
-          <p:cNvPr id="10" name="Rounded Rectangle 9"/>
-          <p:cNvSpPr/>
-          <p:nvPr/>
-        </p:nvSpPr>
-        <p:spPr>
-          <a:xfrm>
-            <a:off x="640080" y="2606039"/>
-            <a:ext cx="10881360" cy="914400"/>
-          </a:xfrm>
-          <a:prstGeom prst="roundRect">
-            <a:avLst/>
-          </a:prstGeom>
-          <a:solidFill>
-            <a:srgbClr val="FFFFFF"/>
-          </a:solidFill>
-          <a:ln>
-            <a:noFill/>
-          </a:ln>
-        </p:spPr>
-        <p:style>
-          <a:lnRef idx="1">
-            <a:schemeClr val="accent1"/>
-          </a:lnRef>
-          <a:fillRef idx="3">
-            <a:schemeClr val="accent1"/>
-          </a:fillRef>
-          <a:effectRef idx="2">
-            <a:schemeClr val="accent1"/>
-          </a:effectRef>
-          <a:fontRef idx="minor">
-            <a:schemeClr val="lt1"/>
-          </a:fontRef>
-        </p:style>
-        <p:txBody>
-          <a:bodyPr rtlCol="0" anchor="ctr"/>
-          <a:lstStyle/>
-          <a:p>
-            <a:pPr algn="ctr"/>
-          </a:p>
-        </p:txBody>
-      </p:sp>
-      <p:sp>
-        <p:nvSpPr>
-          <p:cNvPr id="11" name="Rounded Rectangle 10"/>
-          <p:cNvSpPr/>
-          <p:nvPr/>
-        </p:nvSpPr>
-        <p:spPr>
-          <a:xfrm>
-            <a:off x="868680" y="2834639"/>
-            <a:ext cx="502920" cy="502920"/>
-          </a:xfrm>
-          <a:prstGeom prst="roundRect">
-            <a:avLst/>
-          </a:prstGeom>
-          <a:solidFill>
-            <a:srgbClr val="0F2C59"/>
-          </a:solidFill>
-          <a:ln>
-            <a:noFill/>
-          </a:ln>
-        </p:spPr>
-        <p:style>
-          <a:lnRef idx="1">
-            <a:schemeClr val="accent1"/>
-          </a:lnRef>
-          <a:fillRef idx="3">
-            <a:schemeClr val="accent1"/>
-          </a:fillRef>
-          <a:effectRef idx="2">
-            <a:schemeClr val="accent1"/>
-          </a:effectRef>
-          <a:fontRef idx="minor">
-            <a:schemeClr val="lt1"/>
-          </a:fontRef>
-        </p:style>
-        <p:txBody>
-          <a:bodyPr rtlCol="0" anchor="ctr"/>
-          <a:lstStyle/>
-          <a:p>
-            <a:pPr algn="ctr"/>
-          </a:p>
-        </p:txBody>
-      </p:sp>
-      <p:sp>
-        <p:nvSpPr>
-          <p:cNvPr id="12" name="TextBox 11"/>
-          <p:cNvSpPr txBox="1"/>
-          <p:nvPr/>
-        </p:nvSpPr>
-        <p:spPr>
-          <a:xfrm>
-            <a:off x="868680" y="2898647"/>
-            <a:ext cx="502920" cy="411480"/>
-          </a:xfrm>
-          <a:prstGeom prst="rect">
-            <a:avLst/>
-          </a:prstGeom>
-          <a:noFill/>
-        </p:spPr>
-        <p:txBody>
-          <a:bodyPr wrap="square">
-            <a:spAutoFit/>
-          </a:bodyPr>
-          <a:lstStyle/>
-          <a:p>
-            <a:pPr algn="ctr"/>
-            <a:r>
-              <a:rPr sz="1600" b="1">
-                <a:solidFill>
-                  <a:srgbClr val="FFFFFF"/>
-                </a:solidFill>
-                <a:latin typeface="Calibri"/>
-              </a:rPr>
-              <a:t>2</a:t>
-            </a:r>
-          </a:p>
-        </p:txBody>
-      </p:sp>
-      <p:sp>
-        <p:nvSpPr>
-          <p:cNvPr id="13" name="TextBox 12"/>
-          <p:cNvSpPr txBox="1"/>
-          <p:nvPr/>
-        </p:nvSpPr>
-        <p:spPr>
-          <a:xfrm>
-            <a:off x="1645920" y="2880359"/>
-            <a:ext cx="9509760" cy="457200"/>
-          </a:xfrm>
-          <a:prstGeom prst="rect">
-            <a:avLst/>
-          </a:prstGeom>
-          <a:noFill/>
-        </p:spPr>
-        <p:txBody>
-          <a:bodyPr wrap="square">
-            <a:spAutoFit/>
-          </a:bodyPr>
-          <a:lstStyle/>
-          <a:p>
-            <a:pPr algn="l"/>
-            <a:r>
-              <a:rPr sz="1800" b="0">
-                <a:solidFill>
-                  <a:srgbClr val="1F1F1F"/>
-                </a:solidFill>
-                <a:latin typeface="Calibri"/>
-              </a:rPr>
-              <a:t>Definir dono e prazo para cada ação do plano</a:t>
-            </a:r>
-          </a:p>
-        </p:txBody>
-      </p:sp>
-      <p:sp>
-        <p:nvSpPr>
-          <p:cNvPr id="14" name="Rounded Rectangle 13"/>
-          <p:cNvSpPr/>
-          <p:nvPr/>
-        </p:nvSpPr>
-        <p:spPr>
-          <a:xfrm>
-            <a:off x="640080" y="3657600"/>
-            <a:ext cx="10881360" cy="914400"/>
-          </a:xfrm>
-          <a:prstGeom prst="roundRect">
-            <a:avLst/>
-          </a:prstGeom>
-          <a:solidFill>
-            <a:srgbClr val="FFFFFF"/>
-          </a:solidFill>
-          <a:ln>
-            <a:noFill/>
-          </a:ln>
-        </p:spPr>
-        <p:style>
-          <a:lnRef idx="1">
-            <a:schemeClr val="accent1"/>
-          </a:lnRef>
-          <a:fillRef idx="3">
-            <a:schemeClr val="accent1"/>
-          </a:fillRef>
-          <a:effectRef idx="2">
-            <a:schemeClr val="accent1"/>
-          </a:effectRef>
-          <a:fontRef idx="minor">
-            <a:schemeClr val="lt1"/>
-          </a:fontRef>
-        </p:style>
-        <p:txBody>
-          <a:bodyPr rtlCol="0" anchor="ctr"/>
-          <a:lstStyle/>
-          <a:p>
-            <a:pPr algn="ctr"/>
-          </a:p>
-        </p:txBody>
-      </p:sp>
-      <p:sp>
-        <p:nvSpPr>
-          <p:cNvPr id="15" name="Rounded Rectangle 14"/>
-          <p:cNvSpPr/>
-          <p:nvPr/>
-        </p:nvSpPr>
-        <p:spPr>
-          <a:xfrm>
-            <a:off x="868680" y="3886200"/>
-            <a:ext cx="502920" cy="502920"/>
-          </a:xfrm>
-          <a:prstGeom prst="roundRect">
-            <a:avLst/>
-          </a:prstGeom>
-          <a:solidFill>
-            <a:srgbClr val="0F2C59"/>
-          </a:solidFill>
-          <a:ln>
-            <a:noFill/>
-          </a:ln>
-        </p:spPr>
-        <p:style>
-          <a:lnRef idx="1">
-            <a:schemeClr val="accent1"/>
-          </a:lnRef>
-          <a:fillRef idx="3">
-            <a:schemeClr val="accent1"/>
-          </a:fillRef>
-          <a:effectRef idx="2">
-            <a:schemeClr val="accent1"/>
-          </a:effectRef>
-          <a:fontRef idx="minor">
-            <a:schemeClr val="lt1"/>
-          </a:fontRef>
-        </p:style>
-        <p:txBody>
-          <a:bodyPr rtlCol="0" anchor="ctr"/>
-          <a:lstStyle/>
-          <a:p>
-            <a:pPr algn="ctr"/>
-          </a:p>
-        </p:txBody>
-      </p:sp>
-      <p:sp>
-        <p:nvSpPr>
-          <p:cNvPr id="16" name="TextBox 15"/>
-          <p:cNvSpPr txBox="1"/>
-          <p:nvPr/>
-        </p:nvSpPr>
-        <p:spPr>
-          <a:xfrm>
-            <a:off x="868680" y="3950208"/>
-            <a:ext cx="502920" cy="411480"/>
-          </a:xfrm>
-          <a:prstGeom prst="rect">
-            <a:avLst/>
-          </a:prstGeom>
-          <a:noFill/>
-        </p:spPr>
-        <p:txBody>
-          <a:bodyPr wrap="square">
-            <a:spAutoFit/>
-          </a:bodyPr>
-          <a:lstStyle/>
-          <a:p>
-            <a:pPr algn="ctr"/>
-            <a:r>
-              <a:rPr sz="1600" b="1">
-                <a:solidFill>
-                  <a:srgbClr val="FFFFFF"/>
-                </a:solidFill>
-                <a:latin typeface="Calibri"/>
-              </a:rPr>
-              <a:t>3</a:t>
-            </a:r>
-          </a:p>
-        </p:txBody>
-      </p:sp>
-      <p:sp>
-        <p:nvSpPr>
-          <p:cNvPr id="17" name="TextBox 16"/>
-          <p:cNvSpPr txBox="1"/>
-          <p:nvPr/>
-        </p:nvSpPr>
-        <p:spPr>
-          <a:xfrm>
-            <a:off x="1645920" y="3931920"/>
-            <a:ext cx="9509760" cy="457200"/>
-          </a:xfrm>
-          <a:prstGeom prst="rect">
-            <a:avLst/>
-          </a:prstGeom>
-          <a:noFill/>
-        </p:spPr>
-        <p:txBody>
-          <a:bodyPr wrap="square">
-            <a:spAutoFit/>
-          </a:bodyPr>
-          <a:lstStyle/>
-          <a:p>
-            <a:pPr algn="l"/>
-            <a:r>
-              <a:rPr sz="1800" b="0">
-                <a:solidFill>
-                  <a:srgbClr val="1F1F1F"/>
-                </a:solidFill>
-                <a:latin typeface="Calibri"/>
-              </a:rPr>
-              <a:t>Exigir evidência antes de escalar ocorrência para TI</a:t>
-            </a:r>
-          </a:p>
-        </p:txBody>
-      </p:sp>
-      <p:sp>
-        <p:nvSpPr>
-          <p:cNvPr id="18" name="Rounded Rectangle 17"/>
-          <p:cNvSpPr/>
-          <p:nvPr/>
-        </p:nvSpPr>
-        <p:spPr>
-          <a:xfrm>
-            <a:off x="640080" y="4709159"/>
-            <a:ext cx="10881360" cy="914400"/>
-          </a:xfrm>
-          <a:prstGeom prst="roundRect">
-            <a:avLst/>
-          </a:prstGeom>
-          <a:solidFill>
-            <a:srgbClr val="FFFFFF"/>
-          </a:solidFill>
-          <a:ln>
-            <a:noFill/>
-          </a:ln>
-        </p:spPr>
-        <p:style>
-          <a:lnRef idx="1">
-            <a:schemeClr val="accent1"/>
-          </a:lnRef>
-          <a:fillRef idx="3">
-            <a:schemeClr val="accent1"/>
-          </a:fillRef>
-          <a:effectRef idx="2">
-            <a:schemeClr val="accent1"/>
-          </a:effectRef>
-          <a:fontRef idx="minor">
-            <a:schemeClr val="lt1"/>
-          </a:fontRef>
-        </p:style>
-        <p:txBody>
-          <a:bodyPr rtlCol="0" anchor="ctr"/>
-          <a:lstStyle/>
-          <a:p>
-            <a:pPr algn="ctr"/>
-          </a:p>
-        </p:txBody>
-      </p:sp>
-      <p:sp>
-        <p:nvSpPr>
-          <p:cNvPr id="19" name="Rounded Rectangle 18"/>
-          <p:cNvSpPr/>
-          <p:nvPr/>
-        </p:nvSpPr>
-        <p:spPr>
-          <a:xfrm>
-            <a:off x="868680" y="4937759"/>
-            <a:ext cx="502920" cy="502920"/>
-          </a:xfrm>
-          <a:prstGeom prst="roundRect">
-            <a:avLst/>
-          </a:prstGeom>
-          <a:solidFill>
-            <a:srgbClr val="0F2C59"/>
-          </a:solidFill>
-          <a:ln>
-            <a:noFill/>
-          </a:ln>
-        </p:spPr>
-        <p:style>
-          <a:lnRef idx="1">
-            <a:schemeClr val="accent1"/>
-          </a:lnRef>
-          <a:fillRef idx="3">
-            <a:schemeClr val="accent1"/>
-          </a:fillRef>
-          <a:effectRef idx="2">
-            <a:schemeClr val="accent1"/>
-          </a:effectRef>
-          <a:fontRef idx="minor">
-            <a:schemeClr val="lt1"/>
-          </a:fontRef>
-        </p:style>
-        <p:txBody>
-          <a:bodyPr rtlCol="0" anchor="ctr"/>
-          <a:lstStyle/>
-          <a:p>
-            <a:pPr algn="ctr"/>
-          </a:p>
-        </p:txBody>
-      </p:sp>
-      <p:sp>
-        <p:nvSpPr>
-          <p:cNvPr id="20" name="TextBox 19"/>
-          <p:cNvSpPr txBox="1"/>
-          <p:nvPr/>
-        </p:nvSpPr>
-        <p:spPr>
-          <a:xfrm>
-            <a:off x="868680" y="5001767"/>
-            <a:ext cx="502920" cy="411480"/>
-          </a:xfrm>
-          <a:prstGeom prst="rect">
-            <a:avLst/>
-          </a:prstGeom>
-          <a:noFill/>
-        </p:spPr>
-        <p:txBody>
-          <a:bodyPr wrap="square">
-            <a:spAutoFit/>
-          </a:bodyPr>
-          <a:lstStyle/>
-          <a:p>
-            <a:pPr algn="ctr"/>
-            <a:r>
-              <a:rPr sz="1600" b="1">
-                <a:solidFill>
-                  <a:srgbClr val="FFFFFF"/>
-                </a:solidFill>
-                <a:latin typeface="Calibri"/>
-              </a:rPr>
-              <a:t>4</a:t>
-            </a:r>
-          </a:p>
-        </p:txBody>
-      </p:sp>
-      <p:sp>
-        <p:nvSpPr>
-          <p:cNvPr id="21" name="TextBox 20"/>
-          <p:cNvSpPr txBox="1"/>
-          <p:nvPr/>
-        </p:nvSpPr>
-        <p:spPr>
-          <a:xfrm>
-            <a:off x="1645920" y="4983479"/>
-            <a:ext cx="9509760" cy="457200"/>
-          </a:xfrm>
-          <a:prstGeom prst="rect">
-            <a:avLst/>
-          </a:prstGeom>
-          <a:noFill/>
-        </p:spPr>
-        <p:txBody>
-          <a:bodyPr wrap="square">
-            <a:spAutoFit/>
-          </a:bodyPr>
-          <a:lstStyle/>
-          <a:p>
-            <a:pPr algn="l"/>
-            <a:r>
-              <a:rPr sz="1800" b="0">
-                <a:solidFill>
-                  <a:srgbClr val="1F1F1F"/>
-                </a:solidFill>
-                <a:latin typeface="Calibri"/>
-              </a:rPr>
-              <a:t>Apoiar o treinamento e a padronização de IP / Filebeat</a:t>
-            </a:r>
-          </a:p>
-        </p:txBody>
-      </p:sp>
-      <p:sp>
-        <p:nvSpPr>
-          <p:cNvPr id="22" name="TextBox 21"/>
-          <p:cNvSpPr txBox="1"/>
-          <p:nvPr/>
-        </p:nvSpPr>
-        <p:spPr>
-          <a:xfrm>
-            <a:off x="457200" y="6446520"/>
-            <a:ext cx="9144000" cy="274320"/>
-          </a:xfrm>
-          <a:prstGeom prst="rect">
-            <a:avLst/>
-          </a:prstGeom>
-          <a:noFill/>
-        </p:spPr>
-        <p:txBody>
-          <a:bodyPr wrap="square">
-            <a:spAutoFit/>
-          </a:bodyPr>
-          <a:lstStyle/>
-          <a:p>
-            <a:pPr algn="l"/>
-            <a:r>
-              <a:rPr sz="1100" b="0">
-                <a:solidFill>
-                  <a:srgbClr val="8A8A8A"/>
-                </a:solidFill>
-                <a:latin typeface="Calibri"/>
-              </a:rPr>
-              <a:t>TI  ·  Área Técnica  ·  Engenharia</a:t>
-            </a:r>
-          </a:p>
-        </p:txBody>
-      </p:sp>
-      <p:sp>
-        <p:nvSpPr>
-          <p:cNvPr id="23" name="TextBox 22"/>
-          <p:cNvSpPr txBox="1"/>
-          <p:nvPr/>
-        </p:nvSpPr>
-        <p:spPr>
-          <a:xfrm>
-            <a:off x="10515600" y="6446520"/>
-            <a:ext cx="1280160" cy="274320"/>
-          </a:xfrm>
-          <a:prstGeom prst="rect">
-            <a:avLst/>
-          </a:prstGeom>
-          <a:noFill/>
-        </p:spPr>
-        <p:txBody>
-          <a:bodyPr wrap="square">
-            <a:spAutoFit/>
-          </a:bodyPr>
-          <a:lstStyle/>
-          <a:p>
-            <a:pPr algn="r"/>
-            <a:r>
-              <a:rPr sz="1100" b="0">
-                <a:solidFill>
-                  <a:srgbClr val="8A8A8A"/>
-                </a:solidFill>
-                <a:latin typeface="Calibri"/>
-              </a:rPr>
-              <a:t>8/10</a:t>
-            </a:r>
-          </a:p>
-        </p:txBody>
-      </p:sp>
-    </p:spTree>
-  </p:cSld>
-  <p:clrMapOvr>
-    <a:masterClrMapping/>
-  </p:clrMapOvr>
-</p:sld>
-</file>
-
-<file path=ppt/slides/slide9.xml><?xml version="1.0" encoding="utf-8"?>
-<p:sld xmlns:a="http://schemas.openxmlformats.org/drawingml/2006/main" xmlns:p="http://schemas.openxmlformats.org/presentationml/2006/main" xmlns:r="http://schemas.openxmlformats.org/officeDocument/2006/relationships">
-  <p:cSld>
-    <p:spTree>
-      <p:nvGrpSpPr>
-        <p:cNvPr id="1" name=""/>
-        <p:cNvGrpSpPr/>
-        <p:nvPr/>
-      </p:nvGrpSpPr>
-      <p:grpSpPr/>
-      <p:sp>
-        <p:nvSpPr>
-          <p:cNvPr id="2" name="Rectangle 1"/>
-          <p:cNvSpPr/>
-          <p:nvPr/>
-        </p:nvSpPr>
-        <p:spPr>
-          <a:xfrm>
-            <a:off x="0" y="0"/>
-            <a:ext cx="12191695" cy="6858000"/>
-          </a:xfrm>
-          <a:prstGeom prst="rect">
-            <a:avLst/>
-          </a:prstGeom>
-          <a:solidFill>
-            <a:srgbClr val="F7F9FC"/>
-          </a:solidFill>
-          <a:ln>
-            <a:noFill/>
-          </a:ln>
-        </p:spPr>
-        <p:style>
-          <a:lnRef idx="1">
-            <a:schemeClr val="accent1"/>
-          </a:lnRef>
-          <a:fillRef idx="3">
-            <a:schemeClr val="accent1"/>
-          </a:fillRef>
-          <a:effectRef idx="2">
-            <a:schemeClr val="accent1"/>
-          </a:effectRef>
-          <a:fontRef idx="minor">
-            <a:schemeClr val="lt1"/>
-          </a:fontRef>
-        </p:style>
-        <p:txBody>
-          <a:bodyPr rtlCol="0" anchor="ctr"/>
-          <a:lstStyle/>
-          <a:p>
-            <a:pPr algn="ctr"/>
-          </a:p>
-        </p:txBody>
-      </p:sp>
-      <p:sp>
-        <p:nvSpPr>
-          <p:cNvPr id="3" name="Rectangle 2"/>
-          <p:cNvSpPr/>
-          <p:nvPr/>
-        </p:nvSpPr>
-        <p:spPr>
-          <a:xfrm>
-            <a:off x="0" y="0"/>
-            <a:ext cx="12191695" cy="960120"/>
-          </a:xfrm>
-          <a:prstGeom prst="rect">
-            <a:avLst/>
-          </a:prstGeom>
-          <a:solidFill>
-            <a:srgbClr val="0F2C59"/>
-          </a:solidFill>
-          <a:ln>
-            <a:noFill/>
-          </a:ln>
-        </p:spPr>
-        <p:style>
-          <a:lnRef idx="1">
-            <a:schemeClr val="accent1"/>
-          </a:lnRef>
-          <a:fillRef idx="3">
-            <a:schemeClr val="accent1"/>
-          </a:fillRef>
-          <a:effectRef idx="2">
-            <a:schemeClr val="accent1"/>
-          </a:effectRef>
-          <a:fontRef idx="minor">
-            <a:schemeClr val="lt1"/>
-          </a:fontRef>
-        </p:style>
-        <p:txBody>
-          <a:bodyPr rtlCol="0" anchor="ctr"/>
-          <a:lstStyle/>
-          <a:p>
-            <a:pPr algn="ctr"/>
-          </a:p>
-        </p:txBody>
-      </p:sp>
-      <p:sp>
-        <p:nvSpPr>
-          <p:cNvPr id="4" name="Rectangle 3"/>
-          <p:cNvSpPr/>
-          <p:nvPr/>
-        </p:nvSpPr>
-        <p:spPr>
-          <a:xfrm>
-            <a:off x="0" y="960120"/>
-            <a:ext cx="12191695" cy="73152"/>
-          </a:xfrm>
-          <a:prstGeom prst="rect">
-            <a:avLst/>
-          </a:prstGeom>
-          <a:solidFill>
-            <a:srgbClr val="1B6B93"/>
-          </a:solidFill>
-          <a:ln>
-            <a:noFill/>
-          </a:ln>
-        </p:spPr>
-        <p:style>
-          <a:lnRef idx="1">
-            <a:schemeClr val="accent1"/>
-          </a:lnRef>
-          <a:fillRef idx="3">
-            <a:schemeClr val="accent1"/>
-          </a:fillRef>
-          <a:effectRef idx="2">
-            <a:schemeClr val="accent1"/>
-          </a:effectRef>
-          <a:fontRef idx="minor">
-            <a:schemeClr val="lt1"/>
-          </a:fontRef>
-        </p:style>
-        <p:txBody>
-          <a:bodyPr rtlCol="0" anchor="ctr"/>
-          <a:lstStyle/>
-          <a:p>
-            <a:pPr algn="ctr"/>
-          </a:p>
-        </p:txBody>
-      </p:sp>
-      <p:sp>
-        <p:nvSpPr>
-          <p:cNvPr id="5" name="TextBox 4"/>
-          <p:cNvSpPr txBox="1"/>
-          <p:nvPr/>
-        </p:nvSpPr>
-        <p:spPr>
-          <a:xfrm>
-            <a:off x="457200" y="256032"/>
-            <a:ext cx="10972800" cy="457200"/>
-          </a:xfrm>
-          <a:prstGeom prst="rect">
-            <a:avLst/>
-          </a:prstGeom>
-          <a:noFill/>
-        </p:spPr>
-        <p:txBody>
-          <a:bodyPr wrap="square">
-            <a:spAutoFit/>
-          </a:bodyPr>
-          <a:lstStyle/>
-          <a:p>
-            <a:pPr algn="l"/>
-            <a:r>
-              <a:rPr sz="2800" b="1">
-                <a:solidFill>
-                  <a:srgbClr val="FFFFFF"/>
-                </a:solidFill>
-                <a:latin typeface="Calibri"/>
-              </a:rPr>
-              <a:t>Plano de ação resumido</a:t>
-            </a:r>
-          </a:p>
-        </p:txBody>
-      </p:sp>
-      <p:sp>
-        <p:nvSpPr>
-          <p:cNvPr id="6" name="Rectangle 5"/>
-          <p:cNvSpPr/>
-          <p:nvPr/>
-        </p:nvSpPr>
-        <p:spPr>
-          <a:xfrm>
-            <a:off x="457200" y="1417320"/>
-            <a:ext cx="11247120" cy="502920"/>
-          </a:xfrm>
-          <a:prstGeom prst="rect">
-            <a:avLst/>
-          </a:prstGeom>
-          <a:solidFill>
-            <a:srgbClr val="0F2C59"/>
-          </a:solidFill>
-          <a:ln>
-            <a:noFill/>
-          </a:ln>
-        </p:spPr>
-        <p:style>
-          <a:lnRef idx="1">
-            <a:schemeClr val="accent1"/>
-          </a:lnRef>
-          <a:fillRef idx="3">
-            <a:schemeClr val="accent1"/>
-          </a:fillRef>
-          <a:effectRef idx="2">
-            <a:schemeClr val="accent1"/>
-          </a:effectRef>
-          <a:fontRef idx="minor">
-            <a:schemeClr val="lt1"/>
-          </a:fontRef>
-        </p:style>
-        <p:txBody>
-          <a:bodyPr rtlCol="0" anchor="ctr"/>
-          <a:lstStyle/>
-          <a:p>
-            <a:pPr algn="ctr"/>
-          </a:p>
-        </p:txBody>
-      </p:sp>
-      <p:sp>
-        <p:nvSpPr>
-          <p:cNvPr id="7" name="TextBox 6"/>
-          <p:cNvSpPr txBox="1"/>
-          <p:nvPr/>
-        </p:nvSpPr>
-        <p:spPr>
-          <a:xfrm>
-            <a:off x="640080" y="1508760"/>
-            <a:ext cx="1188720" cy="365760"/>
-          </a:xfrm>
-          <a:prstGeom prst="rect">
-            <a:avLst/>
-          </a:prstGeom>
-          <a:noFill/>
-        </p:spPr>
-        <p:txBody>
-          <a:bodyPr wrap="square">
-            <a:spAutoFit/>
-          </a:bodyPr>
-          <a:lstStyle/>
-          <a:p>
-            <a:pPr algn="l"/>
-            <a:r>
-              <a:rPr sz="1400" b="1">
-                <a:solidFill>
-                  <a:srgbClr val="FFFFFF"/>
-                </a:solidFill>
-                <a:latin typeface="Calibri"/>
-              </a:rPr>
-              <a:t>ID</a:t>
-            </a:r>
-          </a:p>
-        </p:txBody>
-      </p:sp>
-      <p:sp>
-        <p:nvSpPr>
-          <p:cNvPr id="8" name="TextBox 7"/>
-          <p:cNvSpPr txBox="1"/>
-          <p:nvPr/>
-        </p:nvSpPr>
-        <p:spPr>
-          <a:xfrm>
-            <a:off x="2011680" y="1508760"/>
-            <a:ext cx="5943600" cy="365760"/>
-          </a:xfrm>
-          <a:prstGeom prst="rect">
-            <a:avLst/>
-          </a:prstGeom>
-          <a:noFill/>
-        </p:spPr>
-        <p:txBody>
-          <a:bodyPr wrap="square">
-            <a:spAutoFit/>
-          </a:bodyPr>
-          <a:lstStyle/>
-          <a:p>
-            <a:pPr algn="l"/>
-            <a:r>
-              <a:rPr sz="1400" b="1">
-                <a:solidFill>
-                  <a:srgbClr val="FFFFFF"/>
-                </a:solidFill>
-                <a:latin typeface="Calibri"/>
-              </a:rPr>
-              <a:t>Ação</a:t>
-            </a:r>
-          </a:p>
-        </p:txBody>
-      </p:sp>
-      <p:sp>
-        <p:nvSpPr>
-          <p:cNvPr id="9" name="TextBox 8"/>
-          <p:cNvSpPr txBox="1"/>
-          <p:nvPr/>
-        </p:nvSpPr>
-        <p:spPr>
-          <a:xfrm>
-            <a:off x="8046720" y="1508760"/>
-            <a:ext cx="3383280" cy="365760"/>
-          </a:xfrm>
-          <a:prstGeom prst="rect">
-            <a:avLst/>
-          </a:prstGeom>
-          <a:noFill/>
-        </p:spPr>
-        <p:txBody>
-          <a:bodyPr wrap="square">
-            <a:spAutoFit/>
-          </a:bodyPr>
-          <a:lstStyle/>
-          <a:p>
-            <a:pPr algn="l"/>
-            <a:r>
-              <a:rPr sz="1400" b="1">
-                <a:solidFill>
-                  <a:srgbClr val="FFFFFF"/>
-                </a:solidFill>
-                <a:latin typeface="Calibri"/>
-              </a:rPr>
-              <a:t>Dono</a:t>
-            </a:r>
-          </a:p>
-        </p:txBody>
-      </p:sp>
-      <p:sp>
-        <p:nvSpPr>
-          <p:cNvPr id="10" name="Rectangle 9"/>
-          <p:cNvSpPr/>
-          <p:nvPr/>
-        </p:nvSpPr>
-        <p:spPr>
-          <a:xfrm>
-            <a:off x="457200" y="1965960"/>
-            <a:ext cx="11247120" cy="640080"/>
-          </a:xfrm>
-          <a:prstGeom prst="rect">
-            <a:avLst/>
-          </a:prstGeom>
-          <a:solidFill>
-            <a:srgbClr val="FFFFFF"/>
-          </a:solidFill>
-          <a:ln>
-            <a:noFill/>
-          </a:ln>
-        </p:spPr>
-        <p:style>
-          <a:lnRef idx="1">
-            <a:schemeClr val="accent1"/>
-          </a:lnRef>
-          <a:fillRef idx="3">
-            <a:schemeClr val="accent1"/>
-          </a:fillRef>
-          <a:effectRef idx="2">
-            <a:schemeClr val="accent1"/>
-          </a:effectRef>
-          <a:fontRef idx="minor">
-            <a:schemeClr val="lt1"/>
-          </a:fontRef>
-        </p:style>
-        <p:txBody>
-          <a:bodyPr rtlCol="0" anchor="ctr"/>
-          <a:lstStyle/>
-          <a:p>
-            <a:pPr algn="ctr"/>
-          </a:p>
-        </p:txBody>
-      </p:sp>
-      <p:sp>
-        <p:nvSpPr>
-          <p:cNvPr id="11" name="TextBox 10"/>
-          <p:cNvSpPr txBox="1"/>
-          <p:nvPr/>
-        </p:nvSpPr>
-        <p:spPr>
-          <a:xfrm>
-            <a:off x="640080" y="2130552"/>
-            <a:ext cx="1188720" cy="365760"/>
-          </a:xfrm>
-          <a:prstGeom prst="rect">
-            <a:avLst/>
-          </a:prstGeom>
-          <a:noFill/>
-        </p:spPr>
-        <p:txBody>
-          <a:bodyPr wrap="square">
-            <a:spAutoFit/>
-          </a:bodyPr>
-          <a:lstStyle/>
-          <a:p>
-            <a:pPr algn="l"/>
-            <a:r>
-              <a:rPr sz="1400" b="1">
-                <a:solidFill>
-                  <a:srgbClr val="1B6B93"/>
-                </a:solidFill>
-                <a:latin typeface="Calibri"/>
-              </a:rPr>
-              <a:t>PA-01</a:t>
-            </a:r>
-          </a:p>
-        </p:txBody>
-      </p:sp>
-      <p:sp>
-        <p:nvSpPr>
-          <p:cNvPr id="12" name="TextBox 11"/>
-          <p:cNvSpPr txBox="1"/>
-          <p:nvPr/>
-        </p:nvSpPr>
-        <p:spPr>
-          <a:xfrm>
-            <a:off x="2011680" y="2130552"/>
-            <a:ext cx="5943600" cy="365760"/>
-          </a:xfrm>
-          <a:prstGeom prst="rect">
-            <a:avLst/>
-          </a:prstGeom>
-          <a:noFill/>
-        </p:spPr>
-        <p:txBody>
-          <a:bodyPr wrap="square">
-            <a:spAutoFit/>
-          </a:bodyPr>
-          <a:lstStyle/>
-          <a:p>
-            <a:pPr algn="l"/>
-            <a:r>
-              <a:rPr sz="1400" b="0">
-                <a:solidFill>
-                  <a:srgbClr val="1F1F1F"/>
-                </a:solidFill>
-                <a:latin typeface="Calibri"/>
-              </a:rPr>
-              <a:t>Padronizar/substituir cabos e conectores</a:t>
-            </a:r>
-          </a:p>
-        </p:txBody>
-      </p:sp>
-      <p:sp>
-        <p:nvSpPr>
-          <p:cNvPr id="13" name="TextBox 12"/>
-          <p:cNvSpPr txBox="1"/>
-          <p:nvPr/>
-        </p:nvSpPr>
-        <p:spPr>
-          <a:xfrm>
-            <a:off x="8046720" y="2130552"/>
-            <a:ext cx="3383280" cy="365760"/>
-          </a:xfrm>
-          <a:prstGeom prst="rect">
-            <a:avLst/>
-          </a:prstGeom>
-          <a:noFill/>
-        </p:spPr>
-        <p:txBody>
-          <a:bodyPr wrap="square">
-            <a:spAutoFit/>
-          </a:bodyPr>
-          <a:lstStyle/>
-          <a:p>
-            <a:pPr algn="l"/>
-            <a:r>
-              <a:rPr sz="1300" b="0">
-                <a:solidFill>
-                  <a:srgbClr val="4A4A4A"/>
-                </a:solidFill>
-                <a:latin typeface="Calibri"/>
-              </a:rPr>
-              <a:t>Área Técnica / Engenharia</a:t>
-            </a:r>
-          </a:p>
-        </p:txBody>
-      </p:sp>
-      <p:sp>
-        <p:nvSpPr>
-          <p:cNvPr id="14" name="Rectangle 13"/>
-          <p:cNvSpPr/>
-          <p:nvPr/>
-        </p:nvSpPr>
-        <p:spPr>
-          <a:xfrm>
-            <a:off x="457200" y="2606039"/>
-            <a:ext cx="11247120" cy="640080"/>
-          </a:xfrm>
-          <a:prstGeom prst="rect">
-            <a:avLst/>
-          </a:prstGeom>
-          <a:solidFill>
-            <a:srgbClr val="E8EEF5"/>
-          </a:solidFill>
-          <a:ln>
-            <a:noFill/>
-          </a:ln>
-        </p:spPr>
-        <p:style>
-          <a:lnRef idx="1">
-            <a:schemeClr val="accent1"/>
-          </a:lnRef>
-          <a:fillRef idx="3">
-            <a:schemeClr val="accent1"/>
-          </a:fillRef>
-          <a:effectRef idx="2">
-            <a:schemeClr val="accent1"/>
-          </a:effectRef>
-          <a:fontRef idx="minor">
-            <a:schemeClr val="lt1"/>
-          </a:fontRef>
-        </p:style>
-        <p:txBody>
-          <a:bodyPr rtlCol="0" anchor="ctr"/>
-          <a:lstStyle/>
-          <a:p>
-            <a:pPr algn="ctr"/>
-          </a:p>
-        </p:txBody>
-      </p:sp>
-      <p:sp>
-        <p:nvSpPr>
-          <p:cNvPr id="15" name="TextBox 14"/>
-          <p:cNvSpPr txBox="1"/>
-          <p:nvPr/>
-        </p:nvSpPr>
-        <p:spPr>
-          <a:xfrm>
-            <a:off x="640080" y="2770631"/>
-            <a:ext cx="1188720" cy="365760"/>
-          </a:xfrm>
-          <a:prstGeom prst="rect">
-            <a:avLst/>
-          </a:prstGeom>
-          <a:noFill/>
-        </p:spPr>
-        <p:txBody>
-          <a:bodyPr wrap="square">
-            <a:spAutoFit/>
-          </a:bodyPr>
-          <a:lstStyle/>
-          <a:p>
-            <a:pPr algn="l"/>
-            <a:r>
-              <a:rPr sz="1400" b="1">
-                <a:solidFill>
-                  <a:srgbClr val="1B6B93"/>
-                </a:solidFill>
-                <a:latin typeface="Calibri"/>
-              </a:rPr>
-              <a:t>PA-02</a:t>
-            </a:r>
-          </a:p>
-        </p:txBody>
-      </p:sp>
-      <p:sp>
-        <p:nvSpPr>
-          <p:cNvPr id="16" name="TextBox 15"/>
-          <p:cNvSpPr txBox="1"/>
-          <p:nvPr/>
-        </p:nvSpPr>
-        <p:spPr>
-          <a:xfrm>
-            <a:off x="2011680" y="2770631"/>
-            <a:ext cx="5943600" cy="365760"/>
-          </a:xfrm>
-          <a:prstGeom prst="rect">
-            <a:avLst/>
-          </a:prstGeom>
-          <a:noFill/>
-        </p:spPr>
-        <p:txBody>
-          <a:bodyPr wrap="square">
-            <a:spAutoFit/>
-          </a:bodyPr>
-          <a:lstStyle/>
-          <a:p>
-            <a:pPr algn="l"/>
-            <a:r>
-              <a:rPr sz="1400" b="0">
-                <a:solidFill>
-                  <a:srgbClr val="1F1F1F"/>
-                </a:solidFill>
-                <a:latin typeface="Calibri"/>
-              </a:rPr>
-              <a:t>Eliminar IPs duplicados e oficializar endereçamento</a:t>
-            </a:r>
-          </a:p>
-        </p:txBody>
-      </p:sp>
-      <p:sp>
-        <p:nvSpPr>
-          <p:cNvPr id="17" name="TextBox 16"/>
-          <p:cNvSpPr txBox="1"/>
-          <p:nvPr/>
-        </p:nvSpPr>
-        <p:spPr>
-          <a:xfrm>
-            <a:off x="8046720" y="2770631"/>
-            <a:ext cx="3383280" cy="365760"/>
-          </a:xfrm>
-          <a:prstGeom prst="rect">
-            <a:avLst/>
-          </a:prstGeom>
-          <a:noFill/>
-        </p:spPr>
-        <p:txBody>
-          <a:bodyPr wrap="square">
-            <a:spAutoFit/>
-          </a:bodyPr>
-          <a:lstStyle/>
-          <a:p>
-            <a:pPr algn="l"/>
-            <a:r>
-              <a:rPr sz="1300" b="0">
-                <a:solidFill>
-                  <a:srgbClr val="4A4A4A"/>
-                </a:solidFill>
-                <a:latin typeface="Calibri"/>
-              </a:rPr>
-              <a:t>Área Técnica / Engenharia</a:t>
-            </a:r>
-          </a:p>
-        </p:txBody>
-      </p:sp>
-      <p:sp>
-        <p:nvSpPr>
-          <p:cNvPr id="18" name="Rectangle 17"/>
-          <p:cNvSpPr/>
-          <p:nvPr/>
-        </p:nvSpPr>
-        <p:spPr>
-          <a:xfrm>
-            <a:off x="457200" y="3246120"/>
-            <a:ext cx="11247120" cy="640080"/>
-          </a:xfrm>
-          <a:prstGeom prst="rect">
-            <a:avLst/>
-          </a:prstGeom>
-          <a:solidFill>
-            <a:srgbClr val="FFFFFF"/>
-          </a:solidFill>
-          <a:ln>
-            <a:noFill/>
-          </a:ln>
-        </p:spPr>
-        <p:style>
-          <a:lnRef idx="1">
-            <a:schemeClr val="accent1"/>
-          </a:lnRef>
-          <a:fillRef idx="3">
-            <a:schemeClr val="accent1"/>
-          </a:fillRef>
-          <a:effectRef idx="2">
-            <a:schemeClr val="accent1"/>
-          </a:effectRef>
-          <a:fontRef idx="minor">
-            <a:schemeClr val="lt1"/>
-          </a:fontRef>
-        </p:style>
-        <p:txBody>
-          <a:bodyPr rtlCol="0" anchor="ctr"/>
-          <a:lstStyle/>
-          <a:p>
-            <a:pPr algn="ctr"/>
-          </a:p>
-        </p:txBody>
-      </p:sp>
-      <p:sp>
-        <p:nvSpPr>
-          <p:cNvPr id="19" name="TextBox 18"/>
-          <p:cNvSpPr txBox="1"/>
-          <p:nvPr/>
-        </p:nvSpPr>
-        <p:spPr>
-          <a:xfrm>
-            <a:off x="640080" y="3410712"/>
-            <a:ext cx="1188720" cy="365760"/>
-          </a:xfrm>
-          <a:prstGeom prst="rect">
-            <a:avLst/>
-          </a:prstGeom>
-          <a:noFill/>
-        </p:spPr>
-        <p:txBody>
-          <a:bodyPr wrap="square">
-            <a:spAutoFit/>
-          </a:bodyPr>
-          <a:lstStyle/>
-          <a:p>
-            <a:pPr algn="l"/>
-            <a:r>
-              <a:rPr sz="1400" b="1">
-                <a:solidFill>
-                  <a:srgbClr val="1B6B93"/>
-                </a:solidFill>
-                <a:latin typeface="Calibri"/>
-              </a:rPr>
-              <a:t>PA-03</a:t>
-            </a:r>
-          </a:p>
-        </p:txBody>
-      </p:sp>
-      <p:sp>
-        <p:nvSpPr>
-          <p:cNvPr id="20" name="TextBox 19"/>
-          <p:cNvSpPr txBox="1"/>
-          <p:nvPr/>
-        </p:nvSpPr>
-        <p:spPr>
-          <a:xfrm>
-            <a:off x="2011680" y="3410712"/>
-            <a:ext cx="5943600" cy="365760"/>
-          </a:xfrm>
-          <a:prstGeom prst="rect">
-            <a:avLst/>
-          </a:prstGeom>
-          <a:noFill/>
-        </p:spPr>
-        <p:txBody>
-          <a:bodyPr wrap="square">
-            <a:spAutoFit/>
-          </a:bodyPr>
-          <a:lstStyle/>
-          <a:p>
-            <a:pPr algn="l"/>
-            <a:r>
-              <a:rPr sz="1400" b="0">
-                <a:solidFill>
-                  <a:srgbClr val="1F1F1F"/>
-                </a:solidFill>
-                <a:latin typeface="Calibri"/>
-              </a:rPr>
-              <a:t>Controle de liberação de roteiro</a:t>
-            </a:r>
-          </a:p>
-        </p:txBody>
-      </p:sp>
-      <p:sp>
-        <p:nvSpPr>
-          <p:cNvPr id="21" name="TextBox 20"/>
-          <p:cNvSpPr txBox="1"/>
-          <p:nvPr/>
-        </p:nvSpPr>
-        <p:spPr>
-          <a:xfrm>
-            <a:off x="8046720" y="3410712"/>
-            <a:ext cx="3383280" cy="365760"/>
-          </a:xfrm>
-          <a:prstGeom prst="rect">
-            <a:avLst/>
-          </a:prstGeom>
-          <a:noFill/>
-        </p:spPr>
-        <p:txBody>
-          <a:bodyPr wrap="square">
-            <a:spAutoFit/>
-          </a:bodyPr>
-          <a:lstStyle/>
-          <a:p>
-            <a:pPr algn="l"/>
-            <a:r>
-              <a:rPr sz="1300" b="0">
-                <a:solidFill>
-                  <a:srgbClr val="4A4A4A"/>
-                </a:solidFill>
-                <a:latin typeface="Calibri"/>
-              </a:rPr>
-              <a:t>Engenharia / Área Técnica</a:t>
-            </a:r>
-          </a:p>
-        </p:txBody>
-      </p:sp>
-      <p:sp>
-        <p:nvSpPr>
-          <p:cNvPr id="22" name="Rectangle 21"/>
-          <p:cNvSpPr/>
-          <p:nvPr/>
-        </p:nvSpPr>
-        <p:spPr>
-          <a:xfrm>
-            <a:off x="457200" y="3886200"/>
-            <a:ext cx="11247120" cy="640080"/>
-          </a:xfrm>
-          <a:prstGeom prst="rect">
-            <a:avLst/>
-          </a:prstGeom>
-          <a:solidFill>
-            <a:srgbClr val="E8EEF5"/>
-          </a:solidFill>
-          <a:ln>
-            <a:noFill/>
-          </a:ln>
-        </p:spPr>
-        <p:style>
-          <a:lnRef idx="1">
-            <a:schemeClr val="accent1"/>
-          </a:lnRef>
-          <a:fillRef idx="3">
-            <a:schemeClr val="accent1"/>
-          </a:fillRef>
-          <a:effectRef idx="2">
-            <a:schemeClr val="accent1"/>
-          </a:effectRef>
-          <a:fontRef idx="minor">
-            <a:schemeClr val="lt1"/>
-          </a:fontRef>
-        </p:style>
-        <p:txBody>
-          <a:bodyPr rtlCol="0" anchor="ctr"/>
-          <a:lstStyle/>
-          <a:p>
-            <a:pPr algn="ctr"/>
-          </a:p>
-        </p:txBody>
-      </p:sp>
-      <p:sp>
-        <p:nvSpPr>
-          <p:cNvPr id="23" name="TextBox 22"/>
-          <p:cNvSpPr txBox="1"/>
-          <p:nvPr/>
-        </p:nvSpPr>
-        <p:spPr>
-          <a:xfrm>
-            <a:off x="640080" y="4050792"/>
-            <a:ext cx="1188720" cy="365760"/>
-          </a:xfrm>
-          <a:prstGeom prst="rect">
-            <a:avLst/>
-          </a:prstGeom>
-          <a:noFill/>
-        </p:spPr>
-        <p:txBody>
-          <a:bodyPr wrap="square">
-            <a:spAutoFit/>
-          </a:bodyPr>
-          <a:lstStyle/>
-          <a:p>
-            <a:pPr algn="l"/>
-            <a:r>
-              <a:rPr sz="1400" b="1">
-                <a:solidFill>
-                  <a:srgbClr val="1B6B93"/>
-                </a:solidFill>
-                <a:latin typeface="Calibri"/>
-              </a:rPr>
-              <a:t>PA-04</a:t>
-            </a:r>
-          </a:p>
-        </p:txBody>
-      </p:sp>
-      <p:sp>
-        <p:nvSpPr>
-          <p:cNvPr id="24" name="TextBox 23"/>
-          <p:cNvSpPr txBox="1"/>
-          <p:nvPr/>
-        </p:nvSpPr>
-        <p:spPr>
-          <a:xfrm>
-            <a:off x="2011680" y="4050792"/>
-            <a:ext cx="5943600" cy="365760"/>
-          </a:xfrm>
-          <a:prstGeom prst="rect">
-            <a:avLst/>
-          </a:prstGeom>
-          <a:noFill/>
-        </p:spPr>
-        <p:txBody>
-          <a:bodyPr wrap="square">
-            <a:spAutoFit/>
-          </a:bodyPr>
-          <a:lstStyle/>
-          <a:p>
-            <a:pPr algn="l"/>
-            <a:r>
-              <a:rPr sz="1400" b="0">
-                <a:solidFill>
-                  <a:srgbClr val="1F1F1F"/>
-                </a:solidFill>
-                <a:latin typeface="Calibri"/>
-              </a:rPr>
-              <a:t>Adequação de RASPs/PCs com baixa performance</a:t>
-            </a:r>
-          </a:p>
-        </p:txBody>
-      </p:sp>
-      <p:sp>
-        <p:nvSpPr>
-          <p:cNvPr id="25" name="TextBox 24"/>
-          <p:cNvSpPr txBox="1"/>
-          <p:nvPr/>
-        </p:nvSpPr>
-        <p:spPr>
-          <a:xfrm>
-            <a:off x="8046720" y="4050792"/>
-            <a:ext cx="3383280" cy="365760"/>
-          </a:xfrm>
-          <a:prstGeom prst="rect">
-            <a:avLst/>
-          </a:prstGeom>
-          <a:noFill/>
-        </p:spPr>
-        <p:txBody>
-          <a:bodyPr wrap="square">
-            <a:spAutoFit/>
-          </a:bodyPr>
-          <a:lstStyle/>
-          <a:p>
-            <a:pPr algn="l"/>
-            <a:r>
-              <a:rPr sz="1300" b="0">
-                <a:solidFill>
-                  <a:srgbClr val="4A4A4A"/>
-                </a:solidFill>
-                <a:latin typeface="Calibri"/>
-              </a:rPr>
-              <a:t>Área Técnica / Engenharia</a:t>
-            </a:r>
-          </a:p>
-        </p:txBody>
-      </p:sp>
-      <p:sp>
-        <p:nvSpPr>
-          <p:cNvPr id="26" name="Rectangle 25"/>
-          <p:cNvSpPr/>
-          <p:nvPr/>
-        </p:nvSpPr>
-        <p:spPr>
-          <a:xfrm>
-            <a:off x="457200" y="4526279"/>
-            <a:ext cx="11247120" cy="640080"/>
-          </a:xfrm>
-          <a:prstGeom prst="rect">
-            <a:avLst/>
-          </a:prstGeom>
-          <a:solidFill>
-            <a:srgbClr val="FFFFFF"/>
-          </a:solidFill>
-          <a:ln>
-            <a:noFill/>
-          </a:ln>
-        </p:spPr>
-        <p:style>
-          <a:lnRef idx="1">
-            <a:schemeClr val="accent1"/>
-          </a:lnRef>
-          <a:fillRef idx="3">
-            <a:schemeClr val="accent1"/>
-          </a:fillRef>
-          <a:effectRef idx="2">
-            <a:schemeClr val="accent1"/>
-          </a:effectRef>
-          <a:fontRef idx="minor">
-            <a:schemeClr val="lt1"/>
-          </a:fontRef>
-        </p:style>
-        <p:txBody>
-          <a:bodyPr rtlCol="0" anchor="ctr"/>
-          <a:lstStyle/>
-          <a:p>
-            <a:pPr algn="ctr"/>
-          </a:p>
-        </p:txBody>
-      </p:sp>
-      <p:sp>
-        <p:nvSpPr>
-          <p:cNvPr id="27" name="TextBox 26"/>
-          <p:cNvSpPr txBox="1"/>
-          <p:nvPr/>
-        </p:nvSpPr>
-        <p:spPr>
-          <a:xfrm>
-            <a:off x="640080" y="4690871"/>
-            <a:ext cx="1188720" cy="365760"/>
-          </a:xfrm>
-          <a:prstGeom prst="rect">
-            <a:avLst/>
-          </a:prstGeom>
-          <a:noFill/>
-        </p:spPr>
-        <p:txBody>
-          <a:bodyPr wrap="square">
-            <a:spAutoFit/>
-          </a:bodyPr>
-          <a:lstStyle/>
-          <a:p>
-            <a:pPr algn="l"/>
-            <a:r>
-              <a:rPr sz="1400" b="1">
-                <a:solidFill>
-                  <a:srgbClr val="1B6B93"/>
-                </a:solidFill>
-                <a:latin typeface="Calibri"/>
-              </a:rPr>
-              <a:t>PA-05</a:t>
-            </a:r>
-          </a:p>
-        </p:txBody>
-      </p:sp>
-      <p:sp>
-        <p:nvSpPr>
-          <p:cNvPr id="28" name="TextBox 27"/>
-          <p:cNvSpPr txBox="1"/>
-          <p:nvPr/>
-        </p:nvSpPr>
-        <p:spPr>
-          <a:xfrm>
-            <a:off x="2011680" y="4690871"/>
-            <a:ext cx="5943600" cy="365760"/>
-          </a:xfrm>
-          <a:prstGeom prst="rect">
-            <a:avLst/>
-          </a:prstGeom>
-          <a:noFill/>
-        </p:spPr>
-        <p:txBody>
-          <a:bodyPr wrap="square">
-            <a:spAutoFit/>
-          </a:bodyPr>
-          <a:lstStyle/>
-          <a:p>
-            <a:pPr algn="l"/>
-            <a:r>
-              <a:rPr sz="1400" b="0">
-                <a:solidFill>
-                  <a:srgbClr val="1F1F1F"/>
-                </a:solidFill>
-                <a:latin typeface="Calibri"/>
-              </a:rPr>
-              <a:t>Padronizar status passou/não passou</a:t>
-            </a:r>
-          </a:p>
-        </p:txBody>
-      </p:sp>
-      <p:sp>
-        <p:nvSpPr>
-          <p:cNvPr id="29" name="TextBox 28"/>
-          <p:cNvSpPr txBox="1"/>
-          <p:nvPr/>
-        </p:nvSpPr>
-        <p:spPr>
-          <a:xfrm>
-            <a:off x="8046720" y="4690871"/>
-            <a:ext cx="3383280" cy="365760"/>
-          </a:xfrm>
-          <a:prstGeom prst="rect">
-            <a:avLst/>
-          </a:prstGeom>
-          <a:noFill/>
-        </p:spPr>
-        <p:txBody>
-          <a:bodyPr wrap="square">
-            <a:spAutoFit/>
-          </a:bodyPr>
-          <a:lstStyle/>
-          <a:p>
-            <a:pPr algn="l"/>
-            <a:r>
-              <a:rPr sz="1300" b="0">
-                <a:solidFill>
-                  <a:srgbClr val="4A4A4A"/>
-                </a:solidFill>
-                <a:latin typeface="Calibri"/>
-              </a:rPr>
-              <a:t>Engenharia / Área Técnica</a:t>
-            </a:r>
-          </a:p>
-        </p:txBody>
-      </p:sp>
-      <p:sp>
-        <p:nvSpPr>
-          <p:cNvPr id="30" name="Rectangle 29"/>
-          <p:cNvSpPr/>
-          <p:nvPr/>
-        </p:nvSpPr>
-        <p:spPr>
-          <a:xfrm>
-            <a:off x="457200" y="5166360"/>
-            <a:ext cx="11247120" cy="640080"/>
-          </a:xfrm>
-          <a:prstGeom prst="rect">
-            <a:avLst/>
-          </a:prstGeom>
-          <a:solidFill>
-            <a:srgbClr val="E8EEF5"/>
-          </a:solidFill>
-          <a:ln>
-            <a:noFill/>
-          </a:ln>
-        </p:spPr>
-        <p:style>
-          <a:lnRef idx="1">
-            <a:schemeClr val="accent1"/>
-          </a:lnRef>
-          <a:fillRef idx="3">
-            <a:schemeClr val="accent1"/>
-          </a:fillRef>
-          <a:effectRef idx="2">
-            <a:schemeClr val="accent1"/>
-          </a:effectRef>
-          <a:fontRef idx="minor">
-            <a:schemeClr val="lt1"/>
-          </a:fontRef>
-        </p:style>
-        <p:txBody>
-          <a:bodyPr rtlCol="0" anchor="ctr"/>
-          <a:lstStyle/>
-          <a:p>
-            <a:pPr algn="ctr"/>
-          </a:p>
-        </p:txBody>
-      </p:sp>
-      <p:sp>
-        <p:nvSpPr>
-          <p:cNvPr id="31" name="TextBox 30"/>
-          <p:cNvSpPr txBox="1"/>
-          <p:nvPr/>
-        </p:nvSpPr>
-        <p:spPr>
-          <a:xfrm>
-            <a:off x="640080" y="5330952"/>
-            <a:ext cx="1188720" cy="365760"/>
-          </a:xfrm>
-          <a:prstGeom prst="rect">
-            <a:avLst/>
-          </a:prstGeom>
-          <a:noFill/>
-        </p:spPr>
-        <p:txBody>
-          <a:bodyPr wrap="square">
-            <a:spAutoFit/>
-          </a:bodyPr>
-          <a:lstStyle/>
-          <a:p>
-            <a:pPr algn="l"/>
-            <a:r>
-              <a:rPr sz="1400" b="1">
-                <a:solidFill>
-                  <a:srgbClr val="1B6B93"/>
-                </a:solidFill>
-                <a:latin typeface="Calibri"/>
-              </a:rPr>
-              <a:t>PA-06</a:t>
-            </a:r>
-          </a:p>
-        </p:txBody>
-      </p:sp>
-      <p:sp>
-        <p:nvSpPr>
-          <p:cNvPr id="32" name="TextBox 31"/>
-          <p:cNvSpPr txBox="1"/>
-          <p:nvPr/>
-        </p:nvSpPr>
-        <p:spPr>
-          <a:xfrm>
-            <a:off x="2011680" y="5330952"/>
-            <a:ext cx="5943600" cy="365760"/>
-          </a:xfrm>
-          <a:prstGeom prst="rect">
-            <a:avLst/>
-          </a:prstGeom>
-          <a:noFill/>
-        </p:spPr>
-        <p:txBody>
-          <a:bodyPr wrap="square">
-            <a:spAutoFit/>
-          </a:bodyPr>
-          <a:lstStyle/>
-          <a:p>
-            <a:pPr algn="l"/>
-            <a:r>
-              <a:rPr sz="1400" b="0">
-                <a:solidFill>
-                  <a:srgbClr val="1F1F1F"/>
-                </a:solidFill>
-                <a:latin typeface="Calibri"/>
-              </a:rPr>
-              <a:t>Treinamento TI (IP RAP + Filebeat + checklist)</a:t>
-            </a:r>
-          </a:p>
-        </p:txBody>
-      </p:sp>
-      <p:sp>
-        <p:nvSpPr>
-          <p:cNvPr id="33" name="TextBox 32"/>
-          <p:cNvSpPr txBox="1"/>
-          <p:nvPr/>
-        </p:nvSpPr>
-        <p:spPr>
-          <a:xfrm>
-            <a:off x="8046720" y="5330952"/>
-            <a:ext cx="3383280" cy="365760"/>
-          </a:xfrm>
-          <a:prstGeom prst="rect">
-            <a:avLst/>
-          </a:prstGeom>
-          <a:noFill/>
-        </p:spPr>
-        <p:txBody>
-          <a:bodyPr wrap="square">
-            <a:spAutoFit/>
-          </a:bodyPr>
-          <a:lstStyle/>
-          <a:p>
-            <a:pPr algn="l"/>
-            <a:r>
-              <a:rPr sz="1300" b="0">
-                <a:solidFill>
-                  <a:srgbClr val="4A4A4A"/>
-                </a:solidFill>
-                <a:latin typeface="Calibri"/>
-              </a:rPr>
-              <a:t>TI</a:t>
-            </a:r>
-          </a:p>
-        </p:txBody>
-      </p:sp>
-      <p:sp>
-        <p:nvSpPr>
-          <p:cNvPr id="34" name="TextBox 33"/>
-          <p:cNvSpPr txBox="1"/>
-          <p:nvPr/>
-        </p:nvSpPr>
-        <p:spPr>
-          <a:xfrm>
-            <a:off x="457200" y="6446520"/>
-            <a:ext cx="9144000" cy="274320"/>
-          </a:xfrm>
-          <a:prstGeom prst="rect">
-            <a:avLst/>
-          </a:prstGeom>
-          <a:noFill/>
-        </p:spPr>
-        <p:txBody>
-          <a:bodyPr wrap="square">
-            <a:spAutoFit/>
-          </a:bodyPr>
-          <a:lstStyle/>
-          <a:p>
-            <a:pPr algn="l"/>
-            <a:r>
-              <a:rPr sz="1100" b="0">
-                <a:solidFill>
-                  <a:srgbClr val="8A8A8A"/>
-                </a:solidFill>
-                <a:latin typeface="Calibri"/>
-              </a:rPr>
-              <a:t>TI  ·  Área Técnica  ·  Engenharia</a:t>
-            </a:r>
-          </a:p>
-        </p:txBody>
-      </p:sp>
-      <p:sp>
-        <p:nvSpPr>
-          <p:cNvPr id="35" name="TextBox 34"/>
-          <p:cNvSpPr txBox="1"/>
-          <p:nvPr/>
-        </p:nvSpPr>
-        <p:spPr>
-          <a:xfrm>
-            <a:off x="10515600" y="6446520"/>
-            <a:ext cx="1280160" cy="274320"/>
-          </a:xfrm>
-          <a:prstGeom prst="rect">
-            <a:avLst/>
-          </a:prstGeom>
-          <a:noFill/>
-        </p:spPr>
-        <p:txBody>
-          <a:bodyPr wrap="square">
-            <a:spAutoFit/>
-          </a:bodyPr>
-          <a:lstStyle/>
-          <a:p>
-            <a:pPr algn="r"/>
-            <a:r>
-              <a:rPr sz="1100" b="0">
-                <a:solidFill>
-                  <a:srgbClr val="8A8A8A"/>
-                </a:solidFill>
-                <a:latin typeface="Calibri"/>
-              </a:rPr>
-              <a:t>9/10</a:t>
+              <a:t>TI capacita (IP RAP + Filebeat + checklist)
+Engenharia e Área Técnica corrigem na origem</a:t>
             </a:r>
           </a:p>
         </p:txBody>

</xml_diff>

<commit_message>
Remove evidence slides from presentation deck
Drop former slides 4 and 5, keep a 6-slide managerial flow focused
on message, offenders, TI training, action plan, and close.

Co-authored-by: BossPrime <matheussilva030499-oss@users.noreply.github.com>
</commit_message>
<xml_diff>
--- a/docs/Apresentacao_Ofensores_Lentidao.pptx
+++ b/docs/Apresentacao_Ofensores_Lentidao.pptx
@@ -11,8 +11,6 @@
     <p:sldId id="259" r:id="rId10"/>
     <p:sldId id="260" r:id="rId11"/>
     <p:sldId id="261" r:id="rId12"/>
-    <p:sldId id="262" r:id="rId13"/>
-    <p:sldId id="263" r:id="rId14"/>
   </p:sldIdLst>
   <p:sldSz cx="12191695" cy="6858000" type="screen4x3"/>
   <p:notesSz cx="6858000" cy="9144000"/>
@@ -4081,7 +4079,7 @@
                 </a:solidFill>
                 <a:latin typeface="Calibri"/>
               </a:rPr>
-              <a:t>2/8</a:t>
+              <a:t>2/6</a:t>
             </a:r>
           </a:p>
         </p:txBody>
@@ -5514,7 +5512,7 @@
                 </a:solidFill>
                 <a:latin typeface="Calibri"/>
               </a:rPr>
-              <a:t>3/8</a:t>
+              <a:t>3/6</a:t>
             </a:r>
           </a:p>
         </p:txBody>
@@ -5696,7 +5694,7 @@
                 </a:solidFill>
                 <a:latin typeface="Calibri"/>
               </a:rPr>
-              <a:t>Evidências — conexão física</a:t>
+              <a:t>Compromisso da TI — Treinamento</a:t>
             </a:r>
           </a:p>
         </p:txBody>
@@ -5709,8 +5707,8 @@
         </p:nvSpPr>
         <p:spPr>
           <a:xfrm>
-            <a:off x="457200" y="1143000"/>
-            <a:ext cx="10972800" cy="365760"/>
+            <a:off x="548640" y="1371600"/>
+            <a:ext cx="10972800" cy="457200"/>
           </a:xfrm>
           <a:prstGeom prst="rect">
             <a:avLst/>
@@ -5725,13 +5723,13 @@
           <a:p>
             <a:pPr algn="l"/>
             <a:r>
-              <a:rPr sz="1400" b="0">
-                <a:solidFill>
-                  <a:srgbClr val="1B6B93"/>
+              <a:rPr sz="1800" b="0">
+                <a:solidFill>
+                  <a:srgbClr val="4A4A4A"/>
                 </a:solidFill>
                 <a:latin typeface="Calibri"/>
               </a:rPr>
-              <a:t>Cabo, conector e instalação do posto</a:t>
+              <a:t>A TI não veio só apontar problema. Vamos capacitar Área Técnica e Engenharia.</a:t>
             </a:r>
           </a:p>
         </p:txBody>
@@ -5744,51 +5742,8 @@
         </p:nvSpPr>
         <p:spPr>
           <a:xfrm>
-            <a:off x="457200" y="1554480"/>
-            <a:ext cx="5577840" cy="2011680"/>
-          </a:xfrm>
-          <a:prstGeom prst="roundRect">
-            <a:avLst/>
-          </a:prstGeom>
-          <a:solidFill>
-            <a:srgbClr val="FFFFFF"/>
-          </a:solidFill>
-          <a:ln>
-            <a:noFill/>
-          </a:ln>
-        </p:spPr>
-        <p:style>
-          <a:lnRef idx="1">
-            <a:schemeClr val="accent1"/>
-          </a:lnRef>
-          <a:fillRef idx="3">
-            <a:schemeClr val="accent1"/>
-          </a:fillRef>
-          <a:effectRef idx="2">
-            <a:schemeClr val="accent1"/>
-          </a:effectRef>
-          <a:fontRef idx="minor">
-            <a:schemeClr val="lt1"/>
-          </a:fontRef>
-        </p:style>
-        <p:txBody>
-          <a:bodyPr rtlCol="0" anchor="ctr"/>
-          <a:lstStyle/>
-          <a:p>
-            <a:pPr algn="ctr"/>
-          </a:p>
-        </p:txBody>
-      </p:sp>
-      <p:sp>
-        <p:nvSpPr>
-          <p:cNvPr id="8" name="Rounded Rectangle 7"/>
-          <p:cNvSpPr/>
-          <p:nvPr/>
-        </p:nvSpPr>
-        <p:spPr>
-          <a:xfrm>
-            <a:off x="685800" y="1874520"/>
-            <a:ext cx="1188720" cy="411480"/>
+            <a:off x="548640" y="2103120"/>
+            <a:ext cx="3611880" cy="3200400"/>
           </a:xfrm>
           <a:prstGeom prst="roundRect">
             <a:avLst/>
@@ -5824,14 +5779,14 @@
       </p:sp>
       <p:sp>
         <p:nvSpPr>
-          <p:cNvPr id="9" name="TextBox 8"/>
+          <p:cNvPr id="8" name="TextBox 7"/>
           <p:cNvSpPr txBox="1"/>
           <p:nvPr/>
         </p:nvSpPr>
         <p:spPr>
           <a:xfrm>
-            <a:off x="685800" y="1901952"/>
-            <a:ext cx="1188720" cy="365760"/>
+            <a:off x="822960" y="2377440"/>
+            <a:ext cx="3017520" cy="365760"/>
           </a:xfrm>
           <a:prstGeom prst="rect">
             <a:avLst/>
@@ -5844,29 +5799,29 @@
           </a:bodyPr>
           <a:lstStyle/>
           <a:p>
-            <a:pPr algn="ctr"/>
-            <a:r>
-              <a:rPr sz="1200" b="1">
-                <a:solidFill>
-                  <a:srgbClr val="FFFFFF"/>
+            <a:pPr algn="l"/>
+            <a:r>
+              <a:rPr sz="1400" b="1">
+                <a:solidFill>
+                  <a:srgbClr val="9BC9E0"/>
                 </a:solidFill>
                 <a:latin typeface="Calibri"/>
               </a:rPr>
-              <a:t>EV 01</a:t>
-            </a:r>
-          </a:p>
-        </p:txBody>
-      </p:sp>
-      <p:sp>
-        <p:nvSpPr>
-          <p:cNvPr id="10" name="TextBox 9"/>
+              <a:t>01</a:t>
+            </a:r>
+          </a:p>
+        </p:txBody>
+      </p:sp>
+      <p:sp>
+        <p:nvSpPr>
+          <p:cNvPr id="9" name="TextBox 8"/>
           <p:cNvSpPr txBox="1"/>
           <p:nvPr/>
         </p:nvSpPr>
         <p:spPr>
           <a:xfrm>
-            <a:off x="2103120" y="1874520"/>
-            <a:ext cx="3657600" cy="411480"/>
+            <a:off x="822960" y="2926080"/>
+            <a:ext cx="3017520" cy="548640"/>
           </a:xfrm>
           <a:prstGeom prst="rect">
             <a:avLst/>
@@ -5881,27 +5836,27 @@
           <a:p>
             <a:pPr algn="l"/>
             <a:r>
-              <a:rPr sz="2000" b="1">
-                <a:solidFill>
-                  <a:srgbClr val="0F2C59"/>
+              <a:rPr sz="2600" b="1">
+                <a:solidFill>
+                  <a:srgbClr val="FFFFFF"/>
                 </a:solidFill>
                 <a:latin typeface="Calibri"/>
               </a:rPr>
-              <a:t>Cabo sem presilha</a:t>
-            </a:r>
-          </a:p>
-        </p:txBody>
-      </p:sp>
-      <p:sp>
-        <p:nvSpPr>
-          <p:cNvPr id="11" name="TextBox 10"/>
+              <a:t>IP em RAP</a:t>
+            </a:r>
+          </a:p>
+        </p:txBody>
+      </p:sp>
+      <p:sp>
+        <p:nvSpPr>
+          <p:cNvPr id="10" name="TextBox 9"/>
           <p:cNvSpPr txBox="1"/>
           <p:nvPr/>
         </p:nvSpPr>
         <p:spPr>
           <a:xfrm>
-            <a:off x="777240" y="2560320"/>
-            <a:ext cx="5029200" cy="731520"/>
+            <a:off x="822960" y="3749039"/>
+            <a:ext cx="3017520" cy="1097280"/>
           </a:xfrm>
           <a:prstGeom prst="rect">
             <a:avLst/>
@@ -5916,70 +5871,28 @@
           <a:p>
             <a:pPr algn="l"/>
             <a:r>
-              <a:rPr sz="1500" b="0">
-                <a:solidFill>
-                  <a:srgbClr val="4A4A4A"/>
+              <a:rPr sz="1600" b="0">
+                <a:solidFill>
+                  <a:srgbClr val="D6E3F0"/>
                 </a:solidFill>
                 <a:latin typeface="Calibri"/>
               </a:rPr>
-              <a:t>Solta com vibração → queda de rede da RASP</a:t>
-            </a:r>
-          </a:p>
-        </p:txBody>
-      </p:sp>
-      <p:sp>
-        <p:nvSpPr>
-          <p:cNvPr id="12" name="Rounded Rectangle 11"/>
+              <a:t>Padronização e prevenção
+de IP duplicado</a:t>
+            </a:r>
+          </a:p>
+        </p:txBody>
+      </p:sp>
+      <p:sp>
+        <p:nvSpPr>
+          <p:cNvPr id="11" name="Rounded Rectangle 10"/>
           <p:cNvSpPr/>
           <p:nvPr/>
         </p:nvSpPr>
         <p:spPr>
           <a:xfrm>
-            <a:off x="6309360" y="1554480"/>
-            <a:ext cx="5577840" cy="2011680"/>
-          </a:xfrm>
-          <a:prstGeom prst="roundRect">
-            <a:avLst/>
-          </a:prstGeom>
-          <a:solidFill>
-            <a:srgbClr val="FFFFFF"/>
-          </a:solidFill>
-          <a:ln>
-            <a:noFill/>
-          </a:ln>
-        </p:spPr>
-        <p:style>
-          <a:lnRef idx="1">
-            <a:schemeClr val="accent1"/>
-          </a:lnRef>
-          <a:fillRef idx="3">
-            <a:schemeClr val="accent1"/>
-          </a:fillRef>
-          <a:effectRef idx="2">
-            <a:schemeClr val="accent1"/>
-          </a:effectRef>
-          <a:fontRef idx="minor">
-            <a:schemeClr val="lt1"/>
-          </a:fontRef>
-        </p:style>
-        <p:txBody>
-          <a:bodyPr rtlCol="0" anchor="ctr"/>
-          <a:lstStyle/>
-          <a:p>
-            <a:pPr algn="ctr"/>
-          </a:p>
-        </p:txBody>
-      </p:sp>
-      <p:sp>
-        <p:nvSpPr>
-          <p:cNvPr id="13" name="Rounded Rectangle 12"/>
-          <p:cNvSpPr/>
-          <p:nvPr/>
-        </p:nvSpPr>
-        <p:spPr>
-          <a:xfrm>
-            <a:off x="6537960" y="1874520"/>
-            <a:ext cx="1188720" cy="411480"/>
+            <a:off x="4389120" y="2103120"/>
+            <a:ext cx="3611880" cy="3200400"/>
           </a:xfrm>
           <a:prstGeom prst="roundRect">
             <a:avLst/>
@@ -6015,14 +5928,14 @@
       </p:sp>
       <p:sp>
         <p:nvSpPr>
-          <p:cNvPr id="14" name="TextBox 13"/>
+          <p:cNvPr id="12" name="TextBox 11"/>
           <p:cNvSpPr txBox="1"/>
           <p:nvPr/>
         </p:nvSpPr>
         <p:spPr>
           <a:xfrm>
-            <a:off x="6537960" y="1901952"/>
-            <a:ext cx="1188720" cy="365760"/>
+            <a:off x="4663440" y="2377440"/>
+            <a:ext cx="3017520" cy="365760"/>
           </a:xfrm>
           <a:prstGeom prst="rect">
             <a:avLst/>
@@ -6035,29 +5948,29 @@
           </a:bodyPr>
           <a:lstStyle/>
           <a:p>
-            <a:pPr algn="ctr"/>
-            <a:r>
-              <a:rPr sz="1200" b="1">
-                <a:solidFill>
-                  <a:srgbClr val="FFFFFF"/>
+            <a:pPr algn="l"/>
+            <a:r>
+              <a:rPr sz="1400" b="1">
+                <a:solidFill>
+                  <a:srgbClr val="9BC9E0"/>
                 </a:solidFill>
                 <a:latin typeface="Calibri"/>
               </a:rPr>
-              <a:t>EV 02</a:t>
-            </a:r>
-          </a:p>
-        </p:txBody>
-      </p:sp>
-      <p:sp>
-        <p:nvSpPr>
-          <p:cNvPr id="15" name="TextBox 14"/>
+              <a:t>02</a:t>
+            </a:r>
+          </a:p>
+        </p:txBody>
+      </p:sp>
+      <p:sp>
+        <p:nvSpPr>
+          <p:cNvPr id="13" name="TextBox 12"/>
           <p:cNvSpPr txBox="1"/>
           <p:nvPr/>
         </p:nvSpPr>
         <p:spPr>
           <a:xfrm>
-            <a:off x="7955280" y="1874520"/>
-            <a:ext cx="3657600" cy="411480"/>
+            <a:off x="4663440" y="2926080"/>
+            <a:ext cx="3017520" cy="548640"/>
           </a:xfrm>
           <a:prstGeom prst="rect">
             <a:avLst/>
@@ -6072,27 +5985,27 @@
           <a:p>
             <a:pPr algn="l"/>
             <a:r>
-              <a:rPr sz="2000" b="1">
-                <a:solidFill>
-                  <a:srgbClr val="0F2C59"/>
+              <a:rPr sz="2600" b="1">
+                <a:solidFill>
+                  <a:srgbClr val="FFFFFF"/>
                 </a:solidFill>
                 <a:latin typeface="Calibri"/>
               </a:rPr>
-              <a:t>RJ45 oxidado</a:t>
-            </a:r>
-          </a:p>
-        </p:txBody>
-      </p:sp>
-      <p:sp>
-        <p:nvSpPr>
-          <p:cNvPr id="16" name="TextBox 15"/>
+              <a:t>Filebeat</a:t>
+            </a:r>
+          </a:p>
+        </p:txBody>
+      </p:sp>
+      <p:sp>
+        <p:nvSpPr>
+          <p:cNvPr id="14" name="TextBox 13"/>
           <p:cNvSpPr txBox="1"/>
           <p:nvPr/>
         </p:nvSpPr>
         <p:spPr>
           <a:xfrm>
-            <a:off x="6629400" y="2560320"/>
-            <a:ext cx="5029200" cy="731520"/>
+            <a:off x="4663440" y="3749039"/>
+            <a:ext cx="3017520" cy="1097280"/>
           </a:xfrm>
           <a:prstGeom prst="rect">
             <a:avLst/>
@@ -6107,70 +6020,28 @@
           <a:p>
             <a:pPr algn="l"/>
             <a:r>
-              <a:rPr sz="1500" b="0">
-                <a:solidFill>
-                  <a:srgbClr val="4A4A4A"/>
+              <a:rPr sz="1600" b="0">
+                <a:solidFill>
+                  <a:srgbClr val="D6E3F0"/>
                 </a:solidFill>
                 <a:latin typeface="Calibri"/>
               </a:rPr>
-              <a:t>Contato ruim → instabilidade e lentidão</a:t>
-            </a:r>
-          </a:p>
-        </p:txBody>
-      </p:sp>
-      <p:sp>
-        <p:nvSpPr>
-          <p:cNvPr id="17" name="Rounded Rectangle 16"/>
+              <a:t>Coleta/envio de logs
+e boas práticas</a:t>
+            </a:r>
+          </a:p>
+        </p:txBody>
+      </p:sp>
+      <p:sp>
+        <p:nvSpPr>
+          <p:cNvPr id="15" name="Rounded Rectangle 14"/>
           <p:cNvSpPr/>
           <p:nvPr/>
         </p:nvSpPr>
         <p:spPr>
           <a:xfrm>
-            <a:off x="457200" y="3794760"/>
-            <a:ext cx="5577840" cy="2011680"/>
-          </a:xfrm>
-          <a:prstGeom prst="roundRect">
-            <a:avLst/>
-          </a:prstGeom>
-          <a:solidFill>
-            <a:srgbClr val="FFFFFF"/>
-          </a:solidFill>
-          <a:ln>
-            <a:noFill/>
-          </a:ln>
-        </p:spPr>
-        <p:style>
-          <a:lnRef idx="1">
-            <a:schemeClr val="accent1"/>
-          </a:lnRef>
-          <a:fillRef idx="3">
-            <a:schemeClr val="accent1"/>
-          </a:fillRef>
-          <a:effectRef idx="2">
-            <a:schemeClr val="accent1"/>
-          </a:effectRef>
-          <a:fontRef idx="minor">
-            <a:schemeClr val="lt1"/>
-          </a:fontRef>
-        </p:style>
-        <p:txBody>
-          <a:bodyPr rtlCol="0" anchor="ctr"/>
-          <a:lstStyle/>
-          <a:p>
-            <a:pPr algn="ctr"/>
-          </a:p>
-        </p:txBody>
-      </p:sp>
-      <p:sp>
-        <p:nvSpPr>
-          <p:cNvPr id="18" name="Rounded Rectangle 17"/>
-          <p:cNvSpPr/>
-          <p:nvPr/>
-        </p:nvSpPr>
-        <p:spPr>
-          <a:xfrm>
-            <a:off x="685800" y="4114800"/>
-            <a:ext cx="1188720" cy="411480"/>
+            <a:off x="8229600" y="2103120"/>
+            <a:ext cx="3611880" cy="3200400"/>
           </a:xfrm>
           <a:prstGeom prst="roundRect">
             <a:avLst/>
@@ -6206,14 +6077,14 @@
       </p:sp>
       <p:sp>
         <p:nvSpPr>
-          <p:cNvPr id="19" name="TextBox 18"/>
+          <p:cNvPr id="16" name="TextBox 15"/>
           <p:cNvSpPr txBox="1"/>
           <p:nvPr/>
         </p:nvSpPr>
         <p:spPr>
           <a:xfrm>
-            <a:off x="685800" y="4142232"/>
-            <a:ext cx="1188720" cy="365760"/>
+            <a:off x="8503920" y="2377440"/>
+            <a:ext cx="3017520" cy="365760"/>
           </a:xfrm>
           <a:prstGeom prst="rect">
             <a:avLst/>
@@ -6226,29 +6097,29 @@
           </a:bodyPr>
           <a:lstStyle/>
           <a:p>
-            <a:pPr algn="ctr"/>
-            <a:r>
-              <a:rPr sz="1200" b="1">
-                <a:solidFill>
-                  <a:srgbClr val="FFFFFF"/>
+            <a:pPr algn="l"/>
+            <a:r>
+              <a:rPr sz="1400" b="1">
+                <a:solidFill>
+                  <a:srgbClr val="9BC9E0"/>
                 </a:solidFill>
                 <a:latin typeface="Calibri"/>
               </a:rPr>
-              <a:t>EV 03</a:t>
-            </a:r>
-          </a:p>
-        </p:txBody>
-      </p:sp>
-      <p:sp>
-        <p:nvSpPr>
-          <p:cNvPr id="20" name="TextBox 19"/>
+              <a:t>03</a:t>
+            </a:r>
+          </a:p>
+        </p:txBody>
+      </p:sp>
+      <p:sp>
+        <p:nvSpPr>
+          <p:cNvPr id="17" name="TextBox 16"/>
           <p:cNvSpPr txBox="1"/>
           <p:nvPr/>
         </p:nvSpPr>
         <p:spPr>
           <a:xfrm>
-            <a:off x="2103120" y="4114800"/>
-            <a:ext cx="3657600" cy="411480"/>
+            <a:off x="8503920" y="2926080"/>
+            <a:ext cx="3017520" cy="548640"/>
           </a:xfrm>
           <a:prstGeom prst="rect">
             <a:avLst/>
@@ -6263,27 +6134,27 @@
           <a:p>
             <a:pPr algn="l"/>
             <a:r>
-              <a:rPr sz="2000" b="1">
-                <a:solidFill>
-                  <a:srgbClr val="0F2C59"/>
+              <a:rPr sz="2600" b="1">
+                <a:solidFill>
+                  <a:srgbClr val="FFFFFF"/>
                 </a:solidFill>
                 <a:latin typeface="Calibri"/>
               </a:rPr>
-              <a:t>Cabo Cat.5 / Cat.5e</a:t>
-            </a:r>
-          </a:p>
-        </p:txBody>
-      </p:sp>
-      <p:sp>
-        <p:nvSpPr>
-          <p:cNvPr id="21" name="TextBox 20"/>
+              <a:t>Checklist</a:t>
+            </a:r>
+          </a:p>
+        </p:txBody>
+      </p:sp>
+      <p:sp>
+        <p:nvSpPr>
+          <p:cNvPr id="18" name="TextBox 17"/>
           <p:cNvSpPr txBox="1"/>
           <p:nvPr/>
         </p:nvSpPr>
         <p:spPr>
           <a:xfrm>
-            <a:off x="777240" y="4800600"/>
-            <a:ext cx="5029200" cy="731520"/>
+            <a:off x="8503920" y="3749039"/>
+            <a:ext cx="3017520" cy="1097280"/>
           </a:xfrm>
           <a:prstGeom prst="rect">
             <a:avLst/>
@@ -6298,113 +6169,28 @@
           <a:p>
             <a:pPr algn="l"/>
             <a:r>
-              <a:rPr sz="1500" b="0">
-                <a:solidFill>
-                  <a:srgbClr val="4A4A4A"/>
+              <a:rPr sz="1600" b="0">
+                <a:solidFill>
+                  <a:srgbClr val="D6E3F0"/>
                 </a:solidFill>
                 <a:latin typeface="Calibri"/>
               </a:rPr>
-              <a:t>Padrão abaixo do desejável na linha</a:t>
-            </a:r>
-          </a:p>
-        </p:txBody>
-      </p:sp>
-      <p:sp>
-        <p:nvSpPr>
-          <p:cNvPr id="22" name="Rounded Rectangle 21"/>
-          <p:cNvSpPr/>
-          <p:nvPr/>
-        </p:nvSpPr>
-        <p:spPr>
-          <a:xfrm>
-            <a:off x="6309360" y="3794760"/>
-            <a:ext cx="5577840" cy="2011680"/>
-          </a:xfrm>
-          <a:prstGeom prst="roundRect">
-            <a:avLst/>
-          </a:prstGeom>
-          <a:solidFill>
-            <a:srgbClr val="FFFFFF"/>
-          </a:solidFill>
-          <a:ln>
-            <a:noFill/>
-          </a:ln>
-        </p:spPr>
-        <p:style>
-          <a:lnRef idx="1">
-            <a:schemeClr val="accent1"/>
-          </a:lnRef>
-          <a:fillRef idx="3">
-            <a:schemeClr val="accent1"/>
-          </a:fillRef>
-          <a:effectRef idx="2">
-            <a:schemeClr val="accent1"/>
-          </a:effectRef>
-          <a:fontRef idx="minor">
-            <a:schemeClr val="lt1"/>
-          </a:fontRef>
-        </p:style>
-        <p:txBody>
-          <a:bodyPr rtlCol="0" anchor="ctr"/>
-          <a:lstStyle/>
-          <a:p>
-            <a:pPr algn="ctr"/>
-          </a:p>
-        </p:txBody>
-      </p:sp>
-      <p:sp>
-        <p:nvSpPr>
-          <p:cNvPr id="23" name="Rounded Rectangle 22"/>
-          <p:cNvSpPr/>
-          <p:nvPr/>
-        </p:nvSpPr>
-        <p:spPr>
-          <a:xfrm>
-            <a:off x="6537960" y="4114800"/>
-            <a:ext cx="1188720" cy="411480"/>
-          </a:xfrm>
-          <a:prstGeom prst="roundRect">
-            <a:avLst/>
-          </a:prstGeom>
-          <a:solidFill>
-            <a:srgbClr val="0F2C59"/>
-          </a:solidFill>
-          <a:ln>
-            <a:noFill/>
-          </a:ln>
-        </p:spPr>
-        <p:style>
-          <a:lnRef idx="1">
-            <a:schemeClr val="accent1"/>
-          </a:lnRef>
-          <a:fillRef idx="3">
-            <a:schemeClr val="accent1"/>
-          </a:fillRef>
-          <a:effectRef idx="2">
-            <a:schemeClr val="accent1"/>
-          </a:effectRef>
-          <a:fontRef idx="minor">
-            <a:schemeClr val="lt1"/>
-          </a:fontRef>
-        </p:style>
-        <p:txBody>
-          <a:bodyPr rtlCol="0" anchor="ctr"/>
-          <a:lstStyle/>
-          <a:p>
-            <a:pPr algn="ctr"/>
-          </a:p>
-        </p:txBody>
-      </p:sp>
-      <p:sp>
-        <p:nvSpPr>
-          <p:cNvPr id="24" name="TextBox 23"/>
+              <a:t>Antes de classificar como
+“falha de TI”</a:t>
+            </a:r>
+          </a:p>
+        </p:txBody>
+      </p:sp>
+      <p:sp>
+        <p:nvSpPr>
+          <p:cNvPr id="19" name="TextBox 18"/>
           <p:cNvSpPr txBox="1"/>
           <p:nvPr/>
         </p:nvSpPr>
         <p:spPr>
           <a:xfrm>
-            <a:off x="6537960" y="4142232"/>
-            <a:ext cx="1188720" cy="365760"/>
+            <a:off x="457200" y="6446520"/>
+            <a:ext cx="9144000" cy="274320"/>
           </a:xfrm>
           <a:prstGeom prst="rect">
             <a:avLst/>
@@ -6417,29 +6203,29 @@
           </a:bodyPr>
           <a:lstStyle/>
           <a:p>
-            <a:pPr algn="ctr"/>
-            <a:r>
-              <a:rPr sz="1200" b="1">
-                <a:solidFill>
-                  <a:srgbClr val="FFFFFF"/>
+            <a:pPr algn="l"/>
+            <a:r>
+              <a:rPr sz="1100" b="0">
+                <a:solidFill>
+                  <a:srgbClr val="8A8A8A"/>
                 </a:solidFill>
                 <a:latin typeface="Calibri"/>
               </a:rPr>
-              <a:t>EV 04</a:t>
-            </a:r>
-          </a:p>
-        </p:txBody>
-      </p:sp>
-      <p:sp>
-        <p:nvSpPr>
-          <p:cNvPr id="25" name="TextBox 24"/>
+              <a:t>TI  ·  Área Técnica  ·  Engenharia</a:t>
+            </a:r>
+          </a:p>
+        </p:txBody>
+      </p:sp>
+      <p:sp>
+        <p:nvSpPr>
+          <p:cNvPr id="20" name="TextBox 19"/>
           <p:cNvSpPr txBox="1"/>
           <p:nvPr/>
         </p:nvSpPr>
         <p:spPr>
           <a:xfrm>
-            <a:off x="7955280" y="4114800"/>
-            <a:ext cx="3657600" cy="411480"/>
+            <a:off x="10515600" y="6446520"/>
+            <a:ext cx="1280160" cy="274320"/>
           </a:xfrm>
           <a:prstGeom prst="rect">
             <a:avLst/>
@@ -6452,120 +6238,15 @@
           </a:bodyPr>
           <a:lstStyle/>
           <a:p>
-            <a:pPr algn="l"/>
-            <a:r>
-              <a:rPr sz="2000" b="1">
-                <a:solidFill>
-                  <a:srgbClr val="0F2C59"/>
+            <a:pPr algn="r"/>
+            <a:r>
+              <a:rPr sz="1100" b="0">
+                <a:solidFill>
+                  <a:srgbClr val="8A8A8A"/>
                 </a:solidFill>
                 <a:latin typeface="Calibri"/>
               </a:rPr>
-              <a:t>RASP pendurada</a:t>
-            </a:r>
-          </a:p>
-        </p:txBody>
-      </p:sp>
-      <p:sp>
-        <p:nvSpPr>
-          <p:cNvPr id="26" name="TextBox 25"/>
-          <p:cNvSpPr txBox="1"/>
-          <p:nvPr/>
-        </p:nvSpPr>
-        <p:spPr>
-          <a:xfrm>
-            <a:off x="6629400" y="4800600"/>
-            <a:ext cx="5029200" cy="731520"/>
-          </a:xfrm>
-          <a:prstGeom prst="rect">
-            <a:avLst/>
-          </a:prstGeom>
-          <a:noFill/>
-        </p:spPr>
-        <p:txBody>
-          <a:bodyPr wrap="square">
-            <a:spAutoFit/>
-          </a:bodyPr>
-          <a:lstStyle/>
-          <a:p>
-            <a:pPr algn="l"/>
-            <a:r>
-              <a:rPr sz="1500" b="0">
-                <a:solidFill>
-                  <a:srgbClr val="4A4A4A"/>
-                </a:solidFill>
-                <a:latin typeface="Calibri"/>
-              </a:rPr>
-              <a:t>Falta de disciplina de instalação</a:t>
-            </a:r>
-          </a:p>
-        </p:txBody>
-      </p:sp>
-      <p:sp>
-        <p:nvSpPr>
-          <p:cNvPr id="27" name="TextBox 26"/>
-          <p:cNvSpPr txBox="1"/>
-          <p:nvPr/>
-        </p:nvSpPr>
-        <p:spPr>
-          <a:xfrm>
-            <a:off x="457200" y="6446520"/>
-            <a:ext cx="9144000" cy="274320"/>
-          </a:xfrm>
-          <a:prstGeom prst="rect">
-            <a:avLst/>
-          </a:prstGeom>
-          <a:noFill/>
-        </p:spPr>
-        <p:txBody>
-          <a:bodyPr wrap="square">
-            <a:spAutoFit/>
-          </a:bodyPr>
-          <a:lstStyle/>
-          <a:p>
-            <a:pPr algn="l"/>
-            <a:r>
-              <a:rPr sz="1100" b="0">
-                <a:solidFill>
-                  <a:srgbClr val="8A8A8A"/>
-                </a:solidFill>
-                <a:latin typeface="Calibri"/>
-              </a:rPr>
-              <a:t>TI  ·  Área Técnica  ·  Engenharia</a:t>
-            </a:r>
-          </a:p>
-        </p:txBody>
-      </p:sp>
-      <p:sp>
-        <p:nvSpPr>
-          <p:cNvPr id="28" name="TextBox 27"/>
-          <p:cNvSpPr txBox="1"/>
-          <p:nvPr/>
-        </p:nvSpPr>
-        <p:spPr>
-          <a:xfrm>
-            <a:off x="10515600" y="6446520"/>
-            <a:ext cx="1280160" cy="274320"/>
-          </a:xfrm>
-          <a:prstGeom prst="rect">
-            <a:avLst/>
-          </a:prstGeom>
-          <a:noFill/>
-        </p:spPr>
-        <p:txBody>
-          <a:bodyPr wrap="square">
-            <a:spAutoFit/>
-          </a:bodyPr>
-          <a:lstStyle/>
-          <a:p>
-            <a:pPr algn="r"/>
-            <a:r>
-              <a:rPr sz="1100" b="0">
-                <a:solidFill>
-                  <a:srgbClr val="8A8A8A"/>
-                </a:solidFill>
-                <a:latin typeface="Calibri"/>
-              </a:rPr>
-              <a:t>4/8</a:t>
+              <a:t>4/6</a:t>
             </a:r>
           </a:p>
         </p:txBody>
@@ -6747,21 +6428,64 @@
                 </a:solidFill>
                 <a:latin typeface="Calibri"/>
               </a:rPr>
-              <a:t>Evidências — configuração e desempenho</a:t>
-            </a:r>
-          </a:p>
-        </p:txBody>
-      </p:sp>
-      <p:sp>
-        <p:nvSpPr>
-          <p:cNvPr id="6" name="TextBox 5"/>
+              <a:t>Plano de ação resumido</a:t>
+            </a:r>
+          </a:p>
+        </p:txBody>
+      </p:sp>
+      <p:sp>
+        <p:nvSpPr>
+          <p:cNvPr id="6" name="Rectangle 5"/>
+          <p:cNvSpPr/>
+          <p:nvPr/>
+        </p:nvSpPr>
+        <p:spPr>
+          <a:xfrm>
+            <a:off x="457200" y="1417320"/>
+            <a:ext cx="11247120" cy="502920"/>
+          </a:xfrm>
+          <a:prstGeom prst="rect">
+            <a:avLst/>
+          </a:prstGeom>
+          <a:solidFill>
+            <a:srgbClr val="0F2C59"/>
+          </a:solidFill>
+          <a:ln>
+            <a:noFill/>
+          </a:ln>
+        </p:spPr>
+        <p:style>
+          <a:lnRef idx="1">
+            <a:schemeClr val="accent1"/>
+          </a:lnRef>
+          <a:fillRef idx="3">
+            <a:schemeClr val="accent1"/>
+          </a:fillRef>
+          <a:effectRef idx="2">
+            <a:schemeClr val="accent1"/>
+          </a:effectRef>
+          <a:fontRef idx="minor">
+            <a:schemeClr val="lt1"/>
+          </a:fontRef>
+        </p:style>
+        <p:txBody>
+          <a:bodyPr rtlCol="0" anchor="ctr"/>
+          <a:lstStyle/>
+          <a:p>
+            <a:pPr algn="ctr"/>
+          </a:p>
+        </p:txBody>
+      </p:sp>
+      <p:sp>
+        <p:nvSpPr>
+          <p:cNvPr id="7" name="TextBox 6"/>
           <p:cNvSpPr txBox="1"/>
           <p:nvPr/>
         </p:nvSpPr>
         <p:spPr>
           <a:xfrm>
-            <a:off x="457200" y="1143000"/>
-            <a:ext cx="10972800" cy="365760"/>
+            <a:off x="640080" y="1508760"/>
+            <a:ext cx="1188720" cy="365760"/>
           </a:xfrm>
           <a:prstGeom prst="rect">
             <a:avLst/>
@@ -6776,29 +6500,99 @@
           <a:p>
             <a:pPr algn="l"/>
             <a:r>
-              <a:rPr sz="1400" b="0">
-                <a:solidFill>
-                  <a:srgbClr val="1B6B93"/>
+              <a:rPr sz="1400" b="1">
+                <a:solidFill>
+                  <a:srgbClr val="FFFFFF"/>
                 </a:solidFill>
                 <a:latin typeface="Calibri"/>
               </a:rPr>
-              <a:t>Roteiro errado e RASP com CPU saturada</a:t>
-            </a:r>
-          </a:p>
-        </p:txBody>
-      </p:sp>
-      <p:sp>
-        <p:nvSpPr>
-          <p:cNvPr id="7" name="Rounded Rectangle 6"/>
+              <a:t>ID</a:t>
+            </a:r>
+          </a:p>
+        </p:txBody>
+      </p:sp>
+      <p:sp>
+        <p:nvSpPr>
+          <p:cNvPr id="8" name="TextBox 7"/>
+          <p:cNvSpPr txBox="1"/>
+          <p:nvPr/>
+        </p:nvSpPr>
+        <p:spPr>
+          <a:xfrm>
+            <a:off x="2011680" y="1508760"/>
+            <a:ext cx="5943600" cy="365760"/>
+          </a:xfrm>
+          <a:prstGeom prst="rect">
+            <a:avLst/>
+          </a:prstGeom>
+          <a:noFill/>
+        </p:spPr>
+        <p:txBody>
+          <a:bodyPr wrap="square">
+            <a:spAutoFit/>
+          </a:bodyPr>
+          <a:lstStyle/>
+          <a:p>
+            <a:pPr algn="l"/>
+            <a:r>
+              <a:rPr sz="1400" b="1">
+                <a:solidFill>
+                  <a:srgbClr val="FFFFFF"/>
+                </a:solidFill>
+                <a:latin typeface="Calibri"/>
+              </a:rPr>
+              <a:t>Ação</a:t>
+            </a:r>
+          </a:p>
+        </p:txBody>
+      </p:sp>
+      <p:sp>
+        <p:nvSpPr>
+          <p:cNvPr id="9" name="TextBox 8"/>
+          <p:cNvSpPr txBox="1"/>
+          <p:nvPr/>
+        </p:nvSpPr>
+        <p:spPr>
+          <a:xfrm>
+            <a:off x="8046720" y="1508760"/>
+            <a:ext cx="3383280" cy="365760"/>
+          </a:xfrm>
+          <a:prstGeom prst="rect">
+            <a:avLst/>
+          </a:prstGeom>
+          <a:noFill/>
+        </p:spPr>
+        <p:txBody>
+          <a:bodyPr wrap="square">
+            <a:spAutoFit/>
+          </a:bodyPr>
+          <a:lstStyle/>
+          <a:p>
+            <a:pPr algn="l"/>
+            <a:r>
+              <a:rPr sz="1400" b="1">
+                <a:solidFill>
+                  <a:srgbClr val="FFFFFF"/>
+                </a:solidFill>
+                <a:latin typeface="Calibri"/>
+              </a:rPr>
+              <a:t>Dono</a:t>
+            </a:r>
+          </a:p>
+        </p:txBody>
+      </p:sp>
+      <p:sp>
+        <p:nvSpPr>
+          <p:cNvPr id="10" name="Rectangle 9"/>
           <p:cNvSpPr/>
           <p:nvPr/>
         </p:nvSpPr>
         <p:spPr>
           <a:xfrm>
-            <a:off x="457200" y="1554480"/>
-            <a:ext cx="5577840" cy="4297680"/>
-          </a:xfrm>
-          <a:prstGeom prst="roundRect">
+            <a:off x="457200" y="1965960"/>
+            <a:ext cx="11247120" cy="640080"/>
+          </a:xfrm>
+          <a:prstGeom prst="rect">
             <a:avLst/>
           </a:prstGeom>
           <a:solidFill>
@@ -6832,20 +6626,125 @@
       </p:sp>
       <p:sp>
         <p:nvSpPr>
-          <p:cNvPr id="8" name="Rectangle 7"/>
+          <p:cNvPr id="11" name="TextBox 10"/>
+          <p:cNvSpPr txBox="1"/>
+          <p:nvPr/>
+        </p:nvSpPr>
+        <p:spPr>
+          <a:xfrm>
+            <a:off x="640080" y="2130552"/>
+            <a:ext cx="1188720" cy="365760"/>
+          </a:xfrm>
+          <a:prstGeom prst="rect">
+            <a:avLst/>
+          </a:prstGeom>
+          <a:noFill/>
+        </p:spPr>
+        <p:txBody>
+          <a:bodyPr wrap="square">
+            <a:spAutoFit/>
+          </a:bodyPr>
+          <a:lstStyle/>
+          <a:p>
+            <a:pPr algn="l"/>
+            <a:r>
+              <a:rPr sz="1400" b="1">
+                <a:solidFill>
+                  <a:srgbClr val="1B6B93"/>
+                </a:solidFill>
+                <a:latin typeface="Calibri"/>
+              </a:rPr>
+              <a:t>PA-01</a:t>
+            </a:r>
+          </a:p>
+        </p:txBody>
+      </p:sp>
+      <p:sp>
+        <p:nvSpPr>
+          <p:cNvPr id="12" name="TextBox 11"/>
+          <p:cNvSpPr txBox="1"/>
+          <p:nvPr/>
+        </p:nvSpPr>
+        <p:spPr>
+          <a:xfrm>
+            <a:off x="2011680" y="2130552"/>
+            <a:ext cx="5943600" cy="365760"/>
+          </a:xfrm>
+          <a:prstGeom prst="rect">
+            <a:avLst/>
+          </a:prstGeom>
+          <a:noFill/>
+        </p:spPr>
+        <p:txBody>
+          <a:bodyPr wrap="square">
+            <a:spAutoFit/>
+          </a:bodyPr>
+          <a:lstStyle/>
+          <a:p>
+            <a:pPr algn="l"/>
+            <a:r>
+              <a:rPr sz="1400" b="0">
+                <a:solidFill>
+                  <a:srgbClr val="1F1F1F"/>
+                </a:solidFill>
+                <a:latin typeface="Calibri"/>
+              </a:rPr>
+              <a:t>Padronizar/substituir cabos e conectores</a:t>
+            </a:r>
+          </a:p>
+        </p:txBody>
+      </p:sp>
+      <p:sp>
+        <p:nvSpPr>
+          <p:cNvPr id="13" name="TextBox 12"/>
+          <p:cNvSpPr txBox="1"/>
+          <p:nvPr/>
+        </p:nvSpPr>
+        <p:spPr>
+          <a:xfrm>
+            <a:off x="8046720" y="2130552"/>
+            <a:ext cx="3383280" cy="365760"/>
+          </a:xfrm>
+          <a:prstGeom prst="rect">
+            <a:avLst/>
+          </a:prstGeom>
+          <a:noFill/>
+        </p:spPr>
+        <p:txBody>
+          <a:bodyPr wrap="square">
+            <a:spAutoFit/>
+          </a:bodyPr>
+          <a:lstStyle/>
+          <a:p>
+            <a:pPr algn="l"/>
+            <a:r>
+              <a:rPr sz="1300" b="0">
+                <a:solidFill>
+                  <a:srgbClr val="4A4A4A"/>
+                </a:solidFill>
+                <a:latin typeface="Calibri"/>
+              </a:rPr>
+              <a:t>Área Técnica / Engenharia</a:t>
+            </a:r>
+          </a:p>
+        </p:txBody>
+      </p:sp>
+      <p:sp>
+        <p:nvSpPr>
+          <p:cNvPr id="14" name="Rectangle 13"/>
           <p:cNvSpPr/>
           <p:nvPr/>
         </p:nvSpPr>
         <p:spPr>
           <a:xfrm>
-            <a:off x="457200" y="1554480"/>
-            <a:ext cx="5577840" cy="640080"/>
+            <a:off x="457200" y="2606039"/>
+            <a:ext cx="11247120" cy="640080"/>
           </a:xfrm>
           <a:prstGeom prst="rect">
             <a:avLst/>
           </a:prstGeom>
           <a:solidFill>
-            <a:srgbClr val="0F2C59"/>
+            <a:srgbClr val="E8EEF5"/>
           </a:solidFill>
           <a:ln>
             <a:noFill/>
@@ -6875,14 +6774,14 @@
       </p:sp>
       <p:sp>
         <p:nvSpPr>
-          <p:cNvPr id="9" name="TextBox 8"/>
+          <p:cNvPr id="15" name="TextBox 14"/>
           <p:cNvSpPr txBox="1"/>
           <p:nvPr/>
         </p:nvSpPr>
         <p:spPr>
           <a:xfrm>
-            <a:off x="640080" y="1691640"/>
-            <a:ext cx="5212080" cy="411480"/>
+            <a:off x="640080" y="2770631"/>
+            <a:ext cx="1188720" cy="365760"/>
           </a:xfrm>
           <a:prstGeom prst="rect">
             <a:avLst/>
@@ -6897,27 +6796,27 @@
           <a:p>
             <a:pPr algn="l"/>
             <a:r>
-              <a:rPr sz="1800" b="1">
-                <a:solidFill>
-                  <a:srgbClr val="FFFFFF"/>
+              <a:rPr sz="1400" b="1">
+                <a:solidFill>
+                  <a:srgbClr val="1B6B93"/>
                 </a:solidFill>
                 <a:latin typeface="Calibri"/>
               </a:rPr>
-              <a:t>Configuração de processo</a:t>
-            </a:r>
-          </a:p>
-        </p:txBody>
-      </p:sp>
-      <p:sp>
-        <p:nvSpPr>
-          <p:cNvPr id="10" name="TextBox 9"/>
+              <a:t>PA-02</a:t>
+            </a:r>
+          </a:p>
+        </p:txBody>
+      </p:sp>
+      <p:sp>
+        <p:nvSpPr>
+          <p:cNvPr id="16" name="TextBox 15"/>
           <p:cNvSpPr txBox="1"/>
           <p:nvPr/>
         </p:nvSpPr>
         <p:spPr>
           <a:xfrm>
-            <a:off x="731520" y="2468880"/>
-            <a:ext cx="5029200" cy="3017520"/>
+            <a:off x="2011680" y="2770631"/>
+            <a:ext cx="5943600" cy="365760"/>
           </a:xfrm>
           <a:prstGeom prst="rect">
             <a:avLst/>
@@ -6932,33 +6831,64 @@
           <a:p>
             <a:pPr algn="l"/>
             <a:r>
-              <a:rPr sz="1600" b="0">
-                <a:solidFill>
-                  <a:srgbClr val="4A4A4A"/>
+              <a:rPr sz="1400" b="0">
+                <a:solidFill>
+                  <a:srgbClr val="1F1F1F"/>
                 </a:solidFill>
                 <a:latin typeface="Calibri"/>
               </a:rPr>
-              <a:t>EV 05 — Modelo divergente no roteiro
-Bases coletam, mas modelo ≠ placas da linha.
-EV 06 — FAIL recorrente
-Serial não pertence ao produto cadastrado.
-Dono: Engenharia / Área Técnica</a:t>
-            </a:r>
-          </a:p>
-        </p:txBody>
-      </p:sp>
-      <p:sp>
-        <p:nvSpPr>
-          <p:cNvPr id="11" name="Rounded Rectangle 10"/>
+              <a:t>Eliminar IPs duplicados e oficializar endereçamento</a:t>
+            </a:r>
+          </a:p>
+        </p:txBody>
+      </p:sp>
+      <p:sp>
+        <p:nvSpPr>
+          <p:cNvPr id="17" name="TextBox 16"/>
+          <p:cNvSpPr txBox="1"/>
+          <p:nvPr/>
+        </p:nvSpPr>
+        <p:spPr>
+          <a:xfrm>
+            <a:off x="8046720" y="2770631"/>
+            <a:ext cx="3383280" cy="365760"/>
+          </a:xfrm>
+          <a:prstGeom prst="rect">
+            <a:avLst/>
+          </a:prstGeom>
+          <a:noFill/>
+        </p:spPr>
+        <p:txBody>
+          <a:bodyPr wrap="square">
+            <a:spAutoFit/>
+          </a:bodyPr>
+          <a:lstStyle/>
+          <a:p>
+            <a:pPr algn="l"/>
+            <a:r>
+              <a:rPr sz="1300" b="0">
+                <a:solidFill>
+                  <a:srgbClr val="4A4A4A"/>
+                </a:solidFill>
+                <a:latin typeface="Calibri"/>
+              </a:rPr>
+              <a:t>Área Técnica / Engenharia</a:t>
+            </a:r>
+          </a:p>
+        </p:txBody>
+      </p:sp>
+      <p:sp>
+        <p:nvSpPr>
+          <p:cNvPr id="18" name="Rectangle 17"/>
           <p:cNvSpPr/>
           <p:nvPr/>
         </p:nvSpPr>
         <p:spPr>
           <a:xfrm>
-            <a:off x="6263640" y="1554480"/>
-            <a:ext cx="5486400" cy="4297680"/>
-          </a:xfrm>
-          <a:prstGeom prst="roundRect">
+            <a:off x="457200" y="3246120"/>
+            <a:ext cx="11247120" cy="640080"/>
+          </a:xfrm>
+          <a:prstGeom prst="rect">
             <a:avLst/>
           </a:prstGeom>
           <a:solidFill>
@@ -6992,20 +6922,125 @@
       </p:sp>
       <p:sp>
         <p:nvSpPr>
-          <p:cNvPr id="12" name="Rectangle 11"/>
+          <p:cNvPr id="19" name="TextBox 18"/>
+          <p:cNvSpPr txBox="1"/>
+          <p:nvPr/>
+        </p:nvSpPr>
+        <p:spPr>
+          <a:xfrm>
+            <a:off x="640080" y="3410712"/>
+            <a:ext cx="1188720" cy="365760"/>
+          </a:xfrm>
+          <a:prstGeom prst="rect">
+            <a:avLst/>
+          </a:prstGeom>
+          <a:noFill/>
+        </p:spPr>
+        <p:txBody>
+          <a:bodyPr wrap="square">
+            <a:spAutoFit/>
+          </a:bodyPr>
+          <a:lstStyle/>
+          <a:p>
+            <a:pPr algn="l"/>
+            <a:r>
+              <a:rPr sz="1400" b="1">
+                <a:solidFill>
+                  <a:srgbClr val="1B6B93"/>
+                </a:solidFill>
+                <a:latin typeface="Calibri"/>
+              </a:rPr>
+              <a:t>PA-03</a:t>
+            </a:r>
+          </a:p>
+        </p:txBody>
+      </p:sp>
+      <p:sp>
+        <p:nvSpPr>
+          <p:cNvPr id="20" name="TextBox 19"/>
+          <p:cNvSpPr txBox="1"/>
+          <p:nvPr/>
+        </p:nvSpPr>
+        <p:spPr>
+          <a:xfrm>
+            <a:off x="2011680" y="3410712"/>
+            <a:ext cx="5943600" cy="365760"/>
+          </a:xfrm>
+          <a:prstGeom prst="rect">
+            <a:avLst/>
+          </a:prstGeom>
+          <a:noFill/>
+        </p:spPr>
+        <p:txBody>
+          <a:bodyPr wrap="square">
+            <a:spAutoFit/>
+          </a:bodyPr>
+          <a:lstStyle/>
+          <a:p>
+            <a:pPr algn="l"/>
+            <a:r>
+              <a:rPr sz="1400" b="0">
+                <a:solidFill>
+                  <a:srgbClr val="1F1F1F"/>
+                </a:solidFill>
+                <a:latin typeface="Calibri"/>
+              </a:rPr>
+              <a:t>Controle de liberação de roteiro</a:t>
+            </a:r>
+          </a:p>
+        </p:txBody>
+      </p:sp>
+      <p:sp>
+        <p:nvSpPr>
+          <p:cNvPr id="21" name="TextBox 20"/>
+          <p:cNvSpPr txBox="1"/>
+          <p:nvPr/>
+        </p:nvSpPr>
+        <p:spPr>
+          <a:xfrm>
+            <a:off x="8046720" y="3410712"/>
+            <a:ext cx="3383280" cy="365760"/>
+          </a:xfrm>
+          <a:prstGeom prst="rect">
+            <a:avLst/>
+          </a:prstGeom>
+          <a:noFill/>
+        </p:spPr>
+        <p:txBody>
+          <a:bodyPr wrap="square">
+            <a:spAutoFit/>
+          </a:bodyPr>
+          <a:lstStyle/>
+          <a:p>
+            <a:pPr algn="l"/>
+            <a:r>
+              <a:rPr sz="1300" b="0">
+                <a:solidFill>
+                  <a:srgbClr val="4A4A4A"/>
+                </a:solidFill>
+                <a:latin typeface="Calibri"/>
+              </a:rPr>
+              <a:t>Engenharia / Área Técnica</a:t>
+            </a:r>
+          </a:p>
+        </p:txBody>
+      </p:sp>
+      <p:sp>
+        <p:nvSpPr>
+          <p:cNvPr id="22" name="Rectangle 21"/>
           <p:cNvSpPr/>
           <p:nvPr/>
         </p:nvSpPr>
         <p:spPr>
           <a:xfrm>
-            <a:off x="6263640" y="1554480"/>
-            <a:ext cx="5486400" cy="640080"/>
+            <a:off x="457200" y="3886200"/>
+            <a:ext cx="11247120" cy="640080"/>
           </a:xfrm>
           <a:prstGeom prst="rect">
             <a:avLst/>
           </a:prstGeom>
           <a:solidFill>
-            <a:srgbClr val="1B6B93"/>
+            <a:srgbClr val="E8EEF5"/>
           </a:solidFill>
           <a:ln>
             <a:noFill/>
@@ -7035,14 +7070,14 @@
       </p:sp>
       <p:sp>
         <p:nvSpPr>
-          <p:cNvPr id="13" name="TextBox 12"/>
+          <p:cNvPr id="23" name="TextBox 22"/>
           <p:cNvSpPr txBox="1"/>
           <p:nvPr/>
         </p:nvSpPr>
         <p:spPr>
           <a:xfrm>
-            <a:off x="6446520" y="1691640"/>
-            <a:ext cx="5120640" cy="411480"/>
+            <a:off x="640080" y="4050792"/>
+            <a:ext cx="1188720" cy="365760"/>
           </a:xfrm>
           <a:prstGeom prst="rect">
             <a:avLst/>
@@ -7057,27 +7092,27 @@
           <a:p>
             <a:pPr algn="l"/>
             <a:r>
-              <a:rPr sz="1800" b="1">
-                <a:solidFill>
-                  <a:srgbClr val="FFFFFF"/>
+              <a:rPr sz="1400" b="1">
+                <a:solidFill>
+                  <a:srgbClr val="1B6B93"/>
                 </a:solidFill>
                 <a:latin typeface="Calibri"/>
               </a:rPr>
-              <a:t>Desempenho do posto</a:t>
-            </a:r>
-          </a:p>
-        </p:txBody>
-      </p:sp>
-      <p:sp>
-        <p:nvSpPr>
-          <p:cNvPr id="14" name="TextBox 13"/>
+              <a:t>PA-04</a:t>
+            </a:r>
+          </a:p>
+        </p:txBody>
+      </p:sp>
+      <p:sp>
+        <p:nvSpPr>
+          <p:cNvPr id="24" name="TextBox 23"/>
           <p:cNvSpPr txBox="1"/>
           <p:nvPr/>
         </p:nvSpPr>
         <p:spPr>
           <a:xfrm>
-            <a:off x="6537960" y="2468880"/>
-            <a:ext cx="5029200" cy="3017520"/>
+            <a:off x="2011680" y="4050792"/>
+            <a:ext cx="5943600" cy="365760"/>
           </a:xfrm>
           <a:prstGeom prst="rect">
             <a:avLst/>
@@ -7092,31 +7127,27 @@
           <a:p>
             <a:pPr algn="l"/>
             <a:r>
-              <a:rPr sz="1600" b="0">
-                <a:solidFill>
-                  <a:srgbClr val="4A4A4A"/>
+              <a:rPr sz="1400" b="0">
+                <a:solidFill>
+                  <a:srgbClr val="1F1F1F"/>
                 </a:solidFill>
                 <a:latin typeface="Calibri"/>
               </a:rPr>
-              <a:t>EV 07 — TCL006 com CPU em 100%
-Gargalo de processamento no posto.
-EV 08 — TCL007 com CPU em 100%
-Mesmo padrão em outro posto.
-Dono: Área Técnica / Engenharia</a:t>
-            </a:r>
-          </a:p>
-        </p:txBody>
-      </p:sp>
-      <p:sp>
-        <p:nvSpPr>
-          <p:cNvPr id="15" name="TextBox 14"/>
+              <a:t>Adequação de RASPs/PCs com baixa performance</a:t>
+            </a:r>
+          </a:p>
+        </p:txBody>
+      </p:sp>
+      <p:sp>
+        <p:nvSpPr>
+          <p:cNvPr id="25" name="TextBox 24"/>
           <p:cNvSpPr txBox="1"/>
           <p:nvPr/>
         </p:nvSpPr>
         <p:spPr>
           <a:xfrm>
-            <a:off x="457200" y="6446520"/>
-            <a:ext cx="9144000" cy="274320"/>
+            <a:off x="8046720" y="4050792"/>
+            <a:ext cx="3383280" cy="365760"/>
           </a:xfrm>
           <a:prstGeom prst="rect">
             <a:avLst/>
@@ -7131,6 +7162,337 @@
           <a:p>
             <a:pPr algn="l"/>
             <a:r>
+              <a:rPr sz="1300" b="0">
+                <a:solidFill>
+                  <a:srgbClr val="4A4A4A"/>
+                </a:solidFill>
+                <a:latin typeface="Calibri"/>
+              </a:rPr>
+              <a:t>Área Técnica / Engenharia</a:t>
+            </a:r>
+          </a:p>
+        </p:txBody>
+      </p:sp>
+      <p:sp>
+        <p:nvSpPr>
+          <p:cNvPr id="26" name="Rectangle 25"/>
+          <p:cNvSpPr/>
+          <p:nvPr/>
+        </p:nvSpPr>
+        <p:spPr>
+          <a:xfrm>
+            <a:off x="457200" y="4526279"/>
+            <a:ext cx="11247120" cy="640080"/>
+          </a:xfrm>
+          <a:prstGeom prst="rect">
+            <a:avLst/>
+          </a:prstGeom>
+          <a:solidFill>
+            <a:srgbClr val="FFFFFF"/>
+          </a:solidFill>
+          <a:ln>
+            <a:noFill/>
+          </a:ln>
+        </p:spPr>
+        <p:style>
+          <a:lnRef idx="1">
+            <a:schemeClr val="accent1"/>
+          </a:lnRef>
+          <a:fillRef idx="3">
+            <a:schemeClr val="accent1"/>
+          </a:fillRef>
+          <a:effectRef idx="2">
+            <a:schemeClr val="accent1"/>
+          </a:effectRef>
+          <a:fontRef idx="minor">
+            <a:schemeClr val="lt1"/>
+          </a:fontRef>
+        </p:style>
+        <p:txBody>
+          <a:bodyPr rtlCol="0" anchor="ctr"/>
+          <a:lstStyle/>
+          <a:p>
+            <a:pPr algn="ctr"/>
+          </a:p>
+        </p:txBody>
+      </p:sp>
+      <p:sp>
+        <p:nvSpPr>
+          <p:cNvPr id="27" name="TextBox 26"/>
+          <p:cNvSpPr txBox="1"/>
+          <p:nvPr/>
+        </p:nvSpPr>
+        <p:spPr>
+          <a:xfrm>
+            <a:off x="640080" y="4690871"/>
+            <a:ext cx="1188720" cy="365760"/>
+          </a:xfrm>
+          <a:prstGeom prst="rect">
+            <a:avLst/>
+          </a:prstGeom>
+          <a:noFill/>
+        </p:spPr>
+        <p:txBody>
+          <a:bodyPr wrap="square">
+            <a:spAutoFit/>
+          </a:bodyPr>
+          <a:lstStyle/>
+          <a:p>
+            <a:pPr algn="l"/>
+            <a:r>
+              <a:rPr sz="1400" b="1">
+                <a:solidFill>
+                  <a:srgbClr val="1B6B93"/>
+                </a:solidFill>
+                <a:latin typeface="Calibri"/>
+              </a:rPr>
+              <a:t>PA-05</a:t>
+            </a:r>
+          </a:p>
+        </p:txBody>
+      </p:sp>
+      <p:sp>
+        <p:nvSpPr>
+          <p:cNvPr id="28" name="TextBox 27"/>
+          <p:cNvSpPr txBox="1"/>
+          <p:nvPr/>
+        </p:nvSpPr>
+        <p:spPr>
+          <a:xfrm>
+            <a:off x="2011680" y="4690871"/>
+            <a:ext cx="5943600" cy="365760"/>
+          </a:xfrm>
+          <a:prstGeom prst="rect">
+            <a:avLst/>
+          </a:prstGeom>
+          <a:noFill/>
+        </p:spPr>
+        <p:txBody>
+          <a:bodyPr wrap="square">
+            <a:spAutoFit/>
+          </a:bodyPr>
+          <a:lstStyle/>
+          <a:p>
+            <a:pPr algn="l"/>
+            <a:r>
+              <a:rPr sz="1400" b="0">
+                <a:solidFill>
+                  <a:srgbClr val="1F1F1F"/>
+                </a:solidFill>
+                <a:latin typeface="Calibri"/>
+              </a:rPr>
+              <a:t>Padronizar status passou/não passou</a:t>
+            </a:r>
+          </a:p>
+        </p:txBody>
+      </p:sp>
+      <p:sp>
+        <p:nvSpPr>
+          <p:cNvPr id="29" name="TextBox 28"/>
+          <p:cNvSpPr txBox="1"/>
+          <p:nvPr/>
+        </p:nvSpPr>
+        <p:spPr>
+          <a:xfrm>
+            <a:off x="8046720" y="4690871"/>
+            <a:ext cx="3383280" cy="365760"/>
+          </a:xfrm>
+          <a:prstGeom prst="rect">
+            <a:avLst/>
+          </a:prstGeom>
+          <a:noFill/>
+        </p:spPr>
+        <p:txBody>
+          <a:bodyPr wrap="square">
+            <a:spAutoFit/>
+          </a:bodyPr>
+          <a:lstStyle/>
+          <a:p>
+            <a:pPr algn="l"/>
+            <a:r>
+              <a:rPr sz="1300" b="0">
+                <a:solidFill>
+                  <a:srgbClr val="4A4A4A"/>
+                </a:solidFill>
+                <a:latin typeface="Calibri"/>
+              </a:rPr>
+              <a:t>Engenharia / Área Técnica</a:t>
+            </a:r>
+          </a:p>
+        </p:txBody>
+      </p:sp>
+      <p:sp>
+        <p:nvSpPr>
+          <p:cNvPr id="30" name="Rectangle 29"/>
+          <p:cNvSpPr/>
+          <p:nvPr/>
+        </p:nvSpPr>
+        <p:spPr>
+          <a:xfrm>
+            <a:off x="457200" y="5166360"/>
+            <a:ext cx="11247120" cy="640080"/>
+          </a:xfrm>
+          <a:prstGeom prst="rect">
+            <a:avLst/>
+          </a:prstGeom>
+          <a:solidFill>
+            <a:srgbClr val="E8EEF5"/>
+          </a:solidFill>
+          <a:ln>
+            <a:noFill/>
+          </a:ln>
+        </p:spPr>
+        <p:style>
+          <a:lnRef idx="1">
+            <a:schemeClr val="accent1"/>
+          </a:lnRef>
+          <a:fillRef idx="3">
+            <a:schemeClr val="accent1"/>
+          </a:fillRef>
+          <a:effectRef idx="2">
+            <a:schemeClr val="accent1"/>
+          </a:effectRef>
+          <a:fontRef idx="minor">
+            <a:schemeClr val="lt1"/>
+          </a:fontRef>
+        </p:style>
+        <p:txBody>
+          <a:bodyPr rtlCol="0" anchor="ctr"/>
+          <a:lstStyle/>
+          <a:p>
+            <a:pPr algn="ctr"/>
+          </a:p>
+        </p:txBody>
+      </p:sp>
+      <p:sp>
+        <p:nvSpPr>
+          <p:cNvPr id="31" name="TextBox 30"/>
+          <p:cNvSpPr txBox="1"/>
+          <p:nvPr/>
+        </p:nvSpPr>
+        <p:spPr>
+          <a:xfrm>
+            <a:off x="640080" y="5330952"/>
+            <a:ext cx="1188720" cy="365760"/>
+          </a:xfrm>
+          <a:prstGeom prst="rect">
+            <a:avLst/>
+          </a:prstGeom>
+          <a:noFill/>
+        </p:spPr>
+        <p:txBody>
+          <a:bodyPr wrap="square">
+            <a:spAutoFit/>
+          </a:bodyPr>
+          <a:lstStyle/>
+          <a:p>
+            <a:pPr algn="l"/>
+            <a:r>
+              <a:rPr sz="1400" b="1">
+                <a:solidFill>
+                  <a:srgbClr val="1B6B93"/>
+                </a:solidFill>
+                <a:latin typeface="Calibri"/>
+              </a:rPr>
+              <a:t>PA-06</a:t>
+            </a:r>
+          </a:p>
+        </p:txBody>
+      </p:sp>
+      <p:sp>
+        <p:nvSpPr>
+          <p:cNvPr id="32" name="TextBox 31"/>
+          <p:cNvSpPr txBox="1"/>
+          <p:nvPr/>
+        </p:nvSpPr>
+        <p:spPr>
+          <a:xfrm>
+            <a:off x="2011680" y="5330952"/>
+            <a:ext cx="5943600" cy="365760"/>
+          </a:xfrm>
+          <a:prstGeom prst="rect">
+            <a:avLst/>
+          </a:prstGeom>
+          <a:noFill/>
+        </p:spPr>
+        <p:txBody>
+          <a:bodyPr wrap="square">
+            <a:spAutoFit/>
+          </a:bodyPr>
+          <a:lstStyle/>
+          <a:p>
+            <a:pPr algn="l"/>
+            <a:r>
+              <a:rPr sz="1400" b="0">
+                <a:solidFill>
+                  <a:srgbClr val="1F1F1F"/>
+                </a:solidFill>
+                <a:latin typeface="Calibri"/>
+              </a:rPr>
+              <a:t>Treinamento TI (IP RAP + Filebeat + checklist)</a:t>
+            </a:r>
+          </a:p>
+        </p:txBody>
+      </p:sp>
+      <p:sp>
+        <p:nvSpPr>
+          <p:cNvPr id="33" name="TextBox 32"/>
+          <p:cNvSpPr txBox="1"/>
+          <p:nvPr/>
+        </p:nvSpPr>
+        <p:spPr>
+          <a:xfrm>
+            <a:off x="8046720" y="5330952"/>
+            <a:ext cx="3383280" cy="365760"/>
+          </a:xfrm>
+          <a:prstGeom prst="rect">
+            <a:avLst/>
+          </a:prstGeom>
+          <a:noFill/>
+        </p:spPr>
+        <p:txBody>
+          <a:bodyPr wrap="square">
+            <a:spAutoFit/>
+          </a:bodyPr>
+          <a:lstStyle/>
+          <a:p>
+            <a:pPr algn="l"/>
+            <a:r>
+              <a:rPr sz="1300" b="0">
+                <a:solidFill>
+                  <a:srgbClr val="4A4A4A"/>
+                </a:solidFill>
+                <a:latin typeface="Calibri"/>
+              </a:rPr>
+              <a:t>TI</a:t>
+            </a:r>
+          </a:p>
+        </p:txBody>
+      </p:sp>
+      <p:sp>
+        <p:nvSpPr>
+          <p:cNvPr id="34" name="TextBox 33"/>
+          <p:cNvSpPr txBox="1"/>
+          <p:nvPr/>
+        </p:nvSpPr>
+        <p:spPr>
+          <a:xfrm>
+            <a:off x="457200" y="6446520"/>
+            <a:ext cx="9144000" cy="274320"/>
+          </a:xfrm>
+          <a:prstGeom prst="rect">
+            <a:avLst/>
+          </a:prstGeom>
+          <a:noFill/>
+        </p:spPr>
+        <p:txBody>
+          <a:bodyPr wrap="square">
+            <a:spAutoFit/>
+          </a:bodyPr>
+          <a:lstStyle/>
+          <a:p>
+            <a:pPr algn="l"/>
+            <a:r>
               <a:rPr sz="1100" b="0">
                 <a:solidFill>
                   <a:srgbClr val="8A8A8A"/>
@@ -7144,7 +7506,7 @@
       </p:sp>
       <p:sp>
         <p:nvSpPr>
-          <p:cNvPr id="16" name="TextBox 15"/>
+          <p:cNvPr id="35" name="TextBox 34"/>
           <p:cNvSpPr txBox="1"/>
           <p:nvPr/>
         </p:nvSpPr>
@@ -7172,7 +7534,7 @@
                 </a:solidFill>
                 <a:latin typeface="Calibri"/>
               </a:rPr>
-              <a:t>5/8</a:t>
+              <a:t>5/6</a:t>
             </a:r>
           </a:p>
         </p:txBody>
@@ -7186,2028 +7548,6 @@
 </file>
 
 <file path=ppt/slides/slide6.xml><?xml version="1.0" encoding="utf-8"?>
-<p:sld xmlns:a="http://schemas.openxmlformats.org/drawingml/2006/main" xmlns:p="http://schemas.openxmlformats.org/presentationml/2006/main" xmlns:r="http://schemas.openxmlformats.org/officeDocument/2006/relationships">
-  <p:cSld>
-    <p:spTree>
-      <p:nvGrpSpPr>
-        <p:cNvPr id="1" name=""/>
-        <p:cNvGrpSpPr/>
-        <p:nvPr/>
-      </p:nvGrpSpPr>
-      <p:grpSpPr/>
-      <p:sp>
-        <p:nvSpPr>
-          <p:cNvPr id="2" name="Rectangle 1"/>
-          <p:cNvSpPr/>
-          <p:nvPr/>
-        </p:nvSpPr>
-        <p:spPr>
-          <a:xfrm>
-            <a:off x="0" y="0"/>
-            <a:ext cx="12191695" cy="6858000"/>
-          </a:xfrm>
-          <a:prstGeom prst="rect">
-            <a:avLst/>
-          </a:prstGeom>
-          <a:solidFill>
-            <a:srgbClr val="F7F9FC"/>
-          </a:solidFill>
-          <a:ln>
-            <a:noFill/>
-          </a:ln>
-        </p:spPr>
-        <p:style>
-          <a:lnRef idx="1">
-            <a:schemeClr val="accent1"/>
-          </a:lnRef>
-          <a:fillRef idx="3">
-            <a:schemeClr val="accent1"/>
-          </a:fillRef>
-          <a:effectRef idx="2">
-            <a:schemeClr val="accent1"/>
-          </a:effectRef>
-          <a:fontRef idx="minor">
-            <a:schemeClr val="lt1"/>
-          </a:fontRef>
-        </p:style>
-        <p:txBody>
-          <a:bodyPr rtlCol="0" anchor="ctr"/>
-          <a:lstStyle/>
-          <a:p>
-            <a:pPr algn="ctr"/>
-          </a:p>
-        </p:txBody>
-      </p:sp>
-      <p:sp>
-        <p:nvSpPr>
-          <p:cNvPr id="3" name="Rectangle 2"/>
-          <p:cNvSpPr/>
-          <p:nvPr/>
-        </p:nvSpPr>
-        <p:spPr>
-          <a:xfrm>
-            <a:off x="0" y="0"/>
-            <a:ext cx="12191695" cy="960120"/>
-          </a:xfrm>
-          <a:prstGeom prst="rect">
-            <a:avLst/>
-          </a:prstGeom>
-          <a:solidFill>
-            <a:srgbClr val="0F2C59"/>
-          </a:solidFill>
-          <a:ln>
-            <a:noFill/>
-          </a:ln>
-        </p:spPr>
-        <p:style>
-          <a:lnRef idx="1">
-            <a:schemeClr val="accent1"/>
-          </a:lnRef>
-          <a:fillRef idx="3">
-            <a:schemeClr val="accent1"/>
-          </a:fillRef>
-          <a:effectRef idx="2">
-            <a:schemeClr val="accent1"/>
-          </a:effectRef>
-          <a:fontRef idx="minor">
-            <a:schemeClr val="lt1"/>
-          </a:fontRef>
-        </p:style>
-        <p:txBody>
-          <a:bodyPr rtlCol="0" anchor="ctr"/>
-          <a:lstStyle/>
-          <a:p>
-            <a:pPr algn="ctr"/>
-          </a:p>
-        </p:txBody>
-      </p:sp>
-      <p:sp>
-        <p:nvSpPr>
-          <p:cNvPr id="4" name="Rectangle 3"/>
-          <p:cNvSpPr/>
-          <p:nvPr/>
-        </p:nvSpPr>
-        <p:spPr>
-          <a:xfrm>
-            <a:off x="0" y="960120"/>
-            <a:ext cx="12191695" cy="73152"/>
-          </a:xfrm>
-          <a:prstGeom prst="rect">
-            <a:avLst/>
-          </a:prstGeom>
-          <a:solidFill>
-            <a:srgbClr val="1B6B93"/>
-          </a:solidFill>
-          <a:ln>
-            <a:noFill/>
-          </a:ln>
-        </p:spPr>
-        <p:style>
-          <a:lnRef idx="1">
-            <a:schemeClr val="accent1"/>
-          </a:lnRef>
-          <a:fillRef idx="3">
-            <a:schemeClr val="accent1"/>
-          </a:fillRef>
-          <a:effectRef idx="2">
-            <a:schemeClr val="accent1"/>
-          </a:effectRef>
-          <a:fontRef idx="minor">
-            <a:schemeClr val="lt1"/>
-          </a:fontRef>
-        </p:style>
-        <p:txBody>
-          <a:bodyPr rtlCol="0" anchor="ctr"/>
-          <a:lstStyle/>
-          <a:p>
-            <a:pPr algn="ctr"/>
-          </a:p>
-        </p:txBody>
-      </p:sp>
-      <p:sp>
-        <p:nvSpPr>
-          <p:cNvPr id="5" name="TextBox 4"/>
-          <p:cNvSpPr txBox="1"/>
-          <p:nvPr/>
-        </p:nvSpPr>
-        <p:spPr>
-          <a:xfrm>
-            <a:off x="457200" y="256032"/>
-            <a:ext cx="10972800" cy="457200"/>
-          </a:xfrm>
-          <a:prstGeom prst="rect">
-            <a:avLst/>
-          </a:prstGeom>
-          <a:noFill/>
-        </p:spPr>
-        <p:txBody>
-          <a:bodyPr wrap="square">
-            <a:spAutoFit/>
-          </a:bodyPr>
-          <a:lstStyle/>
-          <a:p>
-            <a:pPr algn="l"/>
-            <a:r>
-              <a:rPr sz="2800" b="1">
-                <a:solidFill>
-                  <a:srgbClr val="FFFFFF"/>
-                </a:solidFill>
-                <a:latin typeface="Calibri"/>
-              </a:rPr>
-              <a:t>Compromisso da TI — Treinamento</a:t>
-            </a:r>
-          </a:p>
-        </p:txBody>
-      </p:sp>
-      <p:sp>
-        <p:nvSpPr>
-          <p:cNvPr id="6" name="TextBox 5"/>
-          <p:cNvSpPr txBox="1"/>
-          <p:nvPr/>
-        </p:nvSpPr>
-        <p:spPr>
-          <a:xfrm>
-            <a:off x="548640" y="1371600"/>
-            <a:ext cx="10972800" cy="457200"/>
-          </a:xfrm>
-          <a:prstGeom prst="rect">
-            <a:avLst/>
-          </a:prstGeom>
-          <a:noFill/>
-        </p:spPr>
-        <p:txBody>
-          <a:bodyPr wrap="square">
-            <a:spAutoFit/>
-          </a:bodyPr>
-          <a:lstStyle/>
-          <a:p>
-            <a:pPr algn="l"/>
-            <a:r>
-              <a:rPr sz="1800" b="0">
-                <a:solidFill>
-                  <a:srgbClr val="4A4A4A"/>
-                </a:solidFill>
-                <a:latin typeface="Calibri"/>
-              </a:rPr>
-              <a:t>A TI não veio só apontar problema. Vamos capacitar Área Técnica e Engenharia.</a:t>
-            </a:r>
-          </a:p>
-        </p:txBody>
-      </p:sp>
-      <p:sp>
-        <p:nvSpPr>
-          <p:cNvPr id="7" name="Rounded Rectangle 6"/>
-          <p:cNvSpPr/>
-          <p:nvPr/>
-        </p:nvSpPr>
-        <p:spPr>
-          <a:xfrm>
-            <a:off x="548640" y="2103120"/>
-            <a:ext cx="3611880" cy="3200400"/>
-          </a:xfrm>
-          <a:prstGeom prst="roundRect">
-            <a:avLst/>
-          </a:prstGeom>
-          <a:solidFill>
-            <a:srgbClr val="0F2C59"/>
-          </a:solidFill>
-          <a:ln>
-            <a:noFill/>
-          </a:ln>
-        </p:spPr>
-        <p:style>
-          <a:lnRef idx="1">
-            <a:schemeClr val="accent1"/>
-          </a:lnRef>
-          <a:fillRef idx="3">
-            <a:schemeClr val="accent1"/>
-          </a:fillRef>
-          <a:effectRef idx="2">
-            <a:schemeClr val="accent1"/>
-          </a:effectRef>
-          <a:fontRef idx="minor">
-            <a:schemeClr val="lt1"/>
-          </a:fontRef>
-        </p:style>
-        <p:txBody>
-          <a:bodyPr rtlCol="0" anchor="ctr"/>
-          <a:lstStyle/>
-          <a:p>
-            <a:pPr algn="ctr"/>
-          </a:p>
-        </p:txBody>
-      </p:sp>
-      <p:sp>
-        <p:nvSpPr>
-          <p:cNvPr id="8" name="TextBox 7"/>
-          <p:cNvSpPr txBox="1"/>
-          <p:nvPr/>
-        </p:nvSpPr>
-        <p:spPr>
-          <a:xfrm>
-            <a:off x="822960" y="2377440"/>
-            <a:ext cx="3017520" cy="365760"/>
-          </a:xfrm>
-          <a:prstGeom prst="rect">
-            <a:avLst/>
-          </a:prstGeom>
-          <a:noFill/>
-        </p:spPr>
-        <p:txBody>
-          <a:bodyPr wrap="square">
-            <a:spAutoFit/>
-          </a:bodyPr>
-          <a:lstStyle/>
-          <a:p>
-            <a:pPr algn="l"/>
-            <a:r>
-              <a:rPr sz="1400" b="1">
-                <a:solidFill>
-                  <a:srgbClr val="9BC9E0"/>
-                </a:solidFill>
-                <a:latin typeface="Calibri"/>
-              </a:rPr>
-              <a:t>01</a:t>
-            </a:r>
-          </a:p>
-        </p:txBody>
-      </p:sp>
-      <p:sp>
-        <p:nvSpPr>
-          <p:cNvPr id="9" name="TextBox 8"/>
-          <p:cNvSpPr txBox="1"/>
-          <p:nvPr/>
-        </p:nvSpPr>
-        <p:spPr>
-          <a:xfrm>
-            <a:off x="822960" y="2926080"/>
-            <a:ext cx="3017520" cy="548640"/>
-          </a:xfrm>
-          <a:prstGeom prst="rect">
-            <a:avLst/>
-          </a:prstGeom>
-          <a:noFill/>
-        </p:spPr>
-        <p:txBody>
-          <a:bodyPr wrap="square">
-            <a:spAutoFit/>
-          </a:bodyPr>
-          <a:lstStyle/>
-          <a:p>
-            <a:pPr algn="l"/>
-            <a:r>
-              <a:rPr sz="2600" b="1">
-                <a:solidFill>
-                  <a:srgbClr val="FFFFFF"/>
-                </a:solidFill>
-                <a:latin typeface="Calibri"/>
-              </a:rPr>
-              <a:t>IP em RAP</a:t>
-            </a:r>
-          </a:p>
-        </p:txBody>
-      </p:sp>
-      <p:sp>
-        <p:nvSpPr>
-          <p:cNvPr id="10" name="TextBox 9"/>
-          <p:cNvSpPr txBox="1"/>
-          <p:nvPr/>
-        </p:nvSpPr>
-        <p:spPr>
-          <a:xfrm>
-            <a:off x="822960" y="3749039"/>
-            <a:ext cx="3017520" cy="1097280"/>
-          </a:xfrm>
-          <a:prstGeom prst="rect">
-            <a:avLst/>
-          </a:prstGeom>
-          <a:noFill/>
-        </p:spPr>
-        <p:txBody>
-          <a:bodyPr wrap="square">
-            <a:spAutoFit/>
-          </a:bodyPr>
-          <a:lstStyle/>
-          <a:p>
-            <a:pPr algn="l"/>
-            <a:r>
-              <a:rPr sz="1600" b="0">
-                <a:solidFill>
-                  <a:srgbClr val="D6E3F0"/>
-                </a:solidFill>
-                <a:latin typeface="Calibri"/>
-              </a:rPr>
-              <a:t>Padronização e prevenção
-de IP duplicado</a:t>
-            </a:r>
-          </a:p>
-        </p:txBody>
-      </p:sp>
-      <p:sp>
-        <p:nvSpPr>
-          <p:cNvPr id="11" name="Rounded Rectangle 10"/>
-          <p:cNvSpPr/>
-          <p:nvPr/>
-        </p:nvSpPr>
-        <p:spPr>
-          <a:xfrm>
-            <a:off x="4389120" y="2103120"/>
-            <a:ext cx="3611880" cy="3200400"/>
-          </a:xfrm>
-          <a:prstGeom prst="roundRect">
-            <a:avLst/>
-          </a:prstGeom>
-          <a:solidFill>
-            <a:srgbClr val="0F2C59"/>
-          </a:solidFill>
-          <a:ln>
-            <a:noFill/>
-          </a:ln>
-        </p:spPr>
-        <p:style>
-          <a:lnRef idx="1">
-            <a:schemeClr val="accent1"/>
-          </a:lnRef>
-          <a:fillRef idx="3">
-            <a:schemeClr val="accent1"/>
-          </a:fillRef>
-          <a:effectRef idx="2">
-            <a:schemeClr val="accent1"/>
-          </a:effectRef>
-          <a:fontRef idx="minor">
-            <a:schemeClr val="lt1"/>
-          </a:fontRef>
-        </p:style>
-        <p:txBody>
-          <a:bodyPr rtlCol="0" anchor="ctr"/>
-          <a:lstStyle/>
-          <a:p>
-            <a:pPr algn="ctr"/>
-          </a:p>
-        </p:txBody>
-      </p:sp>
-      <p:sp>
-        <p:nvSpPr>
-          <p:cNvPr id="12" name="TextBox 11"/>
-          <p:cNvSpPr txBox="1"/>
-          <p:nvPr/>
-        </p:nvSpPr>
-        <p:spPr>
-          <a:xfrm>
-            <a:off x="4663440" y="2377440"/>
-            <a:ext cx="3017520" cy="365760"/>
-          </a:xfrm>
-          <a:prstGeom prst="rect">
-            <a:avLst/>
-          </a:prstGeom>
-          <a:noFill/>
-        </p:spPr>
-        <p:txBody>
-          <a:bodyPr wrap="square">
-            <a:spAutoFit/>
-          </a:bodyPr>
-          <a:lstStyle/>
-          <a:p>
-            <a:pPr algn="l"/>
-            <a:r>
-              <a:rPr sz="1400" b="1">
-                <a:solidFill>
-                  <a:srgbClr val="9BC9E0"/>
-                </a:solidFill>
-                <a:latin typeface="Calibri"/>
-              </a:rPr>
-              <a:t>02</a:t>
-            </a:r>
-          </a:p>
-        </p:txBody>
-      </p:sp>
-      <p:sp>
-        <p:nvSpPr>
-          <p:cNvPr id="13" name="TextBox 12"/>
-          <p:cNvSpPr txBox="1"/>
-          <p:nvPr/>
-        </p:nvSpPr>
-        <p:spPr>
-          <a:xfrm>
-            <a:off x="4663440" y="2926080"/>
-            <a:ext cx="3017520" cy="548640"/>
-          </a:xfrm>
-          <a:prstGeom prst="rect">
-            <a:avLst/>
-          </a:prstGeom>
-          <a:noFill/>
-        </p:spPr>
-        <p:txBody>
-          <a:bodyPr wrap="square">
-            <a:spAutoFit/>
-          </a:bodyPr>
-          <a:lstStyle/>
-          <a:p>
-            <a:pPr algn="l"/>
-            <a:r>
-              <a:rPr sz="2600" b="1">
-                <a:solidFill>
-                  <a:srgbClr val="FFFFFF"/>
-                </a:solidFill>
-                <a:latin typeface="Calibri"/>
-              </a:rPr>
-              <a:t>Filebeat</a:t>
-            </a:r>
-          </a:p>
-        </p:txBody>
-      </p:sp>
-      <p:sp>
-        <p:nvSpPr>
-          <p:cNvPr id="14" name="TextBox 13"/>
-          <p:cNvSpPr txBox="1"/>
-          <p:nvPr/>
-        </p:nvSpPr>
-        <p:spPr>
-          <a:xfrm>
-            <a:off x="4663440" y="3749039"/>
-            <a:ext cx="3017520" cy="1097280"/>
-          </a:xfrm>
-          <a:prstGeom prst="rect">
-            <a:avLst/>
-          </a:prstGeom>
-          <a:noFill/>
-        </p:spPr>
-        <p:txBody>
-          <a:bodyPr wrap="square">
-            <a:spAutoFit/>
-          </a:bodyPr>
-          <a:lstStyle/>
-          <a:p>
-            <a:pPr algn="l"/>
-            <a:r>
-              <a:rPr sz="1600" b="0">
-                <a:solidFill>
-                  <a:srgbClr val="D6E3F0"/>
-                </a:solidFill>
-                <a:latin typeface="Calibri"/>
-              </a:rPr>
-              <a:t>Coleta/envio de logs
-e boas práticas</a:t>
-            </a:r>
-          </a:p>
-        </p:txBody>
-      </p:sp>
-      <p:sp>
-        <p:nvSpPr>
-          <p:cNvPr id="15" name="Rounded Rectangle 14"/>
-          <p:cNvSpPr/>
-          <p:nvPr/>
-        </p:nvSpPr>
-        <p:spPr>
-          <a:xfrm>
-            <a:off x="8229600" y="2103120"/>
-            <a:ext cx="3611880" cy="3200400"/>
-          </a:xfrm>
-          <a:prstGeom prst="roundRect">
-            <a:avLst/>
-          </a:prstGeom>
-          <a:solidFill>
-            <a:srgbClr val="0F2C59"/>
-          </a:solidFill>
-          <a:ln>
-            <a:noFill/>
-          </a:ln>
-        </p:spPr>
-        <p:style>
-          <a:lnRef idx="1">
-            <a:schemeClr val="accent1"/>
-          </a:lnRef>
-          <a:fillRef idx="3">
-            <a:schemeClr val="accent1"/>
-          </a:fillRef>
-          <a:effectRef idx="2">
-            <a:schemeClr val="accent1"/>
-          </a:effectRef>
-          <a:fontRef idx="minor">
-            <a:schemeClr val="lt1"/>
-          </a:fontRef>
-        </p:style>
-        <p:txBody>
-          <a:bodyPr rtlCol="0" anchor="ctr"/>
-          <a:lstStyle/>
-          <a:p>
-            <a:pPr algn="ctr"/>
-          </a:p>
-        </p:txBody>
-      </p:sp>
-      <p:sp>
-        <p:nvSpPr>
-          <p:cNvPr id="16" name="TextBox 15"/>
-          <p:cNvSpPr txBox="1"/>
-          <p:nvPr/>
-        </p:nvSpPr>
-        <p:spPr>
-          <a:xfrm>
-            <a:off x="8503920" y="2377440"/>
-            <a:ext cx="3017520" cy="365760"/>
-          </a:xfrm>
-          <a:prstGeom prst="rect">
-            <a:avLst/>
-          </a:prstGeom>
-          <a:noFill/>
-        </p:spPr>
-        <p:txBody>
-          <a:bodyPr wrap="square">
-            <a:spAutoFit/>
-          </a:bodyPr>
-          <a:lstStyle/>
-          <a:p>
-            <a:pPr algn="l"/>
-            <a:r>
-              <a:rPr sz="1400" b="1">
-                <a:solidFill>
-                  <a:srgbClr val="9BC9E0"/>
-                </a:solidFill>
-                <a:latin typeface="Calibri"/>
-              </a:rPr>
-              <a:t>03</a:t>
-            </a:r>
-          </a:p>
-        </p:txBody>
-      </p:sp>
-      <p:sp>
-        <p:nvSpPr>
-          <p:cNvPr id="17" name="TextBox 16"/>
-          <p:cNvSpPr txBox="1"/>
-          <p:nvPr/>
-        </p:nvSpPr>
-        <p:spPr>
-          <a:xfrm>
-            <a:off x="8503920" y="2926080"/>
-            <a:ext cx="3017520" cy="548640"/>
-          </a:xfrm>
-          <a:prstGeom prst="rect">
-            <a:avLst/>
-          </a:prstGeom>
-          <a:noFill/>
-        </p:spPr>
-        <p:txBody>
-          <a:bodyPr wrap="square">
-            <a:spAutoFit/>
-          </a:bodyPr>
-          <a:lstStyle/>
-          <a:p>
-            <a:pPr algn="l"/>
-            <a:r>
-              <a:rPr sz="2600" b="1">
-                <a:solidFill>
-                  <a:srgbClr val="FFFFFF"/>
-                </a:solidFill>
-                <a:latin typeface="Calibri"/>
-              </a:rPr>
-              <a:t>Checklist</a:t>
-            </a:r>
-          </a:p>
-        </p:txBody>
-      </p:sp>
-      <p:sp>
-        <p:nvSpPr>
-          <p:cNvPr id="18" name="TextBox 17"/>
-          <p:cNvSpPr txBox="1"/>
-          <p:nvPr/>
-        </p:nvSpPr>
-        <p:spPr>
-          <a:xfrm>
-            <a:off x="8503920" y="3749039"/>
-            <a:ext cx="3017520" cy="1097280"/>
-          </a:xfrm>
-          <a:prstGeom prst="rect">
-            <a:avLst/>
-          </a:prstGeom>
-          <a:noFill/>
-        </p:spPr>
-        <p:txBody>
-          <a:bodyPr wrap="square">
-            <a:spAutoFit/>
-          </a:bodyPr>
-          <a:lstStyle/>
-          <a:p>
-            <a:pPr algn="l"/>
-            <a:r>
-              <a:rPr sz="1600" b="0">
-                <a:solidFill>
-                  <a:srgbClr val="D6E3F0"/>
-                </a:solidFill>
-                <a:latin typeface="Calibri"/>
-              </a:rPr>
-              <a:t>Antes de classificar como
-“falha de TI”</a:t>
-            </a:r>
-          </a:p>
-        </p:txBody>
-      </p:sp>
-      <p:sp>
-        <p:nvSpPr>
-          <p:cNvPr id="19" name="TextBox 18"/>
-          <p:cNvSpPr txBox="1"/>
-          <p:nvPr/>
-        </p:nvSpPr>
-        <p:spPr>
-          <a:xfrm>
-            <a:off x="457200" y="6446520"/>
-            <a:ext cx="9144000" cy="274320"/>
-          </a:xfrm>
-          <a:prstGeom prst="rect">
-            <a:avLst/>
-          </a:prstGeom>
-          <a:noFill/>
-        </p:spPr>
-        <p:txBody>
-          <a:bodyPr wrap="square">
-            <a:spAutoFit/>
-          </a:bodyPr>
-          <a:lstStyle/>
-          <a:p>
-            <a:pPr algn="l"/>
-            <a:r>
-              <a:rPr sz="1100" b="0">
-                <a:solidFill>
-                  <a:srgbClr val="8A8A8A"/>
-                </a:solidFill>
-                <a:latin typeface="Calibri"/>
-              </a:rPr>
-              <a:t>TI  ·  Área Técnica  ·  Engenharia</a:t>
-            </a:r>
-          </a:p>
-        </p:txBody>
-      </p:sp>
-      <p:sp>
-        <p:nvSpPr>
-          <p:cNvPr id="20" name="TextBox 19"/>
-          <p:cNvSpPr txBox="1"/>
-          <p:nvPr/>
-        </p:nvSpPr>
-        <p:spPr>
-          <a:xfrm>
-            <a:off x="10515600" y="6446520"/>
-            <a:ext cx="1280160" cy="274320"/>
-          </a:xfrm>
-          <a:prstGeom prst="rect">
-            <a:avLst/>
-          </a:prstGeom>
-          <a:noFill/>
-        </p:spPr>
-        <p:txBody>
-          <a:bodyPr wrap="square">
-            <a:spAutoFit/>
-          </a:bodyPr>
-          <a:lstStyle/>
-          <a:p>
-            <a:pPr algn="r"/>
-            <a:r>
-              <a:rPr sz="1100" b="0">
-                <a:solidFill>
-                  <a:srgbClr val="8A8A8A"/>
-                </a:solidFill>
-                <a:latin typeface="Calibri"/>
-              </a:rPr>
-              <a:t>6/8</a:t>
-            </a:r>
-          </a:p>
-        </p:txBody>
-      </p:sp>
-    </p:spTree>
-  </p:cSld>
-  <p:clrMapOvr>
-    <a:masterClrMapping/>
-  </p:clrMapOvr>
-</p:sld>
-</file>
-
-<file path=ppt/slides/slide7.xml><?xml version="1.0" encoding="utf-8"?>
-<p:sld xmlns:a="http://schemas.openxmlformats.org/drawingml/2006/main" xmlns:p="http://schemas.openxmlformats.org/presentationml/2006/main" xmlns:r="http://schemas.openxmlformats.org/officeDocument/2006/relationships">
-  <p:cSld>
-    <p:spTree>
-      <p:nvGrpSpPr>
-        <p:cNvPr id="1" name=""/>
-        <p:cNvGrpSpPr/>
-        <p:nvPr/>
-      </p:nvGrpSpPr>
-      <p:grpSpPr/>
-      <p:sp>
-        <p:nvSpPr>
-          <p:cNvPr id="2" name="Rectangle 1"/>
-          <p:cNvSpPr/>
-          <p:nvPr/>
-        </p:nvSpPr>
-        <p:spPr>
-          <a:xfrm>
-            <a:off x="0" y="0"/>
-            <a:ext cx="12191695" cy="6858000"/>
-          </a:xfrm>
-          <a:prstGeom prst="rect">
-            <a:avLst/>
-          </a:prstGeom>
-          <a:solidFill>
-            <a:srgbClr val="F7F9FC"/>
-          </a:solidFill>
-          <a:ln>
-            <a:noFill/>
-          </a:ln>
-        </p:spPr>
-        <p:style>
-          <a:lnRef idx="1">
-            <a:schemeClr val="accent1"/>
-          </a:lnRef>
-          <a:fillRef idx="3">
-            <a:schemeClr val="accent1"/>
-          </a:fillRef>
-          <a:effectRef idx="2">
-            <a:schemeClr val="accent1"/>
-          </a:effectRef>
-          <a:fontRef idx="minor">
-            <a:schemeClr val="lt1"/>
-          </a:fontRef>
-        </p:style>
-        <p:txBody>
-          <a:bodyPr rtlCol="0" anchor="ctr"/>
-          <a:lstStyle/>
-          <a:p>
-            <a:pPr algn="ctr"/>
-          </a:p>
-        </p:txBody>
-      </p:sp>
-      <p:sp>
-        <p:nvSpPr>
-          <p:cNvPr id="3" name="Rectangle 2"/>
-          <p:cNvSpPr/>
-          <p:nvPr/>
-        </p:nvSpPr>
-        <p:spPr>
-          <a:xfrm>
-            <a:off x="0" y="0"/>
-            <a:ext cx="12191695" cy="960120"/>
-          </a:xfrm>
-          <a:prstGeom prst="rect">
-            <a:avLst/>
-          </a:prstGeom>
-          <a:solidFill>
-            <a:srgbClr val="0F2C59"/>
-          </a:solidFill>
-          <a:ln>
-            <a:noFill/>
-          </a:ln>
-        </p:spPr>
-        <p:style>
-          <a:lnRef idx="1">
-            <a:schemeClr val="accent1"/>
-          </a:lnRef>
-          <a:fillRef idx="3">
-            <a:schemeClr val="accent1"/>
-          </a:fillRef>
-          <a:effectRef idx="2">
-            <a:schemeClr val="accent1"/>
-          </a:effectRef>
-          <a:fontRef idx="minor">
-            <a:schemeClr val="lt1"/>
-          </a:fontRef>
-        </p:style>
-        <p:txBody>
-          <a:bodyPr rtlCol="0" anchor="ctr"/>
-          <a:lstStyle/>
-          <a:p>
-            <a:pPr algn="ctr"/>
-          </a:p>
-        </p:txBody>
-      </p:sp>
-      <p:sp>
-        <p:nvSpPr>
-          <p:cNvPr id="4" name="Rectangle 3"/>
-          <p:cNvSpPr/>
-          <p:nvPr/>
-        </p:nvSpPr>
-        <p:spPr>
-          <a:xfrm>
-            <a:off x="0" y="960120"/>
-            <a:ext cx="12191695" cy="73152"/>
-          </a:xfrm>
-          <a:prstGeom prst="rect">
-            <a:avLst/>
-          </a:prstGeom>
-          <a:solidFill>
-            <a:srgbClr val="1B6B93"/>
-          </a:solidFill>
-          <a:ln>
-            <a:noFill/>
-          </a:ln>
-        </p:spPr>
-        <p:style>
-          <a:lnRef idx="1">
-            <a:schemeClr val="accent1"/>
-          </a:lnRef>
-          <a:fillRef idx="3">
-            <a:schemeClr val="accent1"/>
-          </a:fillRef>
-          <a:effectRef idx="2">
-            <a:schemeClr val="accent1"/>
-          </a:effectRef>
-          <a:fontRef idx="minor">
-            <a:schemeClr val="lt1"/>
-          </a:fontRef>
-        </p:style>
-        <p:txBody>
-          <a:bodyPr rtlCol="0" anchor="ctr"/>
-          <a:lstStyle/>
-          <a:p>
-            <a:pPr algn="ctr"/>
-          </a:p>
-        </p:txBody>
-      </p:sp>
-      <p:sp>
-        <p:nvSpPr>
-          <p:cNvPr id="5" name="TextBox 4"/>
-          <p:cNvSpPr txBox="1"/>
-          <p:nvPr/>
-        </p:nvSpPr>
-        <p:spPr>
-          <a:xfrm>
-            <a:off x="457200" y="256032"/>
-            <a:ext cx="10972800" cy="457200"/>
-          </a:xfrm>
-          <a:prstGeom prst="rect">
-            <a:avLst/>
-          </a:prstGeom>
-          <a:noFill/>
-        </p:spPr>
-        <p:txBody>
-          <a:bodyPr wrap="square">
-            <a:spAutoFit/>
-          </a:bodyPr>
-          <a:lstStyle/>
-          <a:p>
-            <a:pPr algn="l"/>
-            <a:r>
-              <a:rPr sz="2800" b="1">
-                <a:solidFill>
-                  <a:srgbClr val="FFFFFF"/>
-                </a:solidFill>
-                <a:latin typeface="Calibri"/>
-              </a:rPr>
-              <a:t>Plano de ação resumido</a:t>
-            </a:r>
-          </a:p>
-        </p:txBody>
-      </p:sp>
-      <p:sp>
-        <p:nvSpPr>
-          <p:cNvPr id="6" name="Rectangle 5"/>
-          <p:cNvSpPr/>
-          <p:nvPr/>
-        </p:nvSpPr>
-        <p:spPr>
-          <a:xfrm>
-            <a:off x="457200" y="1417320"/>
-            <a:ext cx="11247120" cy="502920"/>
-          </a:xfrm>
-          <a:prstGeom prst="rect">
-            <a:avLst/>
-          </a:prstGeom>
-          <a:solidFill>
-            <a:srgbClr val="0F2C59"/>
-          </a:solidFill>
-          <a:ln>
-            <a:noFill/>
-          </a:ln>
-        </p:spPr>
-        <p:style>
-          <a:lnRef idx="1">
-            <a:schemeClr val="accent1"/>
-          </a:lnRef>
-          <a:fillRef idx="3">
-            <a:schemeClr val="accent1"/>
-          </a:fillRef>
-          <a:effectRef idx="2">
-            <a:schemeClr val="accent1"/>
-          </a:effectRef>
-          <a:fontRef idx="minor">
-            <a:schemeClr val="lt1"/>
-          </a:fontRef>
-        </p:style>
-        <p:txBody>
-          <a:bodyPr rtlCol="0" anchor="ctr"/>
-          <a:lstStyle/>
-          <a:p>
-            <a:pPr algn="ctr"/>
-          </a:p>
-        </p:txBody>
-      </p:sp>
-      <p:sp>
-        <p:nvSpPr>
-          <p:cNvPr id="7" name="TextBox 6"/>
-          <p:cNvSpPr txBox="1"/>
-          <p:nvPr/>
-        </p:nvSpPr>
-        <p:spPr>
-          <a:xfrm>
-            <a:off x="640080" y="1508760"/>
-            <a:ext cx="1188720" cy="365760"/>
-          </a:xfrm>
-          <a:prstGeom prst="rect">
-            <a:avLst/>
-          </a:prstGeom>
-          <a:noFill/>
-        </p:spPr>
-        <p:txBody>
-          <a:bodyPr wrap="square">
-            <a:spAutoFit/>
-          </a:bodyPr>
-          <a:lstStyle/>
-          <a:p>
-            <a:pPr algn="l"/>
-            <a:r>
-              <a:rPr sz="1400" b="1">
-                <a:solidFill>
-                  <a:srgbClr val="FFFFFF"/>
-                </a:solidFill>
-                <a:latin typeface="Calibri"/>
-              </a:rPr>
-              <a:t>ID</a:t>
-            </a:r>
-          </a:p>
-        </p:txBody>
-      </p:sp>
-      <p:sp>
-        <p:nvSpPr>
-          <p:cNvPr id="8" name="TextBox 7"/>
-          <p:cNvSpPr txBox="1"/>
-          <p:nvPr/>
-        </p:nvSpPr>
-        <p:spPr>
-          <a:xfrm>
-            <a:off x="2011680" y="1508760"/>
-            <a:ext cx="5943600" cy="365760"/>
-          </a:xfrm>
-          <a:prstGeom prst="rect">
-            <a:avLst/>
-          </a:prstGeom>
-          <a:noFill/>
-        </p:spPr>
-        <p:txBody>
-          <a:bodyPr wrap="square">
-            <a:spAutoFit/>
-          </a:bodyPr>
-          <a:lstStyle/>
-          <a:p>
-            <a:pPr algn="l"/>
-            <a:r>
-              <a:rPr sz="1400" b="1">
-                <a:solidFill>
-                  <a:srgbClr val="FFFFFF"/>
-                </a:solidFill>
-                <a:latin typeface="Calibri"/>
-              </a:rPr>
-              <a:t>Ação</a:t>
-            </a:r>
-          </a:p>
-        </p:txBody>
-      </p:sp>
-      <p:sp>
-        <p:nvSpPr>
-          <p:cNvPr id="9" name="TextBox 8"/>
-          <p:cNvSpPr txBox="1"/>
-          <p:nvPr/>
-        </p:nvSpPr>
-        <p:spPr>
-          <a:xfrm>
-            <a:off x="8046720" y="1508760"/>
-            <a:ext cx="3383280" cy="365760"/>
-          </a:xfrm>
-          <a:prstGeom prst="rect">
-            <a:avLst/>
-          </a:prstGeom>
-          <a:noFill/>
-        </p:spPr>
-        <p:txBody>
-          <a:bodyPr wrap="square">
-            <a:spAutoFit/>
-          </a:bodyPr>
-          <a:lstStyle/>
-          <a:p>
-            <a:pPr algn="l"/>
-            <a:r>
-              <a:rPr sz="1400" b="1">
-                <a:solidFill>
-                  <a:srgbClr val="FFFFFF"/>
-                </a:solidFill>
-                <a:latin typeface="Calibri"/>
-              </a:rPr>
-              <a:t>Dono</a:t>
-            </a:r>
-          </a:p>
-        </p:txBody>
-      </p:sp>
-      <p:sp>
-        <p:nvSpPr>
-          <p:cNvPr id="10" name="Rectangle 9"/>
-          <p:cNvSpPr/>
-          <p:nvPr/>
-        </p:nvSpPr>
-        <p:spPr>
-          <a:xfrm>
-            <a:off x="457200" y="1965960"/>
-            <a:ext cx="11247120" cy="640080"/>
-          </a:xfrm>
-          <a:prstGeom prst="rect">
-            <a:avLst/>
-          </a:prstGeom>
-          <a:solidFill>
-            <a:srgbClr val="FFFFFF"/>
-          </a:solidFill>
-          <a:ln>
-            <a:noFill/>
-          </a:ln>
-        </p:spPr>
-        <p:style>
-          <a:lnRef idx="1">
-            <a:schemeClr val="accent1"/>
-          </a:lnRef>
-          <a:fillRef idx="3">
-            <a:schemeClr val="accent1"/>
-          </a:fillRef>
-          <a:effectRef idx="2">
-            <a:schemeClr val="accent1"/>
-          </a:effectRef>
-          <a:fontRef idx="minor">
-            <a:schemeClr val="lt1"/>
-          </a:fontRef>
-        </p:style>
-        <p:txBody>
-          <a:bodyPr rtlCol="0" anchor="ctr"/>
-          <a:lstStyle/>
-          <a:p>
-            <a:pPr algn="ctr"/>
-          </a:p>
-        </p:txBody>
-      </p:sp>
-      <p:sp>
-        <p:nvSpPr>
-          <p:cNvPr id="11" name="TextBox 10"/>
-          <p:cNvSpPr txBox="1"/>
-          <p:nvPr/>
-        </p:nvSpPr>
-        <p:spPr>
-          <a:xfrm>
-            <a:off x="640080" y="2130552"/>
-            <a:ext cx="1188720" cy="365760"/>
-          </a:xfrm>
-          <a:prstGeom prst="rect">
-            <a:avLst/>
-          </a:prstGeom>
-          <a:noFill/>
-        </p:spPr>
-        <p:txBody>
-          <a:bodyPr wrap="square">
-            <a:spAutoFit/>
-          </a:bodyPr>
-          <a:lstStyle/>
-          <a:p>
-            <a:pPr algn="l"/>
-            <a:r>
-              <a:rPr sz="1400" b="1">
-                <a:solidFill>
-                  <a:srgbClr val="1B6B93"/>
-                </a:solidFill>
-                <a:latin typeface="Calibri"/>
-              </a:rPr>
-              <a:t>PA-01</a:t>
-            </a:r>
-          </a:p>
-        </p:txBody>
-      </p:sp>
-      <p:sp>
-        <p:nvSpPr>
-          <p:cNvPr id="12" name="TextBox 11"/>
-          <p:cNvSpPr txBox="1"/>
-          <p:nvPr/>
-        </p:nvSpPr>
-        <p:spPr>
-          <a:xfrm>
-            <a:off x="2011680" y="2130552"/>
-            <a:ext cx="5943600" cy="365760"/>
-          </a:xfrm>
-          <a:prstGeom prst="rect">
-            <a:avLst/>
-          </a:prstGeom>
-          <a:noFill/>
-        </p:spPr>
-        <p:txBody>
-          <a:bodyPr wrap="square">
-            <a:spAutoFit/>
-          </a:bodyPr>
-          <a:lstStyle/>
-          <a:p>
-            <a:pPr algn="l"/>
-            <a:r>
-              <a:rPr sz="1400" b="0">
-                <a:solidFill>
-                  <a:srgbClr val="1F1F1F"/>
-                </a:solidFill>
-                <a:latin typeface="Calibri"/>
-              </a:rPr>
-              <a:t>Padronizar/substituir cabos e conectores</a:t>
-            </a:r>
-          </a:p>
-        </p:txBody>
-      </p:sp>
-      <p:sp>
-        <p:nvSpPr>
-          <p:cNvPr id="13" name="TextBox 12"/>
-          <p:cNvSpPr txBox="1"/>
-          <p:nvPr/>
-        </p:nvSpPr>
-        <p:spPr>
-          <a:xfrm>
-            <a:off x="8046720" y="2130552"/>
-            <a:ext cx="3383280" cy="365760"/>
-          </a:xfrm>
-          <a:prstGeom prst="rect">
-            <a:avLst/>
-          </a:prstGeom>
-          <a:noFill/>
-        </p:spPr>
-        <p:txBody>
-          <a:bodyPr wrap="square">
-            <a:spAutoFit/>
-          </a:bodyPr>
-          <a:lstStyle/>
-          <a:p>
-            <a:pPr algn="l"/>
-            <a:r>
-              <a:rPr sz="1300" b="0">
-                <a:solidFill>
-                  <a:srgbClr val="4A4A4A"/>
-                </a:solidFill>
-                <a:latin typeface="Calibri"/>
-              </a:rPr>
-              <a:t>Área Técnica / Engenharia</a:t>
-            </a:r>
-          </a:p>
-        </p:txBody>
-      </p:sp>
-      <p:sp>
-        <p:nvSpPr>
-          <p:cNvPr id="14" name="Rectangle 13"/>
-          <p:cNvSpPr/>
-          <p:nvPr/>
-        </p:nvSpPr>
-        <p:spPr>
-          <a:xfrm>
-            <a:off x="457200" y="2606039"/>
-            <a:ext cx="11247120" cy="640080"/>
-          </a:xfrm>
-          <a:prstGeom prst="rect">
-            <a:avLst/>
-          </a:prstGeom>
-          <a:solidFill>
-            <a:srgbClr val="E8EEF5"/>
-          </a:solidFill>
-          <a:ln>
-            <a:noFill/>
-          </a:ln>
-        </p:spPr>
-        <p:style>
-          <a:lnRef idx="1">
-            <a:schemeClr val="accent1"/>
-          </a:lnRef>
-          <a:fillRef idx="3">
-            <a:schemeClr val="accent1"/>
-          </a:fillRef>
-          <a:effectRef idx="2">
-            <a:schemeClr val="accent1"/>
-          </a:effectRef>
-          <a:fontRef idx="minor">
-            <a:schemeClr val="lt1"/>
-          </a:fontRef>
-        </p:style>
-        <p:txBody>
-          <a:bodyPr rtlCol="0" anchor="ctr"/>
-          <a:lstStyle/>
-          <a:p>
-            <a:pPr algn="ctr"/>
-          </a:p>
-        </p:txBody>
-      </p:sp>
-      <p:sp>
-        <p:nvSpPr>
-          <p:cNvPr id="15" name="TextBox 14"/>
-          <p:cNvSpPr txBox="1"/>
-          <p:nvPr/>
-        </p:nvSpPr>
-        <p:spPr>
-          <a:xfrm>
-            <a:off x="640080" y="2770631"/>
-            <a:ext cx="1188720" cy="365760"/>
-          </a:xfrm>
-          <a:prstGeom prst="rect">
-            <a:avLst/>
-          </a:prstGeom>
-          <a:noFill/>
-        </p:spPr>
-        <p:txBody>
-          <a:bodyPr wrap="square">
-            <a:spAutoFit/>
-          </a:bodyPr>
-          <a:lstStyle/>
-          <a:p>
-            <a:pPr algn="l"/>
-            <a:r>
-              <a:rPr sz="1400" b="1">
-                <a:solidFill>
-                  <a:srgbClr val="1B6B93"/>
-                </a:solidFill>
-                <a:latin typeface="Calibri"/>
-              </a:rPr>
-              <a:t>PA-02</a:t>
-            </a:r>
-          </a:p>
-        </p:txBody>
-      </p:sp>
-      <p:sp>
-        <p:nvSpPr>
-          <p:cNvPr id="16" name="TextBox 15"/>
-          <p:cNvSpPr txBox="1"/>
-          <p:nvPr/>
-        </p:nvSpPr>
-        <p:spPr>
-          <a:xfrm>
-            <a:off x="2011680" y="2770631"/>
-            <a:ext cx="5943600" cy="365760"/>
-          </a:xfrm>
-          <a:prstGeom prst="rect">
-            <a:avLst/>
-          </a:prstGeom>
-          <a:noFill/>
-        </p:spPr>
-        <p:txBody>
-          <a:bodyPr wrap="square">
-            <a:spAutoFit/>
-          </a:bodyPr>
-          <a:lstStyle/>
-          <a:p>
-            <a:pPr algn="l"/>
-            <a:r>
-              <a:rPr sz="1400" b="0">
-                <a:solidFill>
-                  <a:srgbClr val="1F1F1F"/>
-                </a:solidFill>
-                <a:latin typeface="Calibri"/>
-              </a:rPr>
-              <a:t>Eliminar IPs duplicados e oficializar endereçamento</a:t>
-            </a:r>
-          </a:p>
-        </p:txBody>
-      </p:sp>
-      <p:sp>
-        <p:nvSpPr>
-          <p:cNvPr id="17" name="TextBox 16"/>
-          <p:cNvSpPr txBox="1"/>
-          <p:nvPr/>
-        </p:nvSpPr>
-        <p:spPr>
-          <a:xfrm>
-            <a:off x="8046720" y="2770631"/>
-            <a:ext cx="3383280" cy="365760"/>
-          </a:xfrm>
-          <a:prstGeom prst="rect">
-            <a:avLst/>
-          </a:prstGeom>
-          <a:noFill/>
-        </p:spPr>
-        <p:txBody>
-          <a:bodyPr wrap="square">
-            <a:spAutoFit/>
-          </a:bodyPr>
-          <a:lstStyle/>
-          <a:p>
-            <a:pPr algn="l"/>
-            <a:r>
-              <a:rPr sz="1300" b="0">
-                <a:solidFill>
-                  <a:srgbClr val="4A4A4A"/>
-                </a:solidFill>
-                <a:latin typeface="Calibri"/>
-              </a:rPr>
-              <a:t>Área Técnica / Engenharia</a:t>
-            </a:r>
-          </a:p>
-        </p:txBody>
-      </p:sp>
-      <p:sp>
-        <p:nvSpPr>
-          <p:cNvPr id="18" name="Rectangle 17"/>
-          <p:cNvSpPr/>
-          <p:nvPr/>
-        </p:nvSpPr>
-        <p:spPr>
-          <a:xfrm>
-            <a:off x="457200" y="3246120"/>
-            <a:ext cx="11247120" cy="640080"/>
-          </a:xfrm>
-          <a:prstGeom prst="rect">
-            <a:avLst/>
-          </a:prstGeom>
-          <a:solidFill>
-            <a:srgbClr val="FFFFFF"/>
-          </a:solidFill>
-          <a:ln>
-            <a:noFill/>
-          </a:ln>
-        </p:spPr>
-        <p:style>
-          <a:lnRef idx="1">
-            <a:schemeClr val="accent1"/>
-          </a:lnRef>
-          <a:fillRef idx="3">
-            <a:schemeClr val="accent1"/>
-          </a:fillRef>
-          <a:effectRef idx="2">
-            <a:schemeClr val="accent1"/>
-          </a:effectRef>
-          <a:fontRef idx="minor">
-            <a:schemeClr val="lt1"/>
-          </a:fontRef>
-        </p:style>
-        <p:txBody>
-          <a:bodyPr rtlCol="0" anchor="ctr"/>
-          <a:lstStyle/>
-          <a:p>
-            <a:pPr algn="ctr"/>
-          </a:p>
-        </p:txBody>
-      </p:sp>
-      <p:sp>
-        <p:nvSpPr>
-          <p:cNvPr id="19" name="TextBox 18"/>
-          <p:cNvSpPr txBox="1"/>
-          <p:nvPr/>
-        </p:nvSpPr>
-        <p:spPr>
-          <a:xfrm>
-            <a:off x="640080" y="3410712"/>
-            <a:ext cx="1188720" cy="365760"/>
-          </a:xfrm>
-          <a:prstGeom prst="rect">
-            <a:avLst/>
-          </a:prstGeom>
-          <a:noFill/>
-        </p:spPr>
-        <p:txBody>
-          <a:bodyPr wrap="square">
-            <a:spAutoFit/>
-          </a:bodyPr>
-          <a:lstStyle/>
-          <a:p>
-            <a:pPr algn="l"/>
-            <a:r>
-              <a:rPr sz="1400" b="1">
-                <a:solidFill>
-                  <a:srgbClr val="1B6B93"/>
-                </a:solidFill>
-                <a:latin typeface="Calibri"/>
-              </a:rPr>
-              <a:t>PA-03</a:t>
-            </a:r>
-          </a:p>
-        </p:txBody>
-      </p:sp>
-      <p:sp>
-        <p:nvSpPr>
-          <p:cNvPr id="20" name="TextBox 19"/>
-          <p:cNvSpPr txBox="1"/>
-          <p:nvPr/>
-        </p:nvSpPr>
-        <p:spPr>
-          <a:xfrm>
-            <a:off x="2011680" y="3410712"/>
-            <a:ext cx="5943600" cy="365760"/>
-          </a:xfrm>
-          <a:prstGeom prst="rect">
-            <a:avLst/>
-          </a:prstGeom>
-          <a:noFill/>
-        </p:spPr>
-        <p:txBody>
-          <a:bodyPr wrap="square">
-            <a:spAutoFit/>
-          </a:bodyPr>
-          <a:lstStyle/>
-          <a:p>
-            <a:pPr algn="l"/>
-            <a:r>
-              <a:rPr sz="1400" b="0">
-                <a:solidFill>
-                  <a:srgbClr val="1F1F1F"/>
-                </a:solidFill>
-                <a:latin typeface="Calibri"/>
-              </a:rPr>
-              <a:t>Controle de liberação de roteiro</a:t>
-            </a:r>
-          </a:p>
-        </p:txBody>
-      </p:sp>
-      <p:sp>
-        <p:nvSpPr>
-          <p:cNvPr id="21" name="TextBox 20"/>
-          <p:cNvSpPr txBox="1"/>
-          <p:nvPr/>
-        </p:nvSpPr>
-        <p:spPr>
-          <a:xfrm>
-            <a:off x="8046720" y="3410712"/>
-            <a:ext cx="3383280" cy="365760"/>
-          </a:xfrm>
-          <a:prstGeom prst="rect">
-            <a:avLst/>
-          </a:prstGeom>
-          <a:noFill/>
-        </p:spPr>
-        <p:txBody>
-          <a:bodyPr wrap="square">
-            <a:spAutoFit/>
-          </a:bodyPr>
-          <a:lstStyle/>
-          <a:p>
-            <a:pPr algn="l"/>
-            <a:r>
-              <a:rPr sz="1300" b="0">
-                <a:solidFill>
-                  <a:srgbClr val="4A4A4A"/>
-                </a:solidFill>
-                <a:latin typeface="Calibri"/>
-              </a:rPr>
-              <a:t>Engenharia / Área Técnica</a:t>
-            </a:r>
-          </a:p>
-        </p:txBody>
-      </p:sp>
-      <p:sp>
-        <p:nvSpPr>
-          <p:cNvPr id="22" name="Rectangle 21"/>
-          <p:cNvSpPr/>
-          <p:nvPr/>
-        </p:nvSpPr>
-        <p:spPr>
-          <a:xfrm>
-            <a:off x="457200" y="3886200"/>
-            <a:ext cx="11247120" cy="640080"/>
-          </a:xfrm>
-          <a:prstGeom prst="rect">
-            <a:avLst/>
-          </a:prstGeom>
-          <a:solidFill>
-            <a:srgbClr val="E8EEF5"/>
-          </a:solidFill>
-          <a:ln>
-            <a:noFill/>
-          </a:ln>
-        </p:spPr>
-        <p:style>
-          <a:lnRef idx="1">
-            <a:schemeClr val="accent1"/>
-          </a:lnRef>
-          <a:fillRef idx="3">
-            <a:schemeClr val="accent1"/>
-          </a:fillRef>
-          <a:effectRef idx="2">
-            <a:schemeClr val="accent1"/>
-          </a:effectRef>
-          <a:fontRef idx="minor">
-            <a:schemeClr val="lt1"/>
-          </a:fontRef>
-        </p:style>
-        <p:txBody>
-          <a:bodyPr rtlCol="0" anchor="ctr"/>
-          <a:lstStyle/>
-          <a:p>
-            <a:pPr algn="ctr"/>
-          </a:p>
-        </p:txBody>
-      </p:sp>
-      <p:sp>
-        <p:nvSpPr>
-          <p:cNvPr id="23" name="TextBox 22"/>
-          <p:cNvSpPr txBox="1"/>
-          <p:nvPr/>
-        </p:nvSpPr>
-        <p:spPr>
-          <a:xfrm>
-            <a:off x="640080" y="4050792"/>
-            <a:ext cx="1188720" cy="365760"/>
-          </a:xfrm>
-          <a:prstGeom prst="rect">
-            <a:avLst/>
-          </a:prstGeom>
-          <a:noFill/>
-        </p:spPr>
-        <p:txBody>
-          <a:bodyPr wrap="square">
-            <a:spAutoFit/>
-          </a:bodyPr>
-          <a:lstStyle/>
-          <a:p>
-            <a:pPr algn="l"/>
-            <a:r>
-              <a:rPr sz="1400" b="1">
-                <a:solidFill>
-                  <a:srgbClr val="1B6B93"/>
-                </a:solidFill>
-                <a:latin typeface="Calibri"/>
-              </a:rPr>
-              <a:t>PA-04</a:t>
-            </a:r>
-          </a:p>
-        </p:txBody>
-      </p:sp>
-      <p:sp>
-        <p:nvSpPr>
-          <p:cNvPr id="24" name="TextBox 23"/>
-          <p:cNvSpPr txBox="1"/>
-          <p:nvPr/>
-        </p:nvSpPr>
-        <p:spPr>
-          <a:xfrm>
-            <a:off x="2011680" y="4050792"/>
-            <a:ext cx="5943600" cy="365760"/>
-          </a:xfrm>
-          <a:prstGeom prst="rect">
-            <a:avLst/>
-          </a:prstGeom>
-          <a:noFill/>
-        </p:spPr>
-        <p:txBody>
-          <a:bodyPr wrap="square">
-            <a:spAutoFit/>
-          </a:bodyPr>
-          <a:lstStyle/>
-          <a:p>
-            <a:pPr algn="l"/>
-            <a:r>
-              <a:rPr sz="1400" b="0">
-                <a:solidFill>
-                  <a:srgbClr val="1F1F1F"/>
-                </a:solidFill>
-                <a:latin typeface="Calibri"/>
-              </a:rPr>
-              <a:t>Adequação de RASPs/PCs com baixa performance</a:t>
-            </a:r>
-          </a:p>
-        </p:txBody>
-      </p:sp>
-      <p:sp>
-        <p:nvSpPr>
-          <p:cNvPr id="25" name="TextBox 24"/>
-          <p:cNvSpPr txBox="1"/>
-          <p:nvPr/>
-        </p:nvSpPr>
-        <p:spPr>
-          <a:xfrm>
-            <a:off x="8046720" y="4050792"/>
-            <a:ext cx="3383280" cy="365760"/>
-          </a:xfrm>
-          <a:prstGeom prst="rect">
-            <a:avLst/>
-          </a:prstGeom>
-          <a:noFill/>
-        </p:spPr>
-        <p:txBody>
-          <a:bodyPr wrap="square">
-            <a:spAutoFit/>
-          </a:bodyPr>
-          <a:lstStyle/>
-          <a:p>
-            <a:pPr algn="l"/>
-            <a:r>
-              <a:rPr sz="1300" b="0">
-                <a:solidFill>
-                  <a:srgbClr val="4A4A4A"/>
-                </a:solidFill>
-                <a:latin typeface="Calibri"/>
-              </a:rPr>
-              <a:t>Área Técnica / Engenharia</a:t>
-            </a:r>
-          </a:p>
-        </p:txBody>
-      </p:sp>
-      <p:sp>
-        <p:nvSpPr>
-          <p:cNvPr id="26" name="Rectangle 25"/>
-          <p:cNvSpPr/>
-          <p:nvPr/>
-        </p:nvSpPr>
-        <p:spPr>
-          <a:xfrm>
-            <a:off x="457200" y="4526279"/>
-            <a:ext cx="11247120" cy="640080"/>
-          </a:xfrm>
-          <a:prstGeom prst="rect">
-            <a:avLst/>
-          </a:prstGeom>
-          <a:solidFill>
-            <a:srgbClr val="FFFFFF"/>
-          </a:solidFill>
-          <a:ln>
-            <a:noFill/>
-          </a:ln>
-        </p:spPr>
-        <p:style>
-          <a:lnRef idx="1">
-            <a:schemeClr val="accent1"/>
-          </a:lnRef>
-          <a:fillRef idx="3">
-            <a:schemeClr val="accent1"/>
-          </a:fillRef>
-          <a:effectRef idx="2">
-            <a:schemeClr val="accent1"/>
-          </a:effectRef>
-          <a:fontRef idx="minor">
-            <a:schemeClr val="lt1"/>
-          </a:fontRef>
-        </p:style>
-        <p:txBody>
-          <a:bodyPr rtlCol="0" anchor="ctr"/>
-          <a:lstStyle/>
-          <a:p>
-            <a:pPr algn="ctr"/>
-          </a:p>
-        </p:txBody>
-      </p:sp>
-      <p:sp>
-        <p:nvSpPr>
-          <p:cNvPr id="27" name="TextBox 26"/>
-          <p:cNvSpPr txBox="1"/>
-          <p:nvPr/>
-        </p:nvSpPr>
-        <p:spPr>
-          <a:xfrm>
-            <a:off x="640080" y="4690871"/>
-            <a:ext cx="1188720" cy="365760"/>
-          </a:xfrm>
-          <a:prstGeom prst="rect">
-            <a:avLst/>
-          </a:prstGeom>
-          <a:noFill/>
-        </p:spPr>
-        <p:txBody>
-          <a:bodyPr wrap="square">
-            <a:spAutoFit/>
-          </a:bodyPr>
-          <a:lstStyle/>
-          <a:p>
-            <a:pPr algn="l"/>
-            <a:r>
-              <a:rPr sz="1400" b="1">
-                <a:solidFill>
-                  <a:srgbClr val="1B6B93"/>
-                </a:solidFill>
-                <a:latin typeface="Calibri"/>
-              </a:rPr>
-              <a:t>PA-05</a:t>
-            </a:r>
-          </a:p>
-        </p:txBody>
-      </p:sp>
-      <p:sp>
-        <p:nvSpPr>
-          <p:cNvPr id="28" name="TextBox 27"/>
-          <p:cNvSpPr txBox="1"/>
-          <p:nvPr/>
-        </p:nvSpPr>
-        <p:spPr>
-          <a:xfrm>
-            <a:off x="2011680" y="4690871"/>
-            <a:ext cx="5943600" cy="365760"/>
-          </a:xfrm>
-          <a:prstGeom prst="rect">
-            <a:avLst/>
-          </a:prstGeom>
-          <a:noFill/>
-        </p:spPr>
-        <p:txBody>
-          <a:bodyPr wrap="square">
-            <a:spAutoFit/>
-          </a:bodyPr>
-          <a:lstStyle/>
-          <a:p>
-            <a:pPr algn="l"/>
-            <a:r>
-              <a:rPr sz="1400" b="0">
-                <a:solidFill>
-                  <a:srgbClr val="1F1F1F"/>
-                </a:solidFill>
-                <a:latin typeface="Calibri"/>
-              </a:rPr>
-              <a:t>Padronizar status passou/não passou</a:t>
-            </a:r>
-          </a:p>
-        </p:txBody>
-      </p:sp>
-      <p:sp>
-        <p:nvSpPr>
-          <p:cNvPr id="29" name="TextBox 28"/>
-          <p:cNvSpPr txBox="1"/>
-          <p:nvPr/>
-        </p:nvSpPr>
-        <p:spPr>
-          <a:xfrm>
-            <a:off x="8046720" y="4690871"/>
-            <a:ext cx="3383280" cy="365760"/>
-          </a:xfrm>
-          <a:prstGeom prst="rect">
-            <a:avLst/>
-          </a:prstGeom>
-          <a:noFill/>
-        </p:spPr>
-        <p:txBody>
-          <a:bodyPr wrap="square">
-            <a:spAutoFit/>
-          </a:bodyPr>
-          <a:lstStyle/>
-          <a:p>
-            <a:pPr algn="l"/>
-            <a:r>
-              <a:rPr sz="1300" b="0">
-                <a:solidFill>
-                  <a:srgbClr val="4A4A4A"/>
-                </a:solidFill>
-                <a:latin typeface="Calibri"/>
-              </a:rPr>
-              <a:t>Engenharia / Área Técnica</a:t>
-            </a:r>
-          </a:p>
-        </p:txBody>
-      </p:sp>
-      <p:sp>
-        <p:nvSpPr>
-          <p:cNvPr id="30" name="Rectangle 29"/>
-          <p:cNvSpPr/>
-          <p:nvPr/>
-        </p:nvSpPr>
-        <p:spPr>
-          <a:xfrm>
-            <a:off x="457200" y="5166360"/>
-            <a:ext cx="11247120" cy="640080"/>
-          </a:xfrm>
-          <a:prstGeom prst="rect">
-            <a:avLst/>
-          </a:prstGeom>
-          <a:solidFill>
-            <a:srgbClr val="E8EEF5"/>
-          </a:solidFill>
-          <a:ln>
-            <a:noFill/>
-          </a:ln>
-        </p:spPr>
-        <p:style>
-          <a:lnRef idx="1">
-            <a:schemeClr val="accent1"/>
-          </a:lnRef>
-          <a:fillRef idx="3">
-            <a:schemeClr val="accent1"/>
-          </a:fillRef>
-          <a:effectRef idx="2">
-            <a:schemeClr val="accent1"/>
-          </a:effectRef>
-          <a:fontRef idx="minor">
-            <a:schemeClr val="lt1"/>
-          </a:fontRef>
-        </p:style>
-        <p:txBody>
-          <a:bodyPr rtlCol="0" anchor="ctr"/>
-          <a:lstStyle/>
-          <a:p>
-            <a:pPr algn="ctr"/>
-          </a:p>
-        </p:txBody>
-      </p:sp>
-      <p:sp>
-        <p:nvSpPr>
-          <p:cNvPr id="31" name="TextBox 30"/>
-          <p:cNvSpPr txBox="1"/>
-          <p:nvPr/>
-        </p:nvSpPr>
-        <p:spPr>
-          <a:xfrm>
-            <a:off x="640080" y="5330952"/>
-            <a:ext cx="1188720" cy="365760"/>
-          </a:xfrm>
-          <a:prstGeom prst="rect">
-            <a:avLst/>
-          </a:prstGeom>
-          <a:noFill/>
-        </p:spPr>
-        <p:txBody>
-          <a:bodyPr wrap="square">
-            <a:spAutoFit/>
-          </a:bodyPr>
-          <a:lstStyle/>
-          <a:p>
-            <a:pPr algn="l"/>
-            <a:r>
-              <a:rPr sz="1400" b="1">
-                <a:solidFill>
-                  <a:srgbClr val="1B6B93"/>
-                </a:solidFill>
-                <a:latin typeface="Calibri"/>
-              </a:rPr>
-              <a:t>PA-06</a:t>
-            </a:r>
-          </a:p>
-        </p:txBody>
-      </p:sp>
-      <p:sp>
-        <p:nvSpPr>
-          <p:cNvPr id="32" name="TextBox 31"/>
-          <p:cNvSpPr txBox="1"/>
-          <p:nvPr/>
-        </p:nvSpPr>
-        <p:spPr>
-          <a:xfrm>
-            <a:off x="2011680" y="5330952"/>
-            <a:ext cx="5943600" cy="365760"/>
-          </a:xfrm>
-          <a:prstGeom prst="rect">
-            <a:avLst/>
-          </a:prstGeom>
-          <a:noFill/>
-        </p:spPr>
-        <p:txBody>
-          <a:bodyPr wrap="square">
-            <a:spAutoFit/>
-          </a:bodyPr>
-          <a:lstStyle/>
-          <a:p>
-            <a:pPr algn="l"/>
-            <a:r>
-              <a:rPr sz="1400" b="0">
-                <a:solidFill>
-                  <a:srgbClr val="1F1F1F"/>
-                </a:solidFill>
-                <a:latin typeface="Calibri"/>
-              </a:rPr>
-              <a:t>Treinamento TI (IP RAP + Filebeat + checklist)</a:t>
-            </a:r>
-          </a:p>
-        </p:txBody>
-      </p:sp>
-      <p:sp>
-        <p:nvSpPr>
-          <p:cNvPr id="33" name="TextBox 32"/>
-          <p:cNvSpPr txBox="1"/>
-          <p:nvPr/>
-        </p:nvSpPr>
-        <p:spPr>
-          <a:xfrm>
-            <a:off x="8046720" y="5330952"/>
-            <a:ext cx="3383280" cy="365760"/>
-          </a:xfrm>
-          <a:prstGeom prst="rect">
-            <a:avLst/>
-          </a:prstGeom>
-          <a:noFill/>
-        </p:spPr>
-        <p:txBody>
-          <a:bodyPr wrap="square">
-            <a:spAutoFit/>
-          </a:bodyPr>
-          <a:lstStyle/>
-          <a:p>
-            <a:pPr algn="l"/>
-            <a:r>
-              <a:rPr sz="1300" b="0">
-                <a:solidFill>
-                  <a:srgbClr val="4A4A4A"/>
-                </a:solidFill>
-                <a:latin typeface="Calibri"/>
-              </a:rPr>
-              <a:t>TI</a:t>
-            </a:r>
-          </a:p>
-        </p:txBody>
-      </p:sp>
-      <p:sp>
-        <p:nvSpPr>
-          <p:cNvPr id="34" name="TextBox 33"/>
-          <p:cNvSpPr txBox="1"/>
-          <p:nvPr/>
-        </p:nvSpPr>
-        <p:spPr>
-          <a:xfrm>
-            <a:off x="457200" y="6446520"/>
-            <a:ext cx="9144000" cy="274320"/>
-          </a:xfrm>
-          <a:prstGeom prst="rect">
-            <a:avLst/>
-          </a:prstGeom>
-          <a:noFill/>
-        </p:spPr>
-        <p:txBody>
-          <a:bodyPr wrap="square">
-            <a:spAutoFit/>
-          </a:bodyPr>
-          <a:lstStyle/>
-          <a:p>
-            <a:pPr algn="l"/>
-            <a:r>
-              <a:rPr sz="1100" b="0">
-                <a:solidFill>
-                  <a:srgbClr val="8A8A8A"/>
-                </a:solidFill>
-                <a:latin typeface="Calibri"/>
-              </a:rPr>
-              <a:t>TI  ·  Área Técnica  ·  Engenharia</a:t>
-            </a:r>
-          </a:p>
-        </p:txBody>
-      </p:sp>
-      <p:sp>
-        <p:nvSpPr>
-          <p:cNvPr id="35" name="TextBox 34"/>
-          <p:cNvSpPr txBox="1"/>
-          <p:nvPr/>
-        </p:nvSpPr>
-        <p:spPr>
-          <a:xfrm>
-            <a:off x="10515600" y="6446520"/>
-            <a:ext cx="1280160" cy="274320"/>
-          </a:xfrm>
-          <a:prstGeom prst="rect">
-            <a:avLst/>
-          </a:prstGeom>
-          <a:noFill/>
-        </p:spPr>
-        <p:txBody>
-          <a:bodyPr wrap="square">
-            <a:spAutoFit/>
-          </a:bodyPr>
-          <a:lstStyle/>
-          <a:p>
-            <a:pPr algn="r"/>
-            <a:r>
-              <a:rPr sz="1100" b="0">
-                <a:solidFill>
-                  <a:srgbClr val="8A8A8A"/>
-                </a:solidFill>
-                <a:latin typeface="Calibri"/>
-              </a:rPr>
-              <a:t>7/8</a:t>
-            </a:r>
-          </a:p>
-        </p:txBody>
-      </p:sp>
-    </p:spTree>
-  </p:cSld>
-  <p:clrMapOvr>
-    <a:masterClrMapping/>
-  </p:clrMapOvr>
-</p:sld>
-</file>
-
-<file path=ppt/slides/slide8.xml><?xml version="1.0" encoding="utf-8"?>
 <p:sld xmlns:a="http://schemas.openxmlformats.org/drawingml/2006/main" xmlns:p="http://schemas.openxmlformats.org/presentationml/2006/main" xmlns:r="http://schemas.openxmlformats.org/officeDocument/2006/relationships">
   <p:cSld>
     <p:spTree>

</xml_diff>